<commit_message>
Phase 3: verified OWL Manchester Syntax excerpts with plain-English glosses
Slides 3, 7, 9 and 10 now show real OWL 2 Manchester Syntax. Every excerpt is
parsed with the OWL API and checked for OWL 2 DL (presentation/excerpts/).
build.sh rebuilds the deck from the original: restyle, then excerpts.

Co-Authored-By: Claude Opus 5.5 <noreply@anthropic.com>
Claude-Session: https://claude.ai/code/session_01KcycczqUBG98FnzsgJYAW8
</commit_message>
<xml_diff>
--- a/presentation/RIGOR_ISWC2026.pptx
+++ b/presentation/RIGOR_ISWC2026.pptx
@@ -7485,7 +7485,7 @@
           </a:p>
           <a:p>
             <a:r>
-              <a:t>The generator receives the direct mapping and retrieved context. The panel now uses the same format in every row: ontology term, generated statement, and the evidence informing it. The schema grounds the Admission-to-PatientData relation; documentation explains BM_DEP and the ECOG codes. For ECOG, the LLM records the code meanings in an rdfs:comment. Notice the separate provenance statement: prov:wasDerivedFrom traces the ontology element to its source database column, not to the document retrieved during generation. If a suitable external concept is found, RIGOR can additionally align to that vocabulary. This is an illustrative fragment, not a logged model output.</a:t>
+              <a:t>The generator receives the direct mapping and retrieved context. Read the code top to bottom: each block is one ontology element, and the tag on the right shows the evidence that informed it. The schema grounds the Admission-to-PatientData relation; documentation explains BM_DEP and the ECOG codes. For ECOG, the LLM records the code meanings in an rdfs:comment. Notice the separate provenance statement: prov:wasDerivedFrom traces the ontology element to its source database column, not to the document retrieved during generation. If a suitable external concept is found, RIGOR can additionally align to that vocabulary. This is an illustrative fragment, not a logged model output.</a:t>
             </a:r>
           </a:p>
           <a:p/>
@@ -7496,7 +7496,7 @@
           </a:p>
           <a:p>
             <a:r>
-              <a:t>Each row is an ontology contribution; context-source labels are explanatory, while prov:wasDerivedFrom is formal database-schema provenance.</a:t>
+              <a:t>Each code block is an ontology contribution; context-source labels are explanatory, while prov:wasDerivedFrom is formal database-schema provenance.</a:t>
             </a:r>
           </a:p>
           <a:p/>
@@ -10688,8 +10688,8 @@
         </p:nvSpPr>
         <p:spPr>
           <a:xfrm>
-            <a:off x="1188720" y="3227832"/>
-            <a:ext cx="4270248" cy="274320"/>
+            <a:off x="1143000" y="3227832"/>
+            <a:ext cx="4434840" cy="274320"/>
           </a:xfrm>
           <a:prstGeom prst="rect">
             <a:avLst/>
@@ -10703,13 +10703,34 @@
           <a:lstStyle/>
           <a:p>
             <a:r>
-              <a:rPr sz="1600" b="1">
+              <a:rPr lang="en-US" sz="1200" b="0" i="0" dirty="0">
                 <a:solidFill>
                   <a:srgbClr val="B23A1E"/>
                 </a:solidFill>
-                <a:latin typeface="Calibri"/>
-              </a:rPr>
-              <a:t>“0 = dead, 5 = fully active”</a:t>
+                <a:latin typeface="Consolas"/>
+                <a:cs typeface="Consolas"/>
+              </a:rPr>
+              <a:t xml:space="preserve">rdfs:comment</a:t>
+            </a:r>
+            <a:r>
+              <a:rPr lang="en-US" sz="1200" b="0" i="0" dirty="0">
+                <a:solidFill>
+                  <a:srgbClr val="B23A1E"/>
+                </a:solidFill>
+                <a:latin typeface="Consolas"/>
+                <a:cs typeface="Consolas"/>
+              </a:rPr>
+              <a:t xml:space="preserve"> </a:t>
+            </a:r>
+            <a:r>
+              <a:rPr lang="en-US" sz="1200" b="0" i="0" dirty="0">
+                <a:solidFill>
+                  <a:srgbClr val="B23A1E"/>
+                </a:solidFill>
+                <a:latin typeface="Consolas"/>
+                <a:cs typeface="Consolas"/>
+              </a:rPr>
+              <a:t xml:space="preserve">"ECOG 0 = dead … 5 = fully active"@en</a:t>
             </a:r>
           </a:p>
         </p:txBody>
@@ -10883,13 +10904,74 @@
           <a:lstStyle/>
           <a:p>
             <a:r>
-              <a:rPr sz="1570" b="1">
+              <a:rPr lang="en-US" sz="1200" b="1" i="0" dirty="0">
                 <a:solidFill>
                   <a:srgbClr val="B23A1E"/>
                 </a:solidFill>
-                <a:latin typeface="Calibri"/>
-              </a:rPr>
-              <a:t>patient_id → DataProperty</a:t>
+                <a:latin typeface="Consolas"/>
+                <a:cs typeface="Consolas"/>
+              </a:rPr>
+              <a:t xml:space="preserve">DataProperty:</a:t>
+            </a:r>
+            <a:r>
+              <a:rPr lang="en-US" sz="1200" b="0" i="0" dirty="0">
+                <a:solidFill>
+                  <a:srgbClr val="B23A1E"/>
+                </a:solidFill>
+                <a:latin typeface="Consolas"/>
+                <a:cs typeface="Consolas"/>
+              </a:rPr>
+              <a:t xml:space="preserve"> </a:t>
+            </a:r>
+            <a:r>
+              <a:rPr lang="en-US" sz="1200" b="0" i="0" dirty="0">
+                <a:solidFill>
+                  <a:srgbClr val="B23A1E"/>
+                </a:solidFill>
+                <a:latin typeface="Consolas"/>
+                <a:cs typeface="Consolas"/>
+              </a:rPr>
+              <a:t xml:space="preserve">patient_id</a:t>
+            </a:r>
+            <a:r>
+              <a:rPr lang="en-US" sz="1200" b="0" i="0" dirty="0">
+                <a:solidFill>
+                  <a:srgbClr val="B23A1E"/>
+                </a:solidFill>
+                <a:latin typeface="Consolas"/>
+                <a:cs typeface="Consolas"/>
+              </a:rPr>
+              <a:t xml:space="preserve">  </a:t>
+            </a:r>
+            <a:r>
+              <a:rPr lang="en-US" sz="1200" b="1" i="0" dirty="0">
+                <a:solidFill>
+                  <a:srgbClr val="B23A1E"/>
+                </a:solidFill>
+                <a:latin typeface="Consolas"/>
+                <a:cs typeface="Consolas"/>
+              </a:rPr>
+              <a:t xml:space="preserve">Range:</a:t>
+            </a:r>
+            <a:r>
+              <a:rPr lang="en-US" sz="1200" b="0" i="0" dirty="0">
+                <a:solidFill>
+                  <a:srgbClr val="B23A1E"/>
+                </a:solidFill>
+                <a:latin typeface="Consolas"/>
+                <a:cs typeface="Consolas"/>
+              </a:rPr>
+              <a:t xml:space="preserve"> </a:t>
+            </a:r>
+            <a:r>
+              <a:rPr lang="en-US" sz="1200" b="0" i="0" dirty="0">
+                <a:solidFill>
+                  <a:srgbClr val="B23A1E"/>
+                </a:solidFill>
+                <a:latin typeface="Consolas"/>
+                <a:cs typeface="Consolas"/>
+              </a:rPr>
+              <a:t xml:space="preserve">xsd:integer</a:t>
             </a:r>
           </a:p>
         </p:txBody>
@@ -10997,13 +11079,124 @@
           <a:lstStyle/>
           <a:p>
             <a:r>
-              <a:rPr sz="1470" b="1">
+              <a:rPr lang="en-US" sz="1300" b="1" i="0" dirty="0">
+                <a:solidFill>
+                  <a:srgbClr val="0B6E4F"/>
+                </a:solidFill>
+                <a:latin typeface="Calibri"/>
+                <a:cs typeface="Calibri"/>
+              </a:rPr>
+              <a:t xml:space="preserve">CORRECTION   </a:t>
+            </a:r>
+            <a:r>
+              <a:rPr lang="en-US" sz="1200" b="0" i="0" dirty="0">
+                <a:solidFill>
+                  <a:srgbClr val="5B6770"/>
+                </a:solidFill>
+                <a:latin typeface="Consolas"/>
+                <a:cs typeface="Consolas"/>
+              </a:rPr>
+              <a:t xml:space="preserve">rdfs:comment</a:t>
+            </a:r>
+            <a:r>
+              <a:rPr lang="en-US" sz="1200" b="0" i="0" dirty="0">
                 <a:solidFill>
                   <a:srgbClr val="1F2328"/>
                 </a:solidFill>
+                <a:latin typeface="Consolas"/>
+                <a:cs typeface="Consolas"/>
+              </a:rPr>
+              <a:t xml:space="preserve"> </a:t>
+            </a:r>
+            <a:r>
+              <a:rPr lang="en-US" sz="1200" b="0" i="0" dirty="0">
+                <a:solidFill>
+                  <a:srgbClr val="A3401E"/>
+                </a:solidFill>
+                <a:latin typeface="Consolas"/>
+                <a:cs typeface="Consolas"/>
+              </a:rPr>
+              <a:t xml:space="preserve">"ECOG 0 = fully active … 5 = dead"@en</a:t>
+            </a:r>
+            <a:r>
+              <a:rPr lang="en-US" sz="1300" b="0" i="0" dirty="0">
+                <a:solidFill>
+                  <a:srgbClr val="5B6770"/>
+                </a:solidFill>
                 <a:latin typeface="Calibri"/>
-              </a:rPr>
-              <a:t>CORRECTION   ECOG 0 = fully active; 5 = dead     |     patient_id: ObjectProperty → PatientData</a:t>
+                <a:cs typeface="Calibri"/>
+              </a:rPr>
+              <a:t xml:space="preserve">    |    </a:t>
+            </a:r>
+            <a:r>
+              <a:rPr lang="en-US" sz="1200" b="1" i="0" dirty="0">
+                <a:solidFill>
+                  <a:srgbClr val="0B6E4F"/>
+                </a:solidFill>
+                <a:latin typeface="Consolas"/>
+                <a:cs typeface="Consolas"/>
+              </a:rPr>
+              <a:t xml:space="preserve">ObjectProperty:</a:t>
+            </a:r>
+            <a:r>
+              <a:rPr lang="en-US" sz="1200" b="0" i="0" dirty="0">
+                <a:solidFill>
+                  <a:srgbClr val="1F2328"/>
+                </a:solidFill>
+                <a:latin typeface="Consolas"/>
+                <a:cs typeface="Consolas"/>
+              </a:rPr>
+              <a:t xml:space="preserve"> </a:t>
+            </a:r>
+            <a:r>
+              <a:rPr lang="en-US" sz="1200" b="0" i="0" dirty="0">
+                <a:solidFill>
+                  <a:srgbClr val="1F2328"/>
+                </a:solidFill>
+                <a:latin typeface="Consolas"/>
+                <a:cs typeface="Consolas"/>
+              </a:rPr>
+              <a:t xml:space="preserve">patient_id</a:t>
+            </a:r>
+            <a:r>
+              <a:rPr lang="en-US" sz="1200" b="0" i="0" dirty="0">
+                <a:solidFill>
+                  <a:srgbClr val="1F2328"/>
+                </a:solidFill>
+                <a:latin typeface="Consolas"/>
+                <a:cs typeface="Consolas"/>
+              </a:rPr>
+              <a:t xml:space="preserve">  </a:t>
+            </a:r>
+            <a:r>
+              <a:rPr lang="en-US" sz="1200" b="1" i="0" dirty="0">
+                <a:solidFill>
+                  <a:srgbClr val="0B6E4F"/>
+                </a:solidFill>
+                <a:latin typeface="Consolas"/>
+                <a:cs typeface="Consolas"/>
+              </a:rPr>
+              <a:t xml:space="preserve">Range:</a:t>
+            </a:r>
+            <a:r>
+              <a:rPr lang="en-US" sz="1200" b="0" i="0" dirty="0">
+                <a:solidFill>
+                  <a:srgbClr val="1F2328"/>
+                </a:solidFill>
+                <a:latin typeface="Consolas"/>
+                <a:cs typeface="Consolas"/>
+              </a:rPr>
+              <a:t xml:space="preserve"> </a:t>
+            </a:r>
+            <a:r>
+              <a:rPr lang="en-US" sz="1200" b="0" i="0" dirty="0">
+                <a:solidFill>
+                  <a:srgbClr val="1F2328"/>
+                </a:solidFill>
+                <a:latin typeface="Consolas"/>
+                <a:cs typeface="Consolas"/>
+              </a:rPr>
+              <a:t xml:space="preserve">PatientData</a:t>
             </a:r>
           </a:p>
         </p:txBody>
@@ -43974,14 +44167,14 @@
       </p:sp>
       <p:sp>
         <p:nvSpPr>
-          <p:cNvPr id="95" name="Google Shape;95;p3"/>
+          <p:cNvPr id="102" name="Google Shape;102;p3"/>
           <p:cNvSpPr/>
           <p:nvPr/>
         </p:nvSpPr>
         <p:spPr>
           <a:xfrm>
-            <a:off x="5093208" y="3575304"/>
-            <a:ext cx="5989320" cy="448056"/>
+            <a:off x="804672" y="5522976"/>
+            <a:ext cx="10607040" cy="429768"/>
           </a:xfrm>
           <a:prstGeom prst="roundRect">
             <a:avLst>
@@ -43989,7 +44182,7 @@
             </a:avLst>
           </a:prstGeom>
           <a:solidFill>
-            <a:srgbClr val="E9EEEB"/>
+            <a:srgbClr val="F3F5F4"/>
           </a:solidFill>
           <a:ln>
             <a:noFill/>
@@ -44027,14 +44220,14 @@
       </p:sp>
       <p:sp>
         <p:nvSpPr>
-          <p:cNvPr id="96" name="Google Shape;96;p3"/>
+          <p:cNvPr id="103" name="Google Shape;103;p3"/>
           <p:cNvSpPr txBox="1"/>
           <p:nvPr/>
         </p:nvSpPr>
         <p:spPr>
           <a:xfrm>
-            <a:off x="5257800" y="3685032"/>
-            <a:ext cx="1097280" cy="237744"/>
+            <a:off x="996696" y="5596128"/>
+            <a:ext cx="10104120" cy="274320"/>
           </a:xfrm>
           <a:prstGeom prst="rect">
             <a:avLst/>
@@ -44063,281 +44256,28 @@
               <a:buNone/>
             </a:pPr>
             <a:r>
-              <a:rPr b="1" i="0" lang="en-US" sz="1400">
-                <a:solidFill>
-                  <a:srgbClr val="2F6B78"/>
-                </a:solidFill>
-                <a:latin typeface="Consolas"/>
-                <a:ea typeface="Consolas"/>
-                <a:cs typeface="Consolas"/>
-                <a:sym typeface="Consolas"/>
-              </a:rPr>
-              <a:t>BM_DEP</a:t>
-            </a:r>
-            <a:endParaRPr/>
-          </a:p>
-        </p:txBody>
-      </p:sp>
-      <p:sp>
-        <p:nvSpPr>
-          <p:cNvPr id="97" name="Google Shape;97;p3"/>
-          <p:cNvSpPr txBox="1"/>
-          <p:nvPr/>
-        </p:nvSpPr>
-        <p:spPr>
-          <a:xfrm>
-            <a:off x="6419088" y="3685032"/>
-            <a:ext cx="4553712" cy="274320"/>
-          </a:xfrm>
-          <a:prstGeom prst="rect">
-            <a:avLst/>
-          </a:prstGeom>
-          <a:noFill/>
-          <a:ln>
-            <a:noFill/>
-          </a:ln>
-        </p:spPr>
-        <p:txBody>
-          <a:bodyPr anchorCtr="0" anchor="ctr" bIns="0" lIns="0" spcFirstLastPara="1" rIns="0" wrap="square" tIns="0">
-            <a:spAutoFit/>
-          </a:bodyPr>
-          <a:lstStyle/>
-          <a:p>
-            <a:pPr indent="0" lvl="0" marL="0" marR="0" rtl="0" algn="l">
-              <a:lnSpc>
-                <a:spcPct val="105000"/>
-              </a:lnSpc>
-              <a:spcBef>
-                <a:spcPts val="0"/>
-              </a:spcBef>
-              <a:spcAft>
-                <a:spcPts val="0"/>
-              </a:spcAft>
-              <a:buNone/>
-            </a:pPr>
-            <a:r>
-              <a:rPr b="0" i="0" lang="en-US" sz="1550">
-                <a:solidFill>
-                  <a:srgbClr val="1F2328"/>
-                </a:solidFill>
-                <a:latin typeface="Consolas"/>
-                <a:ea typeface="Consolas"/>
-                <a:cs typeface="Consolas"/>
-                <a:sym typeface="Consolas"/>
-              </a:rPr>
-              <a:t>rdfs:label  "Bone Marrow Depression"</a:t>
-            </a:r>
-            <a:endParaRPr/>
-          </a:p>
-        </p:txBody>
-      </p:sp>
-      <p:sp>
-        <p:nvSpPr>
-          <p:cNvPr id="98" name="Google Shape;98;p3"/>
-          <p:cNvSpPr/>
-          <p:nvPr/>
-        </p:nvSpPr>
-        <p:spPr>
-          <a:xfrm>
-            <a:off x="5093208" y="4133087"/>
-            <a:ext cx="5989320" cy="448056"/>
-          </a:xfrm>
-          <a:prstGeom prst="roundRect">
-            <a:avLst>
-              <a:gd fmla="val 10000" name="adj"/>
-            </a:avLst>
-          </a:prstGeom>
-          <a:solidFill>
-            <a:srgbClr val="E9EEEB"/>
-          </a:solidFill>
-          <a:ln>
-            <a:noFill/>
-          </a:ln>
-        </p:spPr>
-        <p:txBody>
-          <a:bodyPr anchorCtr="0" anchor="ctr" bIns="45700" lIns="91425" spcFirstLastPara="1" rIns="91425" wrap="square" tIns="45700">
-            <a:noAutofit/>
-          </a:bodyPr>
-          <a:lstStyle/>
-          <a:p>
-            <a:pPr indent="0" lvl="0" marL="0" marR="0" rtl="0" algn="ctr">
-              <a:spcBef>
-                <a:spcPts val="0"/>
-              </a:spcBef>
-              <a:spcAft>
-                <a:spcPts val="0"/>
-              </a:spcAft>
-              <a:buNone/>
-            </a:pPr>
-            <a:r>
-              <a:t/>
-            </a:r>
-            <a:endParaRPr sz="1800">
-              <a:solidFill>
-                <a:schemeClr val="dk1"/>
-              </a:solidFill>
-              <a:latin typeface="Calibri"/>
-              <a:ea typeface="Calibri"/>
-              <a:cs typeface="Calibri"/>
-              <a:sym typeface="Calibri"/>
-            </a:endParaRPr>
-          </a:p>
-        </p:txBody>
-      </p:sp>
-      <p:sp>
-        <p:nvSpPr>
-          <p:cNvPr id="99" name="Google Shape;99;p3"/>
-          <p:cNvSpPr txBox="1"/>
-          <p:nvPr/>
-        </p:nvSpPr>
-        <p:spPr>
-          <a:xfrm>
-            <a:off x="5257800" y="4242816"/>
-            <a:ext cx="1527048" cy="228600"/>
-          </a:xfrm>
-          <a:prstGeom prst="rect">
-            <a:avLst/>
-          </a:prstGeom>
-          <a:noFill/>
-          <a:ln>
-            <a:noFill/>
-          </a:ln>
-        </p:spPr>
-        <p:txBody>
-          <a:bodyPr anchorCtr="0" anchor="ctr" bIns="0" lIns="0" spcFirstLastPara="1" rIns="0" wrap="square" tIns="0">
-            <a:spAutoFit/>
-          </a:bodyPr>
-          <a:lstStyle/>
-          <a:p>
-            <a:pPr indent="0" lvl="0" marL="0" marR="0" rtl="0" algn="l">
-              <a:lnSpc>
-                <a:spcPct val="105000"/>
-              </a:lnSpc>
-              <a:spcBef>
-                <a:spcPts val="0"/>
-              </a:spcBef>
-              <a:spcAft>
-                <a:spcPts val="0"/>
-              </a:spcAft>
-              <a:buNone/>
-            </a:pPr>
-            <a:r>
-              <a:rPr b="1" i="0" lang="en-US" sz="1400">
-                <a:solidFill>
-                  <a:srgbClr val="2F6B78"/>
-                </a:solidFill>
-                <a:latin typeface="Consolas"/>
-                <a:ea typeface="Consolas"/>
-                <a:cs typeface="Consolas"/>
-                <a:sym typeface="Consolas"/>
-              </a:rPr>
-              <a:t>ecog_stage</a:t>
-            </a:r>
-            <a:endParaRPr/>
-          </a:p>
-        </p:txBody>
-      </p:sp>
-      <p:sp>
-        <p:nvSpPr>
-          <p:cNvPr id="100" name="Google Shape;100;p3"/>
-          <p:cNvSpPr txBox="1"/>
-          <p:nvPr/>
-        </p:nvSpPr>
-        <p:spPr>
-          <a:xfrm>
-            <a:off x="6830568" y="4206240"/>
-            <a:ext cx="4096512" cy="310896"/>
-          </a:xfrm>
-          <a:prstGeom prst="rect">
-            <a:avLst/>
-          </a:prstGeom>
-          <a:noFill/>
-          <a:ln>
-            <a:noFill/>
-          </a:ln>
-        </p:spPr>
-        <p:txBody>
-          <a:bodyPr anchorCtr="0" anchor="ctr" bIns="0" lIns="0" spcFirstLastPara="1" rIns="0" wrap="square" tIns="0">
-            <a:spAutoFit/>
-          </a:bodyPr>
-          <a:lstStyle/>
-          <a:p>
-            <a:pPr indent="0" lvl="0" marL="0" marR="0" rtl="0" algn="l">
-              <a:lnSpc>
-                <a:spcPct val="105000"/>
-              </a:lnSpc>
-              <a:spcBef>
-                <a:spcPts val="0"/>
-              </a:spcBef>
-              <a:spcAft>
-                <a:spcPts val="0"/>
-              </a:spcAft>
-              <a:buNone/>
-            </a:pPr>
-            <a:r>
-              <a:rPr b="0" lang="en-US" sz="1550">
-                <a:solidFill>
-                  <a:srgbClr val="1F2328"/>
+              <a:rPr b="1" lang="en-US" sz="1550">
+                <a:solidFill>
+                  <a:srgbClr val="0B6E4F"/>
                 </a:solidFill>
                 <a:latin typeface="Calibri"/>
                 <a:ea typeface="Calibri"/>
                 <a:cs typeface="Calibri"/>
                 <a:sym typeface="Calibri"/>
               </a:rPr>
-              <a:t>ECOG scale: 0 (fully active) → 5 (dead)</a:t>
-            </a:r>
-            <a:endParaRPr/>
-          </a:p>
-        </p:txBody>
-      </p:sp>
-      <p:sp>
-        <p:nvSpPr>
-          <p:cNvPr id="101" name="Google Shape;101;p3"/>
-          <p:cNvSpPr txBox="1"/>
-          <p:nvPr/>
-        </p:nvSpPr>
-        <p:spPr>
-          <a:xfrm>
-            <a:off x="5239512" y="4800600"/>
-            <a:ext cx="5669280" cy="274320"/>
-          </a:xfrm>
-          <a:prstGeom prst="rect">
-            <a:avLst/>
-          </a:prstGeom>
-          <a:noFill/>
-          <a:ln>
-            <a:noFill/>
-          </a:ln>
-        </p:spPr>
-        <p:txBody>
-          <a:bodyPr anchorCtr="0" anchor="ctr" bIns="0" lIns="0" spcFirstLastPara="1" rIns="0" wrap="square" tIns="0">
-            <a:spAutoFit/>
-          </a:bodyPr>
-          <a:lstStyle/>
-          <a:p>
-            <a:pPr indent="0" lvl="0" marL="0" marR="0" rtl="0" algn="l">
-              <a:lnSpc>
-                <a:spcPct val="105000"/>
-              </a:lnSpc>
-              <a:spcBef>
-                <a:spcPts val="0"/>
-              </a:spcBef>
-              <a:spcAft>
-                <a:spcPts val="0"/>
-              </a:spcAft>
-              <a:buNone/>
-            </a:pPr>
-            <a:r>
-              <a:rPr b="0" i="0" lang="en-US" sz="1550">
-                <a:solidFill>
-                  <a:srgbClr val="3A434C"/>
+              <a:t>WHAT THIS ENABLES   </a:t>
+            </a:r>
+            <a:r>
+              <a:rPr b="0" lang="en-US" sz="1550">
+                <a:solidFill>
+                  <a:srgbClr val="1F2328"/>
                 </a:solidFill>
                 <a:latin typeface="Calibri"/>
                 <a:ea typeface="Calibri"/>
                 <a:cs typeface="Calibri"/>
                 <a:sym typeface="Calibri"/>
               </a:rPr>
-              <a:t>+ source provenance for classes and properties</a:t>
+              <a:t>Concept-based access  ·  KG population  ·  Cross-system interoperability</a:t>
             </a:r>
             <a:endParaRPr/>
           </a:p>
@@ -44345,119 +44285,391 @@
       </p:sp>
       <p:sp>
         <p:nvSpPr>
-          <p:cNvPr id="102" name="Google Shape;102;p3"/>
-          <p:cNvSpPr/>
-          <p:nvPr/>
-        </p:nvSpPr>
-        <p:spPr>
-          <a:xfrm>
-            <a:off x="804672" y="5522976"/>
-            <a:ext cx="10607040" cy="429768"/>
+          <p:cNvPr id="104" name="Code 104" descr="OWL Manchester Syntax excerpt"/>
+          <p:cNvSpPr txBox="1"/>
+          <p:nvPr/>
+        </p:nvSpPr>
+        <p:spPr>
+          <a:xfrm>
+            <a:off x="5093208" y="3529584"/>
+            <a:ext cx="5989320" cy="1498091"/>
           </a:xfrm>
           <a:prstGeom prst="roundRect">
             <a:avLst>
-              <a:gd fmla="val 10000" name="adj"/>
+              <a:gd name="adj" fmla="val 5000"/>
             </a:avLst>
           </a:prstGeom>
           <a:solidFill>
-            <a:srgbClr val="F3F5F4"/>
+            <a:srgbClr val="F6F8FA"/>
           </a:solidFill>
-          <a:ln>
-            <a:noFill/>
-          </a:ln>
-        </p:spPr>
-        <p:txBody>
-          <a:bodyPr anchorCtr="0" anchor="ctr" bIns="45700" lIns="91425" spcFirstLastPara="1" rIns="91425" wrap="square" tIns="45700">
+          <a:ln w="9525">
+            <a:solidFill>
+              <a:srgbClr val="D0D7DE"/>
+            </a:solidFill>
+          </a:ln>
+        </p:spPr>
+        <p:txBody>
+          <a:bodyPr wrap="none" lIns="109728" tIns="73152" rIns="109728" bIns="54864" anchor="t">
             <a:noAutofit/>
           </a:bodyPr>
           <a:lstStyle/>
           <a:p>
-            <a:pPr indent="0" lvl="0" marL="0" marR="0" rtl="0" algn="ctr">
-              <a:spcBef>
-                <a:spcPts val="0"/>
-              </a:spcBef>
-              <a:spcAft>
-                <a:spcPts val="0"/>
-              </a:spcAft>
-              <a:buNone/>
-            </a:pPr>
-            <a:r>
-              <a:t/>
-            </a:r>
-            <a:endParaRPr sz="1800">
-              <a:solidFill>
-                <a:schemeClr val="dk1"/>
-              </a:solidFill>
-              <a:latin typeface="Calibri"/>
-              <a:ea typeface="Calibri"/>
-              <a:cs typeface="Calibri"/>
-              <a:sym typeface="Calibri"/>
-            </a:endParaRPr>
-          </a:p>
-        </p:txBody>
-      </p:sp>
-      <p:sp>
-        <p:nvSpPr>
-          <p:cNvPr id="103" name="Google Shape;103;p3"/>
-          <p:cNvSpPr txBox="1"/>
-          <p:nvPr/>
-        </p:nvSpPr>
-        <p:spPr>
-          <a:xfrm>
-            <a:off x="996696" y="5596128"/>
-            <a:ext cx="10104120" cy="274320"/>
-          </a:xfrm>
-          <a:prstGeom prst="rect">
-            <a:avLst/>
-          </a:prstGeom>
-          <a:noFill/>
-          <a:ln>
-            <a:noFill/>
-          </a:ln>
-        </p:spPr>
-        <p:txBody>
-          <a:bodyPr anchorCtr="0" anchor="ctr" bIns="0" lIns="0" spcFirstLastPara="1" rIns="0" wrap="square" tIns="0">
-            <a:spAutoFit/>
-          </a:bodyPr>
-          <a:lstStyle/>
-          <a:p>
-            <a:pPr indent="0" lvl="0" marL="0" marR="0" rtl="0" algn="l">
+            <a:pPr>
               <a:lnSpc>
-                <a:spcPct val="105000"/>
+                <a:spcPts val="1500"/>
               </a:lnSpc>
               <a:spcBef>
                 <a:spcPts val="0"/>
               </a:spcBef>
-              <a:spcAft>
-                <a:spcPts val="0"/>
-              </a:spcAft>
-              <a:buNone/>
-            </a:pPr>
-            <a:r>
-              <a:rPr b="1" lang="en-US" sz="1550">
+              <a:tabLst>
+                <a:tab pos="3977639" algn="l"/>
+              </a:tabLst>
+            </a:pPr>
+            <a:r>
+              <a:rPr lang="en-US" sz="1300" b="1" i="0" dirty="0">
                 <a:solidFill>
                   <a:srgbClr val="0B6E4F"/>
                 </a:solidFill>
+                <a:latin typeface="Consolas"/>
+                <a:cs typeface="Consolas"/>
+              </a:rPr>
+              <a:t xml:space="preserve">DataProperty:</a:t>
+            </a:r>
+            <a:r>
+              <a:rPr lang="en-US" sz="1300" b="0" i="0" dirty="0">
+                <a:solidFill>
+                  <a:srgbClr val="1F2328"/>
+                </a:solidFill>
+                <a:latin typeface="Consolas"/>
+                <a:cs typeface="Consolas"/>
+              </a:rPr>
+              <a:t xml:space="preserve"> </a:t>
+            </a:r>
+            <a:r>
+              <a:rPr lang="en-US" sz="1300" b="0" i="0" dirty="0">
+                <a:solidFill>
+                  <a:srgbClr val="1F2328"/>
+                </a:solidFill>
+                <a:latin typeface="Consolas"/>
+                <a:cs typeface="Consolas"/>
+              </a:rPr>
+              <a:t xml:space="preserve">BM_DEP</a:t>
+            </a:r>
+            <a:endParaRPr lang="en-US" sz="1300"/>
+          </a:p>
+          <a:p>
+            <a:pPr>
+              <a:lnSpc>
+                <a:spcPts val="1500"/>
+              </a:lnSpc>
+              <a:spcBef>
+                <a:spcPts val="0"/>
+              </a:spcBef>
+              <a:tabLst>
+                <a:tab pos="3977639" algn="l"/>
+              </a:tabLst>
+            </a:pPr>
+            <a:r>
+              <a:rPr lang="en-US" sz="1300" b="0" i="0" dirty="0">
+                <a:solidFill>
+                  <a:srgbClr val="1F2328"/>
+                </a:solidFill>
+                <a:latin typeface="Consolas"/>
+                <a:cs typeface="Consolas"/>
+              </a:rPr>
+              <a:t xml:space="preserve">  </a:t>
+            </a:r>
+            <a:r>
+              <a:rPr lang="en-US" sz="1300" b="1" i="0" dirty="0">
+                <a:solidFill>
+                  <a:srgbClr val="0B6E4F"/>
+                </a:solidFill>
+                <a:latin typeface="Consolas"/>
+                <a:cs typeface="Consolas"/>
+              </a:rPr>
+              <a:t xml:space="preserve">Annotations:</a:t>
+            </a:r>
+            <a:r>
+              <a:rPr lang="en-US" sz="1300" b="0" i="0" dirty="0">
+                <a:solidFill>
+                  <a:srgbClr val="1F2328"/>
+                </a:solidFill>
+                <a:latin typeface="Consolas"/>
+                <a:cs typeface="Consolas"/>
+              </a:rPr>
+              <a:t xml:space="preserve"> </a:t>
+            </a:r>
+            <a:r>
+              <a:rPr lang="en-US" sz="1300" b="0" i="0" dirty="0">
+                <a:solidFill>
+                  <a:srgbClr val="5B6770"/>
+                </a:solidFill>
+                <a:latin typeface="Consolas"/>
+                <a:cs typeface="Consolas"/>
+              </a:rPr>
+              <a:t xml:space="preserve">rdfs:label</a:t>
+            </a:r>
+            <a:endParaRPr lang="en-US" sz="1300"/>
+          </a:p>
+          <a:p>
+            <a:pPr>
+              <a:lnSpc>
+                <a:spcPts val="1500"/>
+              </a:lnSpc>
+              <a:spcBef>
+                <a:spcPts val="0"/>
+              </a:spcBef>
+              <a:tabLst>
+                <a:tab pos="3977639" algn="l"/>
+              </a:tabLst>
+            </a:pPr>
+            <a:r>
+              <a:rPr lang="en-US" sz="1300" b="0" i="0" dirty="0">
+                <a:solidFill>
+                  <a:srgbClr val="1F2328"/>
+                </a:solidFill>
+                <a:latin typeface="Consolas"/>
+                <a:cs typeface="Consolas"/>
+              </a:rPr>
+              <a:t xml:space="preserve">    </a:t>
+            </a:r>
+            <a:r>
+              <a:rPr lang="en-US" sz="1300" b="0" i="0" dirty="0">
+                <a:solidFill>
+                  <a:srgbClr val="A3401E"/>
+                </a:solidFill>
+                <a:latin typeface="Consolas"/>
+                <a:cs typeface="Consolas"/>
+              </a:rPr>
+              <a:t xml:space="preserve">"Bone Marrow Depression"@en</a:t>
+            </a:r>
+            <a:r>
+              <a:rPr lang="en-US" sz="1200" b="0" i="1" dirty="0">
+                <a:solidFill>
+                  <a:srgbClr val="5B6770"/>
+                </a:solidFill>
                 <a:latin typeface="Calibri"/>
-                <a:ea typeface="Calibri"/>
                 <a:cs typeface="Calibri"/>
-                <a:sym typeface="Calibri"/>
-              </a:rPr>
-              <a:t>WHAT THIS ENABLES   </a:t>
-            </a:r>
-            <a:r>
-              <a:rPr b="0" lang="en-US" sz="1550">
+              </a:rPr>
+              <a:t xml:space="preserve">	← human-readable name</a:t>
+            </a:r>
+            <a:endParaRPr lang="en-US" sz="1300"/>
+          </a:p>
+          <a:p>
+            <a:pPr>
+              <a:lnSpc>
+                <a:spcPts val="1500"/>
+              </a:lnSpc>
+              <a:spcBef>
+                <a:spcPts val="0"/>
+              </a:spcBef>
+              <a:tabLst>
+                <a:tab pos="3977639" algn="l"/>
+              </a:tabLst>
+            </a:pPr>
+            <a:r>
+              <a:rPr lang="en-US" sz="1300" b="1" i="0" dirty="0">
+                <a:solidFill>
+                  <a:srgbClr val="0B6E4F"/>
+                </a:solidFill>
+                <a:latin typeface="Consolas"/>
+                <a:cs typeface="Consolas"/>
+              </a:rPr>
+              <a:t xml:space="preserve">DataProperty:</a:t>
+            </a:r>
+            <a:r>
+              <a:rPr lang="en-US" sz="1300" b="0" i="0" dirty="0">
                 <a:solidFill>
                   <a:srgbClr val="1F2328"/>
                 </a:solidFill>
+                <a:latin typeface="Consolas"/>
+                <a:cs typeface="Consolas"/>
+              </a:rPr>
+              <a:t xml:space="preserve"> </a:t>
+            </a:r>
+            <a:r>
+              <a:rPr lang="en-US" sz="1300" b="0" i="0" dirty="0">
+                <a:solidFill>
+                  <a:srgbClr val="1F2328"/>
+                </a:solidFill>
+                <a:latin typeface="Consolas"/>
+                <a:cs typeface="Consolas"/>
+              </a:rPr>
+              <a:t xml:space="preserve">ecog_stage</a:t>
+            </a:r>
+            <a:endParaRPr lang="en-US" sz="1300"/>
+          </a:p>
+          <a:p>
+            <a:pPr>
+              <a:lnSpc>
+                <a:spcPts val="1500"/>
+              </a:lnSpc>
+              <a:spcBef>
+                <a:spcPts val="0"/>
+              </a:spcBef>
+              <a:tabLst>
+                <a:tab pos="3977639" algn="l"/>
+              </a:tabLst>
+            </a:pPr>
+            <a:r>
+              <a:rPr lang="en-US" sz="1300" b="0" i="0" dirty="0">
+                <a:solidFill>
+                  <a:srgbClr val="1F2328"/>
+                </a:solidFill>
+                <a:latin typeface="Consolas"/>
+                <a:cs typeface="Consolas"/>
+              </a:rPr>
+              <a:t xml:space="preserve">  </a:t>
+            </a:r>
+            <a:r>
+              <a:rPr lang="en-US" sz="1300" b="1" i="0" dirty="0">
+                <a:solidFill>
+                  <a:srgbClr val="0B6E4F"/>
+                </a:solidFill>
+                <a:latin typeface="Consolas"/>
+                <a:cs typeface="Consolas"/>
+              </a:rPr>
+              <a:t xml:space="preserve">Annotations:</a:t>
+            </a:r>
+            <a:r>
+              <a:rPr lang="en-US" sz="1300" b="0" i="0" dirty="0">
+                <a:solidFill>
+                  <a:srgbClr val="1F2328"/>
+                </a:solidFill>
+                <a:latin typeface="Consolas"/>
+                <a:cs typeface="Consolas"/>
+              </a:rPr>
+              <a:t xml:space="preserve"> </a:t>
+            </a:r>
+            <a:r>
+              <a:rPr lang="en-US" sz="1300" b="0" i="0" dirty="0">
+                <a:solidFill>
+                  <a:srgbClr val="5B6770"/>
+                </a:solidFill>
+                <a:latin typeface="Consolas"/>
+                <a:cs typeface="Consolas"/>
+              </a:rPr>
+              <a:t xml:space="preserve">rdfs:comment</a:t>
+            </a:r>
+            <a:endParaRPr lang="en-US" sz="1300"/>
+          </a:p>
+          <a:p>
+            <a:pPr>
+              <a:lnSpc>
+                <a:spcPts val="1500"/>
+              </a:lnSpc>
+              <a:spcBef>
+                <a:spcPts val="0"/>
+              </a:spcBef>
+              <a:tabLst>
+                <a:tab pos="3977639" algn="l"/>
+              </a:tabLst>
+            </a:pPr>
+            <a:r>
+              <a:rPr lang="en-US" sz="1300" b="0" i="0" dirty="0">
+                <a:solidFill>
+                  <a:srgbClr val="1F2328"/>
+                </a:solidFill>
+                <a:latin typeface="Consolas"/>
+                <a:cs typeface="Consolas"/>
+              </a:rPr>
+              <a:t xml:space="preserve">    </a:t>
+            </a:r>
+            <a:r>
+              <a:rPr lang="en-US" sz="1300" b="0" i="0" dirty="0">
+                <a:solidFill>
+                  <a:srgbClr val="A3401E"/>
+                </a:solidFill>
+                <a:latin typeface="Consolas"/>
+                <a:cs typeface="Consolas"/>
+              </a:rPr>
+              <a:t xml:space="preserve">"ECOG 0 = fully active … 5 = dead"@en</a:t>
+            </a:r>
+            <a:r>
+              <a:rPr lang="en-US" sz="1300" b="0" i="0" dirty="0">
+                <a:solidFill>
+                  <a:srgbClr val="1F2328"/>
+                </a:solidFill>
+                <a:latin typeface="Consolas"/>
+                <a:cs typeface="Consolas"/>
+              </a:rPr>
+              <a:t xml:space="preserve">,</a:t>
+            </a:r>
+            <a:r>
+              <a:rPr lang="en-US" sz="1200" b="0" i="1" dirty="0">
+                <a:solidFill>
+                  <a:srgbClr val="5B6770"/>
+                </a:solidFill>
                 <a:latin typeface="Calibri"/>
-                <a:ea typeface="Calibri"/>
                 <a:cs typeface="Calibri"/>
-                <a:sym typeface="Calibri"/>
-              </a:rPr>
-              <a:t>Concept-based access  ·  KG population  ·  Cross-system interoperability</a:t>
-            </a:r>
-            <a:endParaRPr/>
+              </a:rPr>
+              <a:t xml:space="preserve">	← what the codes mean</a:t>
+            </a:r>
+            <a:endParaRPr lang="en-US" sz="1300"/>
+          </a:p>
+          <a:p>
+            <a:pPr>
+              <a:lnSpc>
+                <a:spcPts val="1500"/>
+              </a:lnSpc>
+              <a:spcBef>
+                <a:spcPts val="0"/>
+              </a:spcBef>
+              <a:tabLst>
+                <a:tab pos="3977639" algn="l"/>
+              </a:tabLst>
+            </a:pPr>
+            <a:r>
+              <a:rPr lang="en-US" sz="1300" b="0" i="0" dirty="0">
+                <a:solidFill>
+                  <a:srgbClr val="1F2328"/>
+                </a:solidFill>
+                <a:latin typeface="Consolas"/>
+                <a:cs typeface="Consolas"/>
+              </a:rPr>
+              <a:t xml:space="preserve">    </a:t>
+            </a:r>
+            <a:r>
+              <a:rPr lang="en-US" sz="1300" b="0" i="0" dirty="0">
+                <a:solidFill>
+                  <a:srgbClr val="5B6770"/>
+                </a:solidFill>
+                <a:latin typeface="Consolas"/>
+                <a:cs typeface="Consolas"/>
+              </a:rPr>
+              <a:t xml:space="preserve">prov:wasDerivedFrom</a:t>
+            </a:r>
+            <a:r>
+              <a:rPr lang="en-US" sz="1300" b="0" i="0" dirty="0">
+                <a:solidFill>
+                  <a:srgbClr val="1F2328"/>
+                </a:solidFill>
+                <a:latin typeface="Consolas"/>
+                <a:cs typeface="Consolas"/>
+              </a:rPr>
+              <a:t xml:space="preserve"> </a:t>
+            </a:r>
+            <a:r>
+              <a:rPr lang="en-US" sz="1300" b="0" i="0" dirty="0">
+                <a:solidFill>
+                  <a:srgbClr val="2F6B78"/>
+                </a:solidFill>
+                <a:latin typeface="Consolas"/>
+                <a:cs typeface="Consolas"/>
+              </a:rPr>
+              <a:t xml:space="preserve">src:ecog_stage</a:t>
+            </a:r>
+            <a:r>
+              <a:rPr lang="en-US" sz="1200" b="0" i="1" dirty="0">
+                <a:solidFill>
+                  <a:srgbClr val="5B6770"/>
+                </a:solidFill>
+                <a:latin typeface="Calibri"/>
+                <a:cs typeface="Calibri"/>
+              </a:rPr>
+              <a:t xml:space="preserve">	← where it came from</a:t>
+            </a:r>
+            <a:endParaRPr lang="en-US" sz="1300"/>
           </a:p>
         </p:txBody>
       </p:sp>
@@ -50379,430 +50591,6 @@
       </p:sp>
       <p:sp>
         <p:nvSpPr>
-          <p:cNvPr id="230" name="Google Shape;230;p7"/>
-          <p:cNvSpPr/>
-          <p:nvPr/>
-        </p:nvSpPr>
-        <p:spPr>
-          <a:xfrm>
-            <a:off x="5733288" y="2660904"/>
-            <a:ext cx="5266944" cy="402336"/>
-          </a:xfrm>
-          <a:prstGeom prst="roundRect">
-            <a:avLst>
-              <a:gd fmla="val 10000" name="adj"/>
-            </a:avLst>
-          </a:prstGeom>
-          <a:solidFill>
-            <a:srgbClr val="E6F2EC"/>
-          </a:solidFill>
-          <a:ln>
-            <a:noFill/>
-          </a:ln>
-        </p:spPr>
-        <p:txBody>
-          <a:bodyPr anchorCtr="0" anchor="ctr" bIns="45700" lIns="91425" spcFirstLastPara="1" rIns="91425" wrap="square" tIns="45700">
-            <a:noAutofit/>
-          </a:bodyPr>
-          <a:lstStyle/>
-          <a:p>
-            <a:pPr indent="0" lvl="0" marL="0" marR="0" rtl="0" algn="ctr">
-              <a:spcBef>
-                <a:spcPts val="0"/>
-              </a:spcBef>
-              <a:spcAft>
-                <a:spcPts val="0"/>
-              </a:spcAft>
-              <a:buNone/>
-            </a:pPr>
-            <a:r>
-              <a:t/>
-            </a:r>
-            <a:endParaRPr sz="1800">
-              <a:solidFill>
-                <a:schemeClr val="dk1"/>
-              </a:solidFill>
-              <a:latin typeface="Calibri"/>
-              <a:ea typeface="Calibri"/>
-              <a:cs typeface="Calibri"/>
-              <a:sym typeface="Calibri"/>
-            </a:endParaRPr>
-          </a:p>
-        </p:txBody>
-      </p:sp>
-      <p:sp>
-        <p:nvSpPr>
-          <p:cNvPr id="231" name="Google Shape;231;p7"/>
-          <p:cNvSpPr txBox="1"/>
-          <p:nvPr/>
-        </p:nvSpPr>
-        <p:spPr>
-          <a:xfrm>
-            <a:off x="5870448" y="2752344"/>
-            <a:ext cx="4837176" cy="210312"/>
-          </a:xfrm>
-          <a:prstGeom prst="rect">
-            <a:avLst/>
-          </a:prstGeom>
-          <a:noFill/>
-          <a:ln>
-            <a:noFill/>
-          </a:ln>
-        </p:spPr>
-        <p:txBody>
-          <a:bodyPr anchorCtr="0" anchor="ctr" bIns="0" lIns="0" spcFirstLastPara="1" rIns="0" wrap="square" tIns="0">
-            <a:spAutoFit/>
-          </a:bodyPr>
-          <a:lstStyle/>
-          <a:p>
-            <a:pPr indent="0" lvl="0" marL="0" marR="0" rtl="0" algn="l">
-              <a:lnSpc>
-                <a:spcPct val="100000"/>
-              </a:lnSpc>
-              <a:spcBef>
-                <a:spcPts val="0"/>
-              </a:spcBef>
-              <a:spcAft>
-                <a:spcPts val="0"/>
-              </a:spcAft>
-              <a:buNone/>
-            </a:pPr>
-            <a:r>
-              <a:rPr b="1" i="0" lang="en-US" sz="1600">
-                <a:solidFill>
-                  <a:srgbClr val="1F2328"/>
-                </a:solidFill>
-                <a:latin typeface="Consolas"/>
-                <a:ea typeface="Consolas"/>
-                <a:cs typeface="Consolas"/>
-                <a:sym typeface="Consolas"/>
-              </a:rPr>
-              <a:t>Class   Admission</a:t>
-            </a:r>
-            <a:endParaRPr/>
-          </a:p>
-        </p:txBody>
-      </p:sp>
-      <p:sp>
-        <p:nvSpPr>
-          <p:cNvPr id="232" name="Google Shape;232;p7"/>
-          <p:cNvSpPr/>
-          <p:nvPr/>
-        </p:nvSpPr>
-        <p:spPr>
-          <a:xfrm>
-            <a:off x="5733288" y="3172968"/>
-            <a:ext cx="5266944" cy="484632"/>
-          </a:xfrm>
-          <a:prstGeom prst="roundRect">
-            <a:avLst>
-              <a:gd fmla="val 10000" name="adj"/>
-            </a:avLst>
-          </a:prstGeom>
-          <a:solidFill>
-            <a:srgbClr val="F3F5F4"/>
-          </a:solidFill>
-          <a:ln>
-            <a:noFill/>
-          </a:ln>
-        </p:spPr>
-        <p:txBody>
-          <a:bodyPr anchorCtr="0" anchor="ctr" bIns="45700" lIns="91425" spcFirstLastPara="1" rIns="91425" wrap="square" tIns="45700">
-            <a:noAutofit/>
-          </a:bodyPr>
-          <a:lstStyle/>
-          <a:p>
-            <a:pPr indent="0" lvl="0" marL="0" marR="0" rtl="0" algn="ctr">
-              <a:spcBef>
-                <a:spcPts val="0"/>
-              </a:spcBef>
-              <a:spcAft>
-                <a:spcPts val="0"/>
-              </a:spcAft>
-              <a:buNone/>
-            </a:pPr>
-            <a:r>
-              <a:t/>
-            </a:r>
-            <a:endParaRPr sz="1800">
-              <a:solidFill>
-                <a:schemeClr val="dk1"/>
-              </a:solidFill>
-              <a:latin typeface="Calibri"/>
-              <a:ea typeface="Calibri"/>
-              <a:cs typeface="Calibri"/>
-              <a:sym typeface="Calibri"/>
-            </a:endParaRPr>
-          </a:p>
-        </p:txBody>
-      </p:sp>
-      <p:sp>
-        <p:nvSpPr>
-          <p:cNvPr id="233" name="Google Shape;233;p7"/>
-          <p:cNvSpPr txBox="1"/>
-          <p:nvPr/>
-        </p:nvSpPr>
-        <p:spPr>
-          <a:xfrm>
-            <a:off x="5852160" y="3291840"/>
-            <a:ext cx="4919472" cy="228600"/>
-          </a:xfrm>
-          <a:prstGeom prst="rect">
-            <a:avLst/>
-          </a:prstGeom>
-          <a:noFill/>
-          <a:ln>
-            <a:noFill/>
-          </a:ln>
-        </p:spPr>
-        <p:txBody>
-          <a:bodyPr anchorCtr="0" anchor="ctr" bIns="0" lIns="0" spcFirstLastPara="1" rIns="0" wrap="square" tIns="0">
-            <a:spAutoFit/>
-          </a:bodyPr>
-          <a:lstStyle/>
-          <a:p>
-            <a:pPr indent="0" lvl="0" marL="0" marR="0" rtl="0" algn="l">
-              <a:lnSpc>
-                <a:spcPct val="100000"/>
-              </a:lnSpc>
-              <a:spcBef>
-                <a:spcPts val="0"/>
-              </a:spcBef>
-              <a:spcAft>
-                <a:spcPts val="0"/>
-              </a:spcAft>
-              <a:buNone/>
-            </a:pPr>
-            <a:r>
-              <a:rPr b="0" i="0" lang="en-US" sz="1500">
-                <a:solidFill>
-                  <a:srgbClr val="1F2328"/>
-                </a:solidFill>
-                <a:latin typeface="Consolas"/>
-                <a:ea typeface="Consolas"/>
-                <a:cs typeface="Consolas"/>
-                <a:sym typeface="Consolas"/>
-              </a:rPr>
-              <a:t>ObjectProperty   patient_id  →  PatientData</a:t>
-            </a:r>
-            <a:endParaRPr/>
-          </a:p>
-        </p:txBody>
-      </p:sp>
-      <p:sp>
-        <p:nvSpPr>
-          <p:cNvPr id="234" name="Google Shape;234;p7"/>
-          <p:cNvSpPr/>
-          <p:nvPr/>
-        </p:nvSpPr>
-        <p:spPr>
-          <a:xfrm>
-            <a:off x="5733288" y="3749039"/>
-            <a:ext cx="5266944" cy="484632"/>
-          </a:xfrm>
-          <a:prstGeom prst="roundRect">
-            <a:avLst>
-              <a:gd fmla="val 10000" name="adj"/>
-            </a:avLst>
-          </a:prstGeom>
-          <a:solidFill>
-            <a:srgbClr val="F3F5F4"/>
-          </a:solidFill>
-          <a:ln>
-            <a:noFill/>
-          </a:ln>
-        </p:spPr>
-        <p:txBody>
-          <a:bodyPr anchorCtr="0" anchor="ctr" bIns="45700" lIns="91425" spcFirstLastPara="1" rIns="91425" wrap="square" tIns="45700">
-            <a:noAutofit/>
-          </a:bodyPr>
-          <a:lstStyle/>
-          <a:p>
-            <a:pPr indent="0" lvl="0" marL="0" marR="0" rtl="0" algn="ctr">
-              <a:spcBef>
-                <a:spcPts val="0"/>
-              </a:spcBef>
-              <a:spcAft>
-                <a:spcPts val="0"/>
-              </a:spcAft>
-              <a:buNone/>
-            </a:pPr>
-            <a:r>
-              <a:t/>
-            </a:r>
-            <a:endParaRPr sz="1800">
-              <a:solidFill>
-                <a:schemeClr val="dk1"/>
-              </a:solidFill>
-              <a:latin typeface="Calibri"/>
-              <a:ea typeface="Calibri"/>
-              <a:cs typeface="Calibri"/>
-              <a:sym typeface="Calibri"/>
-            </a:endParaRPr>
-          </a:p>
-        </p:txBody>
-      </p:sp>
-      <p:sp>
-        <p:nvSpPr>
-          <p:cNvPr id="235" name="Google Shape;235;p7"/>
-          <p:cNvSpPr txBox="1"/>
-          <p:nvPr/>
-        </p:nvSpPr>
-        <p:spPr>
-          <a:xfrm>
-            <a:off x="5852160" y="3877056"/>
-            <a:ext cx="4919472" cy="228600"/>
-          </a:xfrm>
-          <a:prstGeom prst="rect">
-            <a:avLst/>
-          </a:prstGeom>
-          <a:noFill/>
-          <a:ln>
-            <a:noFill/>
-          </a:ln>
-        </p:spPr>
-        <p:txBody>
-          <a:bodyPr anchorCtr="0" anchor="ctr" bIns="0" lIns="0" spcFirstLastPara="1" rIns="0" wrap="square" tIns="0">
-            <a:spAutoFit/>
-          </a:bodyPr>
-          <a:lstStyle/>
-          <a:p>
-            <a:pPr indent="0" lvl="0" marL="0" marR="0" rtl="0" algn="l">
-              <a:lnSpc>
-                <a:spcPct val="100000"/>
-              </a:lnSpc>
-              <a:spcBef>
-                <a:spcPts val="0"/>
-              </a:spcBef>
-              <a:spcAft>
-                <a:spcPts val="0"/>
-              </a:spcAft>
-              <a:buNone/>
-            </a:pPr>
-            <a:r>
-              <a:rPr b="0" i="0" lang="en-US" sz="1500">
-                <a:solidFill>
-                  <a:srgbClr val="1F2328"/>
-                </a:solidFill>
-                <a:latin typeface="Consolas"/>
-                <a:ea typeface="Consolas"/>
-                <a:cs typeface="Consolas"/>
-                <a:sym typeface="Consolas"/>
-              </a:rPr>
-              <a:t>DataProperty     BM_DEP      →  xsd:integer</a:t>
-            </a:r>
-            <a:endParaRPr/>
-          </a:p>
-        </p:txBody>
-      </p:sp>
-      <p:sp>
-        <p:nvSpPr>
-          <p:cNvPr id="236" name="Google Shape;236;p7"/>
-          <p:cNvSpPr/>
-          <p:nvPr/>
-        </p:nvSpPr>
-        <p:spPr>
-          <a:xfrm>
-            <a:off x="5733288" y="4315968"/>
-            <a:ext cx="5266944" cy="484632"/>
-          </a:xfrm>
-          <a:prstGeom prst="roundRect">
-            <a:avLst>
-              <a:gd fmla="val 10000" name="adj"/>
-            </a:avLst>
-          </a:prstGeom>
-          <a:solidFill>
-            <a:srgbClr val="F3F5F4"/>
-          </a:solidFill>
-          <a:ln>
-            <a:noFill/>
-          </a:ln>
-        </p:spPr>
-        <p:txBody>
-          <a:bodyPr anchorCtr="0" anchor="ctr" bIns="45700" lIns="91425" spcFirstLastPara="1" rIns="91425" wrap="square" tIns="45700">
-            <a:noAutofit/>
-          </a:bodyPr>
-          <a:lstStyle/>
-          <a:p>
-            <a:pPr indent="0" lvl="0" marL="0" marR="0" rtl="0" algn="ctr">
-              <a:spcBef>
-                <a:spcPts val="0"/>
-              </a:spcBef>
-              <a:spcAft>
-                <a:spcPts val="0"/>
-              </a:spcAft>
-              <a:buNone/>
-            </a:pPr>
-            <a:r>
-              <a:t/>
-            </a:r>
-            <a:endParaRPr sz="1800">
-              <a:solidFill>
-                <a:schemeClr val="dk1"/>
-              </a:solidFill>
-              <a:latin typeface="Calibri"/>
-              <a:ea typeface="Calibri"/>
-              <a:cs typeface="Calibri"/>
-              <a:sym typeface="Calibri"/>
-            </a:endParaRPr>
-          </a:p>
-        </p:txBody>
-      </p:sp>
-      <p:sp>
-        <p:nvSpPr>
-          <p:cNvPr id="237" name="Google Shape;237;p7"/>
-          <p:cNvSpPr txBox="1"/>
-          <p:nvPr/>
-        </p:nvSpPr>
-        <p:spPr>
-          <a:xfrm>
-            <a:off x="5852160" y="4443984"/>
-            <a:ext cx="4919472" cy="228600"/>
-          </a:xfrm>
-          <a:prstGeom prst="rect">
-            <a:avLst/>
-          </a:prstGeom>
-          <a:noFill/>
-          <a:ln>
-            <a:noFill/>
-          </a:ln>
-        </p:spPr>
-        <p:txBody>
-          <a:bodyPr anchorCtr="0" anchor="ctr" bIns="0" lIns="0" spcFirstLastPara="1" rIns="0" wrap="square" tIns="0">
-            <a:spAutoFit/>
-          </a:bodyPr>
-          <a:lstStyle/>
-          <a:p>
-            <a:pPr indent="0" lvl="0" marL="0" marR="0" rtl="0" algn="l">
-              <a:lnSpc>
-                <a:spcPct val="100000"/>
-              </a:lnSpc>
-              <a:spcBef>
-                <a:spcPts val="0"/>
-              </a:spcBef>
-              <a:spcAft>
-                <a:spcPts val="0"/>
-              </a:spcAft>
-              <a:buNone/>
-            </a:pPr>
-            <a:r>
-              <a:rPr b="0" i="0" lang="en-US" sz="1500">
-                <a:solidFill>
-                  <a:srgbClr val="1F2328"/>
-                </a:solidFill>
-                <a:latin typeface="Consolas"/>
-                <a:ea typeface="Consolas"/>
-                <a:cs typeface="Consolas"/>
-                <a:sym typeface="Consolas"/>
-              </a:rPr>
-              <a:t>DataProperty     ecog_stage  →  xsd:integer</a:t>
-            </a:r>
-            <a:endParaRPr/>
-          </a:p>
-        </p:txBody>
-      </p:sp>
-      <p:sp>
-        <p:nvSpPr>
           <p:cNvPr id="238" name="Google Shape;238;p7"/>
           <p:cNvSpPr/>
           <p:nvPr/>
@@ -51588,6 +51376,520 @@
               <a:t>6  MERGE</a:t>
             </a:r>
             <a:endParaRPr/>
+          </a:p>
+        </p:txBody>
+      </p:sp>
+      <p:sp>
+        <p:nvSpPr>
+          <p:cNvPr id="252" name="Code 252" descr="OWL Manchester Syntax excerpt"/>
+          <p:cNvSpPr txBox="1"/>
+          <p:nvPr/>
+        </p:nvSpPr>
+        <p:spPr>
+          <a:xfrm>
+            <a:off x="5733288" y="2697480"/>
+            <a:ext cx="5266944" cy="1956816"/>
+          </a:xfrm>
+          <a:prstGeom prst="roundRect">
+            <a:avLst>
+              <a:gd name="adj" fmla="val 5000"/>
+            </a:avLst>
+          </a:prstGeom>
+          <a:solidFill>
+            <a:srgbClr val="F6F8FA"/>
+          </a:solidFill>
+          <a:ln w="9525">
+            <a:solidFill>
+              <a:srgbClr val="D0D7DE"/>
+            </a:solidFill>
+          </a:ln>
+        </p:spPr>
+        <p:txBody>
+          <a:bodyPr wrap="none" lIns="109728" tIns="73152" rIns="109728" bIns="54864" anchor="t">
+            <a:noAutofit/>
+          </a:bodyPr>
+          <a:lstStyle/>
+          <a:p>
+            <a:pPr>
+              <a:lnSpc>
+                <a:spcPts val="1600"/>
+              </a:lnSpc>
+              <a:spcBef>
+                <a:spcPts val="0"/>
+              </a:spcBef>
+              <a:tabLst>
+                <a:tab pos="3246120" algn="l"/>
+              </a:tabLst>
+            </a:pPr>
+            <a:r>
+              <a:rPr lang="en-US" sz="1400" b="1" i="0" dirty="0">
+                <a:solidFill>
+                  <a:srgbClr val="0B6E4F"/>
+                </a:solidFill>
+                <a:latin typeface="Consolas"/>
+                <a:cs typeface="Consolas"/>
+              </a:rPr>
+              <a:t xml:space="preserve">Class:</a:t>
+            </a:r>
+            <a:r>
+              <a:rPr lang="en-US" sz="1400" b="0" i="0" dirty="0">
+                <a:solidFill>
+                  <a:srgbClr val="1F2328"/>
+                </a:solidFill>
+                <a:latin typeface="Consolas"/>
+                <a:cs typeface="Consolas"/>
+              </a:rPr>
+              <a:t xml:space="preserve"> </a:t>
+            </a:r>
+            <a:r>
+              <a:rPr lang="en-US" sz="1400" b="0" i="0" dirty="0">
+                <a:solidFill>
+                  <a:srgbClr val="1F2328"/>
+                </a:solidFill>
+                <a:latin typeface="Consolas"/>
+                <a:cs typeface="Consolas"/>
+              </a:rPr>
+              <a:t xml:space="preserve">Admission</a:t>
+            </a:r>
+            <a:endParaRPr lang="en-US" sz="1400"/>
+          </a:p>
+          <a:p>
+            <a:pPr>
+              <a:lnSpc>
+                <a:spcPts val="1600"/>
+              </a:lnSpc>
+              <a:spcBef>
+                <a:spcPts val="0"/>
+              </a:spcBef>
+              <a:tabLst>
+                <a:tab pos="3246120" algn="l"/>
+              </a:tabLst>
+            </a:pPr>
+            <a:r>
+              <a:rPr lang="en-US" sz="1400" b="0" i="0" dirty="0">
+                <a:solidFill>
+                  <a:srgbClr val="1F2328"/>
+                </a:solidFill>
+                <a:latin typeface="Consolas"/>
+                <a:cs typeface="Consolas"/>
+              </a:rPr>
+              <a:t xml:space="preserve">  </a:t>
+            </a:r>
+            <a:r>
+              <a:rPr lang="en-US" sz="1400" b="1" i="0" dirty="0">
+                <a:solidFill>
+                  <a:srgbClr val="0B6E4F"/>
+                </a:solidFill>
+                <a:latin typeface="Consolas"/>
+                <a:cs typeface="Consolas"/>
+              </a:rPr>
+              <a:t xml:space="preserve">SubClassOf:</a:t>
+            </a:r>
+            <a:endParaRPr lang="en-US" sz="1400"/>
+          </a:p>
+          <a:p>
+            <a:pPr>
+              <a:lnSpc>
+                <a:spcPts val="1600"/>
+              </a:lnSpc>
+              <a:spcBef>
+                <a:spcPts val="0"/>
+              </a:spcBef>
+              <a:tabLst>
+                <a:tab pos="3246120" algn="l"/>
+              </a:tabLst>
+            </a:pPr>
+            <a:r>
+              <a:rPr lang="en-US" sz="1400" b="0" i="0" dirty="0">
+                <a:solidFill>
+                  <a:srgbClr val="1F2328"/>
+                </a:solidFill>
+                <a:latin typeface="Consolas"/>
+                <a:cs typeface="Consolas"/>
+              </a:rPr>
+              <a:t xml:space="preserve">    </a:t>
+            </a:r>
+            <a:r>
+              <a:rPr lang="en-US" sz="1400" b="0" i="0" dirty="0">
+                <a:solidFill>
+                  <a:srgbClr val="1F2328"/>
+                </a:solidFill>
+                <a:latin typeface="Consolas"/>
+                <a:cs typeface="Consolas"/>
+              </a:rPr>
+              <a:t xml:space="preserve">patient_id</a:t>
+            </a:r>
+            <a:r>
+              <a:rPr lang="en-US" sz="1400" b="0" i="0" dirty="0">
+                <a:solidFill>
+                  <a:srgbClr val="1F2328"/>
+                </a:solidFill>
+                <a:latin typeface="Consolas"/>
+                <a:cs typeface="Consolas"/>
+              </a:rPr>
+              <a:t xml:space="preserve"> </a:t>
+            </a:r>
+            <a:r>
+              <a:rPr lang="en-US" sz="1400" b="1" i="0" dirty="0">
+                <a:solidFill>
+                  <a:srgbClr val="0B6E4F"/>
+                </a:solidFill>
+                <a:latin typeface="Consolas"/>
+                <a:cs typeface="Consolas"/>
+              </a:rPr>
+              <a:t xml:space="preserve">some</a:t>
+            </a:r>
+            <a:r>
+              <a:rPr lang="en-US" sz="1400" b="0" i="0" dirty="0">
+                <a:solidFill>
+                  <a:srgbClr val="1F2328"/>
+                </a:solidFill>
+                <a:latin typeface="Consolas"/>
+                <a:cs typeface="Consolas"/>
+              </a:rPr>
+              <a:t xml:space="preserve"> </a:t>
+            </a:r>
+            <a:r>
+              <a:rPr lang="en-US" sz="1400" b="0" i="0" dirty="0">
+                <a:solidFill>
+                  <a:srgbClr val="1F2328"/>
+                </a:solidFill>
+                <a:latin typeface="Consolas"/>
+                <a:cs typeface="Consolas"/>
+              </a:rPr>
+              <a:t xml:space="preserve">PatientData</a:t>
+            </a:r>
+            <a:r>
+              <a:rPr lang="en-US" sz="1400" b="0" i="0" dirty="0">
+                <a:solidFill>
+                  <a:srgbClr val="1F2328"/>
+                </a:solidFill>
+                <a:latin typeface="Consolas"/>
+                <a:cs typeface="Consolas"/>
+              </a:rPr>
+              <a:t xml:space="preserve">,</a:t>
+            </a:r>
+            <a:r>
+              <a:rPr lang="en-US" sz="1200" b="0" i="1" dirty="0">
+                <a:solidFill>
+                  <a:srgbClr val="5B6770"/>
+                </a:solidFill>
+                <a:latin typeface="Calibri"/>
+                <a:cs typeface="Calibri"/>
+              </a:rPr>
+              <a:t xml:space="preserve">	← each has a patient</a:t>
+            </a:r>
+            <a:endParaRPr lang="en-US" sz="1400"/>
+          </a:p>
+          <a:p>
+            <a:pPr>
+              <a:lnSpc>
+                <a:spcPts val="1600"/>
+              </a:lnSpc>
+              <a:spcBef>
+                <a:spcPts val="0"/>
+              </a:spcBef>
+              <a:tabLst>
+                <a:tab pos="3246120" algn="l"/>
+              </a:tabLst>
+            </a:pPr>
+            <a:r>
+              <a:rPr lang="en-US" sz="1400" b="0" i="0" dirty="0">
+                <a:solidFill>
+                  <a:srgbClr val="1F2328"/>
+                </a:solidFill>
+                <a:latin typeface="Consolas"/>
+                <a:cs typeface="Consolas"/>
+              </a:rPr>
+              <a:t xml:space="preserve">    </a:t>
+            </a:r>
+            <a:r>
+              <a:rPr lang="en-US" sz="1400" b="0" i="0" dirty="0">
+                <a:solidFill>
+                  <a:srgbClr val="1F2328"/>
+                </a:solidFill>
+                <a:latin typeface="Consolas"/>
+                <a:cs typeface="Consolas"/>
+              </a:rPr>
+              <a:t xml:space="preserve">BM_DEP</a:t>
+            </a:r>
+            <a:r>
+              <a:rPr lang="en-US" sz="1400" b="0" i="0" dirty="0">
+                <a:solidFill>
+                  <a:srgbClr val="1F2328"/>
+                </a:solidFill>
+                <a:latin typeface="Consolas"/>
+                <a:cs typeface="Consolas"/>
+              </a:rPr>
+              <a:t xml:space="preserve"> </a:t>
+            </a:r>
+            <a:r>
+              <a:rPr lang="en-US" sz="1400" b="1" i="0" dirty="0">
+                <a:solidFill>
+                  <a:srgbClr val="0B6E4F"/>
+                </a:solidFill>
+                <a:latin typeface="Consolas"/>
+                <a:cs typeface="Consolas"/>
+              </a:rPr>
+              <a:t xml:space="preserve">only</a:t>
+            </a:r>
+            <a:r>
+              <a:rPr lang="en-US" sz="1400" b="0" i="0" dirty="0">
+                <a:solidFill>
+                  <a:srgbClr val="1F2328"/>
+                </a:solidFill>
+                <a:latin typeface="Consolas"/>
+                <a:cs typeface="Consolas"/>
+              </a:rPr>
+              <a:t xml:space="preserve"> </a:t>
+            </a:r>
+            <a:r>
+              <a:rPr lang="en-US" sz="1400" b="0" i="0" dirty="0">
+                <a:solidFill>
+                  <a:srgbClr val="6F42C1"/>
+                </a:solidFill>
+                <a:latin typeface="Consolas"/>
+                <a:cs typeface="Consolas"/>
+              </a:rPr>
+              <a:t xml:space="preserve">xsd:integer</a:t>
+            </a:r>
+            <a:r>
+              <a:rPr lang="en-US" sz="1400" b="0" i="0" dirty="0">
+                <a:solidFill>
+                  <a:srgbClr val="1F2328"/>
+                </a:solidFill>
+                <a:latin typeface="Consolas"/>
+                <a:cs typeface="Consolas"/>
+              </a:rPr>
+              <a:t xml:space="preserve">,</a:t>
+            </a:r>
+            <a:r>
+              <a:rPr lang="en-US" sz="1200" b="0" i="1" dirty="0">
+                <a:solidFill>
+                  <a:srgbClr val="5B6770"/>
+                </a:solidFill>
+                <a:latin typeface="Calibri"/>
+                <a:cs typeface="Calibri"/>
+              </a:rPr>
+              <a:t xml:space="preserve">	← if present, an integer</a:t>
+            </a:r>
+            <a:endParaRPr lang="en-US" sz="1400"/>
+          </a:p>
+          <a:p>
+            <a:pPr>
+              <a:lnSpc>
+                <a:spcPts val="1600"/>
+              </a:lnSpc>
+              <a:spcBef>
+                <a:spcPts val="0"/>
+              </a:spcBef>
+              <a:tabLst>
+                <a:tab pos="3246120" algn="l"/>
+              </a:tabLst>
+            </a:pPr>
+            <a:r>
+              <a:rPr lang="en-US" sz="1400" b="0" i="0" dirty="0">
+                <a:solidFill>
+                  <a:srgbClr val="1F2328"/>
+                </a:solidFill>
+                <a:latin typeface="Consolas"/>
+                <a:cs typeface="Consolas"/>
+              </a:rPr>
+              <a:t xml:space="preserve">    </a:t>
+            </a:r>
+            <a:r>
+              <a:rPr lang="en-US" sz="1400" b="0" i="0" dirty="0">
+                <a:solidFill>
+                  <a:srgbClr val="1F2328"/>
+                </a:solidFill>
+                <a:latin typeface="Consolas"/>
+                <a:cs typeface="Consolas"/>
+              </a:rPr>
+              <a:t xml:space="preserve">ecog_stage</a:t>
+            </a:r>
+            <a:r>
+              <a:rPr lang="en-US" sz="1400" b="0" i="0" dirty="0">
+                <a:solidFill>
+                  <a:srgbClr val="1F2328"/>
+                </a:solidFill>
+                <a:latin typeface="Consolas"/>
+                <a:cs typeface="Consolas"/>
+              </a:rPr>
+              <a:t xml:space="preserve"> </a:t>
+            </a:r>
+            <a:r>
+              <a:rPr lang="en-US" sz="1400" b="1" i="0" dirty="0">
+                <a:solidFill>
+                  <a:srgbClr val="0B6E4F"/>
+                </a:solidFill>
+                <a:latin typeface="Consolas"/>
+                <a:cs typeface="Consolas"/>
+              </a:rPr>
+              <a:t xml:space="preserve">only</a:t>
+            </a:r>
+            <a:r>
+              <a:rPr lang="en-US" sz="1400" b="0" i="0" dirty="0">
+                <a:solidFill>
+                  <a:srgbClr val="1F2328"/>
+                </a:solidFill>
+                <a:latin typeface="Consolas"/>
+                <a:cs typeface="Consolas"/>
+              </a:rPr>
+              <a:t xml:space="preserve"> </a:t>
+            </a:r>
+            <a:r>
+              <a:rPr lang="en-US" sz="1400" b="0" i="0" dirty="0">
+                <a:solidFill>
+                  <a:srgbClr val="6F42C1"/>
+                </a:solidFill>
+                <a:latin typeface="Consolas"/>
+                <a:cs typeface="Consolas"/>
+              </a:rPr>
+              <a:t xml:space="preserve">xsd:integer</a:t>
+            </a:r>
+            <a:endParaRPr lang="en-US" sz="1400"/>
+          </a:p>
+          <a:p>
+            <a:pPr>
+              <a:lnSpc>
+                <a:spcPts val="1600"/>
+              </a:lnSpc>
+              <a:spcBef>
+                <a:spcPts val="0"/>
+              </a:spcBef>
+              <a:tabLst>
+                <a:tab pos="3246120" algn="l"/>
+              </a:tabLst>
+            </a:pPr>
+            <a:r>
+              <a:rPr lang="en-US" sz="1400" b="1" i="0" dirty="0">
+                <a:solidFill>
+                  <a:srgbClr val="0B6E4F"/>
+                </a:solidFill>
+                <a:latin typeface="Consolas"/>
+                <a:cs typeface="Consolas"/>
+              </a:rPr>
+              <a:t xml:space="preserve">ObjectProperty:</a:t>
+            </a:r>
+            <a:r>
+              <a:rPr lang="en-US" sz="1400" b="0" i="0" dirty="0">
+                <a:solidFill>
+                  <a:srgbClr val="1F2328"/>
+                </a:solidFill>
+                <a:latin typeface="Consolas"/>
+                <a:cs typeface="Consolas"/>
+              </a:rPr>
+              <a:t xml:space="preserve"> </a:t>
+            </a:r>
+            <a:r>
+              <a:rPr lang="en-US" sz="1400" b="0" i="0" dirty="0">
+                <a:solidFill>
+                  <a:srgbClr val="1F2328"/>
+                </a:solidFill>
+                <a:latin typeface="Consolas"/>
+                <a:cs typeface="Consolas"/>
+              </a:rPr>
+              <a:t xml:space="preserve">patient_id</a:t>
+            </a:r>
+            <a:r>
+              <a:rPr lang="en-US" sz="1200" b="0" i="1" dirty="0">
+                <a:solidFill>
+                  <a:srgbClr val="5B6770"/>
+                </a:solidFill>
+                <a:latin typeface="Calibri"/>
+                <a:cs typeface="Calibri"/>
+              </a:rPr>
+              <a:t xml:space="preserve">	← the FK becomes a link</a:t>
+            </a:r>
+            <a:endParaRPr lang="en-US" sz="1400"/>
+          </a:p>
+          <a:p>
+            <a:pPr>
+              <a:lnSpc>
+                <a:spcPts val="1600"/>
+              </a:lnSpc>
+              <a:spcBef>
+                <a:spcPts val="0"/>
+              </a:spcBef>
+              <a:tabLst>
+                <a:tab pos="3246120" algn="l"/>
+              </a:tabLst>
+            </a:pPr>
+            <a:r>
+              <a:rPr lang="en-US" sz="1400" b="1" i="0" dirty="0">
+                <a:solidFill>
+                  <a:srgbClr val="0B6E4F"/>
+                </a:solidFill>
+                <a:latin typeface="Consolas"/>
+                <a:cs typeface="Consolas"/>
+              </a:rPr>
+              <a:t xml:space="preserve">DataProperty:</a:t>
+            </a:r>
+            <a:r>
+              <a:rPr lang="en-US" sz="1400" b="0" i="0" dirty="0">
+                <a:solidFill>
+                  <a:srgbClr val="1F2328"/>
+                </a:solidFill>
+                <a:latin typeface="Consolas"/>
+                <a:cs typeface="Consolas"/>
+              </a:rPr>
+              <a:t xml:space="preserve"> </a:t>
+            </a:r>
+            <a:r>
+              <a:rPr lang="en-US" sz="1400" b="0" i="0" dirty="0">
+                <a:solidFill>
+                  <a:srgbClr val="1F2328"/>
+                </a:solidFill>
+                <a:latin typeface="Consolas"/>
+                <a:cs typeface="Consolas"/>
+              </a:rPr>
+              <a:t xml:space="preserve">BM_DEP</a:t>
+            </a:r>
+            <a:endParaRPr lang="en-US" sz="1400"/>
+          </a:p>
+          <a:p>
+            <a:pPr>
+              <a:lnSpc>
+                <a:spcPts val="1600"/>
+              </a:lnSpc>
+              <a:spcBef>
+                <a:spcPts val="0"/>
+              </a:spcBef>
+              <a:tabLst>
+                <a:tab pos="3246120" algn="l"/>
+              </a:tabLst>
+            </a:pPr>
+            <a:r>
+              <a:rPr lang="en-US" sz="1400" b="1" i="0" dirty="0">
+                <a:solidFill>
+                  <a:srgbClr val="0B6E4F"/>
+                </a:solidFill>
+                <a:latin typeface="Consolas"/>
+                <a:cs typeface="Consolas"/>
+              </a:rPr>
+              <a:t xml:space="preserve">DataProperty:</a:t>
+            </a:r>
+            <a:r>
+              <a:rPr lang="en-US" sz="1400" b="0" i="0" dirty="0">
+                <a:solidFill>
+                  <a:srgbClr val="1F2328"/>
+                </a:solidFill>
+                <a:latin typeface="Consolas"/>
+                <a:cs typeface="Consolas"/>
+              </a:rPr>
+              <a:t xml:space="preserve"> </a:t>
+            </a:r>
+            <a:r>
+              <a:rPr lang="en-US" sz="1400" b="0" i="0" dirty="0">
+                <a:solidFill>
+                  <a:srgbClr val="1F2328"/>
+                </a:solidFill>
+                <a:latin typeface="Consolas"/>
+                <a:cs typeface="Consolas"/>
+              </a:rPr>
+              <a:t xml:space="preserve">ecog_stage</a:t>
+            </a:r>
+            <a:endParaRPr lang="en-US" sz="1400"/>
           </a:p>
         </p:txBody>
       </p:sp>
@@ -54722,149 +55024,13 @@
       </p:sp>
       <p:sp>
         <p:nvSpPr>
-          <p:cNvPr id="336" name="TextBox 335"/>
-          <p:cNvSpPr txBox="1"/>
-          <p:nvPr/>
-        </p:nvSpPr>
-        <p:spPr>
-          <a:xfrm>
-            <a:off x="1014984" y="2852928"/>
-            <a:ext cx="2468880" cy="365760"/>
-          </a:xfrm>
-          <a:prstGeom prst="rect">
-            <a:avLst/>
-          </a:prstGeom>
-          <a:noFill/>
-        </p:spPr>
-        <p:txBody>
-          <a:bodyPr wrap="square" lIns="0" rIns="0" tIns="0" bIns="0" anchor="ctr">
-            <a:spAutoFit/>
-          </a:bodyPr>
-          <a:lstStyle/>
-          <a:p>
-            <a:r>
-              <a:rPr sz="1900" b="1">
-                <a:solidFill>
-                  <a:srgbClr val="1F2328"/>
-                </a:solidFill>
-                <a:latin typeface="Consolas"/>
-              </a:rPr>
-              <a:t>Class: Admission</a:t>
-            </a:r>
-          </a:p>
-        </p:txBody>
-      </p:sp>
-      <p:sp>
-        <p:nvSpPr>
-          <p:cNvPr id="337" name="TextBox 336"/>
-          <p:cNvSpPr txBox="1"/>
-          <p:nvPr/>
-        </p:nvSpPr>
-        <p:spPr>
-          <a:xfrm>
-            <a:off x="1005840" y="3401568"/>
-            <a:ext cx="2633472" cy="274320"/>
-          </a:xfrm>
-          <a:prstGeom prst="rect">
-            <a:avLst/>
-          </a:prstGeom>
-          <a:noFill/>
-        </p:spPr>
-        <p:txBody>
-          <a:bodyPr wrap="square" lIns="0" rIns="0" tIns="0" bIns="0" anchor="ctr">
-            <a:spAutoFit/>
-          </a:bodyPr>
-          <a:lstStyle/>
-          <a:p>
-            <a:r>
-              <a:rPr sz="1360" b="0">
-                <a:solidFill>
-                  <a:srgbClr val="3A434C"/>
-                </a:solidFill>
-                <a:latin typeface="Consolas"/>
-              </a:rPr>
-              <a:t>patient_id  → PatientData</a:t>
-            </a:r>
-          </a:p>
-        </p:txBody>
-      </p:sp>
-      <p:sp>
-        <p:nvSpPr>
-          <p:cNvPr id="338" name="TextBox 337"/>
-          <p:cNvSpPr txBox="1"/>
-          <p:nvPr/>
-        </p:nvSpPr>
-        <p:spPr>
-          <a:xfrm>
-            <a:off x="1005840" y="3840480"/>
-            <a:ext cx="2633472" cy="274320"/>
-          </a:xfrm>
-          <a:prstGeom prst="rect">
-            <a:avLst/>
-          </a:prstGeom>
-          <a:noFill/>
-        </p:spPr>
-        <p:txBody>
-          <a:bodyPr wrap="square" lIns="0" rIns="0" tIns="0" bIns="0" anchor="ctr">
-            <a:spAutoFit/>
-          </a:bodyPr>
-          <a:lstStyle/>
-          <a:p>
-            <a:r>
-              <a:rPr sz="1360" b="0">
-                <a:solidFill>
-                  <a:srgbClr val="3A434C"/>
-                </a:solidFill>
-                <a:latin typeface="Consolas"/>
-              </a:rPr>
-              <a:t>BM_DEP      → integer</a:t>
-            </a:r>
-          </a:p>
-        </p:txBody>
-      </p:sp>
-      <p:sp>
-        <p:nvSpPr>
-          <p:cNvPr id="339" name="TextBox 338"/>
-          <p:cNvSpPr txBox="1"/>
-          <p:nvPr/>
-        </p:nvSpPr>
-        <p:spPr>
-          <a:xfrm>
-            <a:off x="1005840" y="4279392"/>
-            <a:ext cx="2633472" cy="274320"/>
-          </a:xfrm>
-          <a:prstGeom prst="rect">
-            <a:avLst/>
-          </a:prstGeom>
-          <a:noFill/>
-        </p:spPr>
-        <p:txBody>
-          <a:bodyPr wrap="square" lIns="0" rIns="0" tIns="0" bIns="0" anchor="ctr">
-            <a:spAutoFit/>
-          </a:bodyPr>
-          <a:lstStyle/>
-          <a:p>
-            <a:r>
-              <a:rPr sz="1360" b="0">
-                <a:solidFill>
-                  <a:srgbClr val="3A434C"/>
-                </a:solidFill>
-                <a:latin typeface="Consolas"/>
-              </a:rPr>
-              <a:t>ecog_stage  → integer</a:t>
-            </a:r>
-          </a:p>
-        </p:txBody>
-      </p:sp>
-      <p:sp>
-        <p:nvSpPr>
           <p:cNvPr id="340" name="TextBox 339"/>
           <p:cNvSpPr txBox="1"/>
           <p:nvPr/>
         </p:nvSpPr>
         <p:spPr>
           <a:xfrm>
-            <a:off x="1005840" y="4846320"/>
+            <a:off x="1005840" y="4315968"/>
             <a:ext cx="2560320" cy="393192"/>
           </a:xfrm>
           <a:prstGeom prst="rect">
@@ -55135,23 +55301,885 @@
       </p:sp>
       <p:sp>
         <p:nvSpPr>
-          <p:cNvPr id="365" name="Rectangle 364"/>
+          <p:cNvPr id="385" name="Code 385" descr="OWL Manchester Syntax excerpt"/>
+          <p:cNvSpPr txBox="1"/>
+          <p:nvPr/>
+        </p:nvSpPr>
+        <p:spPr>
+          <a:xfrm>
+            <a:off x="950976" y="3017520"/>
+            <a:ext cx="2670048" cy="1097280"/>
+          </a:xfrm>
+          <a:prstGeom prst="roundRect">
+            <a:avLst>
+              <a:gd name="adj" fmla="val 5000"/>
+            </a:avLst>
+          </a:prstGeom>
+          <a:solidFill>
+            <a:srgbClr val="F6F8FA"/>
+          </a:solidFill>
+          <a:ln w="9525">
+            <a:solidFill>
+              <a:srgbClr val="D0D7DE"/>
+            </a:solidFill>
+          </a:ln>
+        </p:spPr>
+        <p:txBody>
+          <a:bodyPr wrap="none" lIns="73152" tIns="73152" rIns="73152" bIns="54864" anchor="t">
+            <a:noAutofit/>
+          </a:bodyPr>
+          <a:lstStyle/>
+          <a:p>
+            <a:pPr>
+              <a:lnSpc>
+                <a:spcPts val="1350"/>
+              </a:lnSpc>
+              <a:spcBef>
+                <a:spcPts val="0"/>
+              </a:spcBef>
+            </a:pPr>
+            <a:r>
+              <a:rPr lang="en-US" sz="1100" b="1" i="0" dirty="0">
+                <a:solidFill>
+                  <a:srgbClr val="0B6E4F"/>
+                </a:solidFill>
+                <a:latin typeface="Consolas"/>
+                <a:cs typeface="Consolas"/>
+              </a:rPr>
+              <a:t xml:space="preserve">Class:</a:t>
+            </a:r>
+            <a:r>
+              <a:rPr lang="en-US" sz="1100" b="0" i="0" dirty="0">
+                <a:solidFill>
+                  <a:srgbClr val="1F2328"/>
+                </a:solidFill>
+                <a:latin typeface="Consolas"/>
+                <a:cs typeface="Consolas"/>
+              </a:rPr>
+              <a:t xml:space="preserve"> </a:t>
+            </a:r>
+            <a:r>
+              <a:rPr lang="en-US" sz="1100" b="0" i="0" dirty="0">
+                <a:solidFill>
+                  <a:srgbClr val="1F2328"/>
+                </a:solidFill>
+                <a:latin typeface="Consolas"/>
+                <a:cs typeface="Consolas"/>
+              </a:rPr>
+              <a:t xml:space="preserve">Admission</a:t>
+            </a:r>
+            <a:endParaRPr lang="en-US" sz="1100"/>
+          </a:p>
+          <a:p>
+            <a:pPr>
+              <a:lnSpc>
+                <a:spcPts val="1350"/>
+              </a:lnSpc>
+              <a:spcBef>
+                <a:spcPts val="0"/>
+              </a:spcBef>
+            </a:pPr>
+            <a:r>
+              <a:rPr lang="en-US" sz="1100" b="0" i="0" dirty="0">
+                <a:solidFill>
+                  <a:srgbClr val="1F2328"/>
+                </a:solidFill>
+                <a:latin typeface="Consolas"/>
+                <a:cs typeface="Consolas"/>
+              </a:rPr>
+              <a:t xml:space="preserve">  </a:t>
+            </a:r>
+            <a:r>
+              <a:rPr lang="en-US" sz="1100" b="1" i="0" dirty="0">
+                <a:solidFill>
+                  <a:srgbClr val="0B6E4F"/>
+                </a:solidFill>
+                <a:latin typeface="Consolas"/>
+                <a:cs typeface="Consolas"/>
+              </a:rPr>
+              <a:t xml:space="preserve">SubClassOf:</a:t>
+            </a:r>
+            <a:endParaRPr lang="en-US" sz="1100"/>
+          </a:p>
+          <a:p>
+            <a:pPr>
+              <a:lnSpc>
+                <a:spcPts val="1350"/>
+              </a:lnSpc>
+              <a:spcBef>
+                <a:spcPts val="0"/>
+              </a:spcBef>
+            </a:pPr>
+            <a:r>
+              <a:rPr lang="en-US" sz="1100" b="0" i="0" dirty="0">
+                <a:solidFill>
+                  <a:srgbClr val="1F2328"/>
+                </a:solidFill>
+                <a:latin typeface="Consolas"/>
+                <a:cs typeface="Consolas"/>
+              </a:rPr>
+              <a:t xml:space="preserve">    </a:t>
+            </a:r>
+            <a:r>
+              <a:rPr lang="en-US" sz="1100" b="0" i="0" dirty="0">
+                <a:solidFill>
+                  <a:srgbClr val="1F2328"/>
+                </a:solidFill>
+                <a:latin typeface="Consolas"/>
+                <a:cs typeface="Consolas"/>
+              </a:rPr>
+              <a:t xml:space="preserve">patient_id</a:t>
+            </a:r>
+            <a:r>
+              <a:rPr lang="en-US" sz="1100" b="0" i="0" dirty="0">
+                <a:solidFill>
+                  <a:srgbClr val="1F2328"/>
+                </a:solidFill>
+                <a:latin typeface="Consolas"/>
+                <a:cs typeface="Consolas"/>
+              </a:rPr>
+              <a:t xml:space="preserve"> </a:t>
+            </a:r>
+            <a:r>
+              <a:rPr lang="en-US" sz="1100" b="1" i="0" dirty="0">
+                <a:solidFill>
+                  <a:srgbClr val="0B6E4F"/>
+                </a:solidFill>
+                <a:latin typeface="Consolas"/>
+                <a:cs typeface="Consolas"/>
+              </a:rPr>
+              <a:t xml:space="preserve">some</a:t>
+            </a:r>
+            <a:r>
+              <a:rPr lang="en-US" sz="1100" b="0" i="0" dirty="0">
+                <a:solidFill>
+                  <a:srgbClr val="1F2328"/>
+                </a:solidFill>
+                <a:latin typeface="Consolas"/>
+                <a:cs typeface="Consolas"/>
+              </a:rPr>
+              <a:t xml:space="preserve"> </a:t>
+            </a:r>
+            <a:r>
+              <a:rPr lang="en-US" sz="1100" b="0" i="0" dirty="0">
+                <a:solidFill>
+                  <a:srgbClr val="1F2328"/>
+                </a:solidFill>
+                <a:latin typeface="Consolas"/>
+                <a:cs typeface="Consolas"/>
+              </a:rPr>
+              <a:t xml:space="preserve">PatientData</a:t>
+            </a:r>
+            <a:r>
+              <a:rPr lang="en-US" sz="1100" b="0" i="0" dirty="0">
+                <a:solidFill>
+                  <a:srgbClr val="1F2328"/>
+                </a:solidFill>
+                <a:latin typeface="Consolas"/>
+                <a:cs typeface="Consolas"/>
+              </a:rPr>
+              <a:t xml:space="preserve">,</a:t>
+            </a:r>
+            <a:endParaRPr lang="en-US" sz="1100"/>
+          </a:p>
+          <a:p>
+            <a:pPr>
+              <a:lnSpc>
+                <a:spcPts val="1350"/>
+              </a:lnSpc>
+              <a:spcBef>
+                <a:spcPts val="0"/>
+              </a:spcBef>
+            </a:pPr>
+            <a:r>
+              <a:rPr lang="en-US" sz="1100" b="0" i="0" dirty="0">
+                <a:solidFill>
+                  <a:srgbClr val="1F2328"/>
+                </a:solidFill>
+                <a:latin typeface="Consolas"/>
+                <a:cs typeface="Consolas"/>
+              </a:rPr>
+              <a:t xml:space="preserve">    </a:t>
+            </a:r>
+            <a:r>
+              <a:rPr lang="en-US" sz="1100" b="0" i="0" dirty="0">
+                <a:solidFill>
+                  <a:srgbClr val="1F2328"/>
+                </a:solidFill>
+                <a:latin typeface="Consolas"/>
+                <a:cs typeface="Consolas"/>
+              </a:rPr>
+              <a:t xml:space="preserve">BM_DEP</a:t>
+            </a:r>
+            <a:r>
+              <a:rPr lang="en-US" sz="1100" b="0" i="0" dirty="0">
+                <a:solidFill>
+                  <a:srgbClr val="1F2328"/>
+                </a:solidFill>
+                <a:latin typeface="Consolas"/>
+                <a:cs typeface="Consolas"/>
+              </a:rPr>
+              <a:t xml:space="preserve"> </a:t>
+            </a:r>
+            <a:r>
+              <a:rPr lang="en-US" sz="1100" b="1" i="0" dirty="0">
+                <a:solidFill>
+                  <a:srgbClr val="0B6E4F"/>
+                </a:solidFill>
+                <a:latin typeface="Consolas"/>
+                <a:cs typeface="Consolas"/>
+              </a:rPr>
+              <a:t xml:space="preserve">only</a:t>
+            </a:r>
+            <a:r>
+              <a:rPr lang="en-US" sz="1100" b="0" i="0" dirty="0">
+                <a:solidFill>
+                  <a:srgbClr val="1F2328"/>
+                </a:solidFill>
+                <a:latin typeface="Consolas"/>
+                <a:cs typeface="Consolas"/>
+              </a:rPr>
+              <a:t xml:space="preserve"> </a:t>
+            </a:r>
+            <a:r>
+              <a:rPr lang="en-US" sz="1100" b="0" i="0" dirty="0">
+                <a:solidFill>
+                  <a:srgbClr val="6F42C1"/>
+                </a:solidFill>
+                <a:latin typeface="Consolas"/>
+                <a:cs typeface="Consolas"/>
+              </a:rPr>
+              <a:t xml:space="preserve">xsd:integer</a:t>
+            </a:r>
+            <a:r>
+              <a:rPr lang="en-US" sz="1100" b="0" i="0" dirty="0">
+                <a:solidFill>
+                  <a:srgbClr val="1F2328"/>
+                </a:solidFill>
+                <a:latin typeface="Consolas"/>
+                <a:cs typeface="Consolas"/>
+              </a:rPr>
+              <a:t xml:space="preserve">,</a:t>
+            </a:r>
+            <a:endParaRPr lang="en-US" sz="1100"/>
+          </a:p>
+          <a:p>
+            <a:pPr>
+              <a:lnSpc>
+                <a:spcPts val="1350"/>
+              </a:lnSpc>
+              <a:spcBef>
+                <a:spcPts val="0"/>
+              </a:spcBef>
+            </a:pPr>
+            <a:r>
+              <a:rPr lang="en-US" sz="1100" b="0" i="0" dirty="0">
+                <a:solidFill>
+                  <a:srgbClr val="1F2328"/>
+                </a:solidFill>
+                <a:latin typeface="Consolas"/>
+                <a:cs typeface="Consolas"/>
+              </a:rPr>
+              <a:t xml:space="preserve">    </a:t>
+            </a:r>
+            <a:r>
+              <a:rPr lang="en-US" sz="1100" b="0" i="0" dirty="0">
+                <a:solidFill>
+                  <a:srgbClr val="1F2328"/>
+                </a:solidFill>
+                <a:latin typeface="Consolas"/>
+                <a:cs typeface="Consolas"/>
+              </a:rPr>
+              <a:t xml:space="preserve">ecog_stage</a:t>
+            </a:r>
+            <a:r>
+              <a:rPr lang="en-US" sz="1100" b="0" i="0" dirty="0">
+                <a:solidFill>
+                  <a:srgbClr val="1F2328"/>
+                </a:solidFill>
+                <a:latin typeface="Consolas"/>
+                <a:cs typeface="Consolas"/>
+              </a:rPr>
+              <a:t xml:space="preserve"> </a:t>
+            </a:r>
+            <a:r>
+              <a:rPr lang="en-US" sz="1100" b="1" i="0" dirty="0">
+                <a:solidFill>
+                  <a:srgbClr val="0B6E4F"/>
+                </a:solidFill>
+                <a:latin typeface="Consolas"/>
+                <a:cs typeface="Consolas"/>
+              </a:rPr>
+              <a:t xml:space="preserve">only</a:t>
+            </a:r>
+            <a:r>
+              <a:rPr lang="en-US" sz="1100" b="0" i="0" dirty="0">
+                <a:solidFill>
+                  <a:srgbClr val="1F2328"/>
+                </a:solidFill>
+                <a:latin typeface="Consolas"/>
+                <a:cs typeface="Consolas"/>
+              </a:rPr>
+              <a:t xml:space="preserve"> </a:t>
+            </a:r>
+            <a:r>
+              <a:rPr lang="en-US" sz="1100" b="0" i="0" dirty="0">
+                <a:solidFill>
+                  <a:srgbClr val="6F42C1"/>
+                </a:solidFill>
+                <a:latin typeface="Consolas"/>
+                <a:cs typeface="Consolas"/>
+              </a:rPr>
+              <a:t xml:space="preserve">xsd:integer</a:t>
+            </a:r>
+            <a:endParaRPr lang="en-US" sz="1100"/>
+          </a:p>
+        </p:txBody>
+      </p:sp>
+      <p:sp>
+        <p:nvSpPr>
+          <p:cNvPr id="386" name="Code 386" descr="OWL Manchester Syntax excerpt"/>
+          <p:cNvSpPr txBox="1"/>
+          <p:nvPr/>
+        </p:nvSpPr>
+        <p:spPr>
+          <a:xfrm>
+            <a:off x="4937760" y="2724912"/>
+            <a:ext cx="6172200" cy="2226818"/>
+          </a:xfrm>
+          <a:prstGeom prst="roundRect">
+            <a:avLst>
+              <a:gd name="adj" fmla="val 5000"/>
+            </a:avLst>
+          </a:prstGeom>
+          <a:solidFill>
+            <a:srgbClr val="F6F8FA"/>
+          </a:solidFill>
+          <a:ln w="9525">
+            <a:solidFill>
+              <a:srgbClr val="D0D7DE"/>
+            </a:solidFill>
+          </a:ln>
+        </p:spPr>
+        <p:txBody>
+          <a:bodyPr wrap="none" lIns="109728" tIns="73152" rIns="109728" bIns="54864" anchor="t">
+            <a:noAutofit/>
+          </a:bodyPr>
+          <a:lstStyle/>
+          <a:p>
+            <a:pPr>
+              <a:lnSpc>
+                <a:spcPts val="1450"/>
+              </a:lnSpc>
+              <a:spcBef>
+                <a:spcPts val="0"/>
+              </a:spcBef>
+            </a:pPr>
+            <a:r>
+              <a:rPr lang="en-US" sz="1300" b="1" i="0" dirty="0">
+                <a:solidFill>
+                  <a:srgbClr val="0B6E4F"/>
+                </a:solidFill>
+                <a:latin typeface="Consolas"/>
+                <a:cs typeface="Consolas"/>
+              </a:rPr>
+              <a:t xml:space="preserve">ObjectProperty:</a:t>
+            </a:r>
+            <a:r>
+              <a:rPr lang="en-US" sz="1300" b="0" i="0" dirty="0">
+                <a:solidFill>
+                  <a:srgbClr val="1F2328"/>
+                </a:solidFill>
+                <a:latin typeface="Consolas"/>
+                <a:cs typeface="Consolas"/>
+              </a:rPr>
+              <a:t xml:space="preserve"> </a:t>
+            </a:r>
+            <a:r>
+              <a:rPr lang="en-US" sz="1300" b="0" i="0" dirty="0">
+                <a:solidFill>
+                  <a:srgbClr val="1F2328"/>
+                </a:solidFill>
+                <a:latin typeface="Consolas"/>
+                <a:cs typeface="Consolas"/>
+              </a:rPr>
+              <a:t xml:space="preserve">hasPatientData</a:t>
+            </a:r>
+            <a:endParaRPr lang="en-US" sz="1300"/>
+          </a:p>
+          <a:p>
+            <a:pPr>
+              <a:lnSpc>
+                <a:spcPts val="1450"/>
+              </a:lnSpc>
+              <a:spcBef>
+                <a:spcPts val="0"/>
+              </a:spcBef>
+            </a:pPr>
+            <a:r>
+              <a:rPr lang="en-US" sz="1300" b="0" i="0" dirty="0">
+                <a:solidFill>
+                  <a:srgbClr val="1F2328"/>
+                </a:solidFill>
+                <a:latin typeface="Consolas"/>
+                <a:cs typeface="Consolas"/>
+              </a:rPr>
+              <a:t xml:space="preserve">  </a:t>
+            </a:r>
+            <a:r>
+              <a:rPr lang="en-US" sz="1300" b="1" i="0" dirty="0">
+                <a:solidFill>
+                  <a:srgbClr val="0B6E4F"/>
+                </a:solidFill>
+                <a:latin typeface="Consolas"/>
+                <a:cs typeface="Consolas"/>
+              </a:rPr>
+              <a:t xml:space="preserve">Domain:</a:t>
+            </a:r>
+            <a:r>
+              <a:rPr lang="en-US" sz="1300" b="0" i="0" dirty="0">
+                <a:solidFill>
+                  <a:srgbClr val="1F2328"/>
+                </a:solidFill>
+                <a:latin typeface="Consolas"/>
+                <a:cs typeface="Consolas"/>
+              </a:rPr>
+              <a:t xml:space="preserve"> </a:t>
+            </a:r>
+            <a:r>
+              <a:rPr lang="en-US" sz="1300" b="0" i="0" dirty="0">
+                <a:solidFill>
+                  <a:srgbClr val="1F2328"/>
+                </a:solidFill>
+                <a:latin typeface="Consolas"/>
+                <a:cs typeface="Consolas"/>
+              </a:rPr>
+              <a:t xml:space="preserve">Admission</a:t>
+            </a:r>
+            <a:r>
+              <a:rPr lang="en-US" sz="1300" b="0" i="0" dirty="0">
+                <a:solidFill>
+                  <a:srgbClr val="1F2328"/>
+                </a:solidFill>
+                <a:latin typeface="Consolas"/>
+                <a:cs typeface="Consolas"/>
+              </a:rPr>
+              <a:t xml:space="preserve">  </a:t>
+            </a:r>
+            <a:r>
+              <a:rPr lang="en-US" sz="1300" b="1" i="0" dirty="0">
+                <a:solidFill>
+                  <a:srgbClr val="0B6E4F"/>
+                </a:solidFill>
+                <a:latin typeface="Consolas"/>
+                <a:cs typeface="Consolas"/>
+              </a:rPr>
+              <a:t xml:space="preserve">Range:</a:t>
+            </a:r>
+            <a:r>
+              <a:rPr lang="en-US" sz="1300" b="0" i="0" dirty="0">
+                <a:solidFill>
+                  <a:srgbClr val="1F2328"/>
+                </a:solidFill>
+                <a:latin typeface="Consolas"/>
+                <a:cs typeface="Consolas"/>
+              </a:rPr>
+              <a:t xml:space="preserve"> </a:t>
+            </a:r>
+            <a:r>
+              <a:rPr lang="en-US" sz="1300" b="0" i="0" dirty="0">
+                <a:solidFill>
+                  <a:srgbClr val="1F2328"/>
+                </a:solidFill>
+                <a:latin typeface="Consolas"/>
+                <a:cs typeface="Consolas"/>
+              </a:rPr>
+              <a:t xml:space="preserve">PatientData</a:t>
+            </a:r>
+            <a:endParaRPr lang="en-US" sz="1300"/>
+          </a:p>
+          <a:p>
+            <a:pPr>
+              <a:lnSpc>
+                <a:spcPts val="1450"/>
+              </a:lnSpc>
+              <a:spcBef>
+                <a:spcPts val="0"/>
+              </a:spcBef>
+            </a:pPr>
+            <a:r>
+              <a:rPr lang="en-US" sz="1300" b="1" i="0" dirty="0">
+                <a:solidFill>
+                  <a:srgbClr val="0B6E4F"/>
+                </a:solidFill>
+                <a:latin typeface="Consolas"/>
+                <a:cs typeface="Consolas"/>
+              </a:rPr>
+              <a:t xml:space="preserve">DataProperty:</a:t>
+            </a:r>
+            <a:r>
+              <a:rPr lang="en-US" sz="1300" b="0" i="0" dirty="0">
+                <a:solidFill>
+                  <a:srgbClr val="1F2328"/>
+                </a:solidFill>
+                <a:latin typeface="Consolas"/>
+                <a:cs typeface="Consolas"/>
+              </a:rPr>
+              <a:t xml:space="preserve"> </a:t>
+            </a:r>
+            <a:r>
+              <a:rPr lang="en-US" sz="1300" b="0" i="0" dirty="0">
+                <a:solidFill>
+                  <a:srgbClr val="1F2328"/>
+                </a:solidFill>
+                <a:latin typeface="Consolas"/>
+                <a:cs typeface="Consolas"/>
+              </a:rPr>
+              <a:t xml:space="preserve">BM_DEP</a:t>
+            </a:r>
+            <a:endParaRPr lang="en-US" sz="1300"/>
+          </a:p>
+          <a:p>
+            <a:pPr>
+              <a:lnSpc>
+                <a:spcPts val="1450"/>
+              </a:lnSpc>
+              <a:spcBef>
+                <a:spcPts val="0"/>
+              </a:spcBef>
+            </a:pPr>
+            <a:r>
+              <a:rPr lang="en-US" sz="1300" b="0" i="0" dirty="0">
+                <a:solidFill>
+                  <a:srgbClr val="1F2328"/>
+                </a:solidFill>
+                <a:latin typeface="Consolas"/>
+                <a:cs typeface="Consolas"/>
+              </a:rPr>
+              <a:t xml:space="preserve">  </a:t>
+            </a:r>
+            <a:r>
+              <a:rPr lang="en-US" sz="1300" b="1" i="0" dirty="0">
+                <a:solidFill>
+                  <a:srgbClr val="0B6E4F"/>
+                </a:solidFill>
+                <a:latin typeface="Consolas"/>
+                <a:cs typeface="Consolas"/>
+              </a:rPr>
+              <a:t xml:space="preserve">Annotations:</a:t>
+            </a:r>
+            <a:r>
+              <a:rPr lang="en-US" sz="1300" b="0" i="0" dirty="0">
+                <a:solidFill>
+                  <a:srgbClr val="1F2328"/>
+                </a:solidFill>
+                <a:latin typeface="Consolas"/>
+                <a:cs typeface="Consolas"/>
+              </a:rPr>
+              <a:t xml:space="preserve"> </a:t>
+            </a:r>
+            <a:r>
+              <a:rPr lang="en-US" sz="1300" b="0" i="0" dirty="0">
+                <a:solidFill>
+                  <a:srgbClr val="5B6770"/>
+                </a:solidFill>
+                <a:latin typeface="Consolas"/>
+                <a:cs typeface="Consolas"/>
+              </a:rPr>
+              <a:t xml:space="preserve">rdfs:label</a:t>
+            </a:r>
+            <a:r>
+              <a:rPr lang="en-US" sz="1300" b="0" i="0" dirty="0">
+                <a:solidFill>
+                  <a:srgbClr val="1F2328"/>
+                </a:solidFill>
+                <a:latin typeface="Consolas"/>
+                <a:cs typeface="Consolas"/>
+              </a:rPr>
+              <a:t xml:space="preserve"> </a:t>
+            </a:r>
+            <a:r>
+              <a:rPr lang="en-US" sz="1300" b="0" i="0" dirty="0">
+                <a:solidFill>
+                  <a:srgbClr val="A3401E"/>
+                </a:solidFill>
+                <a:latin typeface="Consolas"/>
+                <a:cs typeface="Consolas"/>
+              </a:rPr>
+              <a:t xml:space="preserve">"Bone Marrow Depression"@en</a:t>
+            </a:r>
+            <a:endParaRPr lang="en-US" sz="1300"/>
+          </a:p>
+          <a:p>
+            <a:pPr>
+              <a:lnSpc>
+                <a:spcPts val="1450"/>
+              </a:lnSpc>
+              <a:spcBef>
+                <a:spcPts val="0"/>
+              </a:spcBef>
+            </a:pPr>
+            <a:r>
+              <a:rPr lang="en-US" sz="1300" b="1" i="0" dirty="0">
+                <a:solidFill>
+                  <a:srgbClr val="0B6E4F"/>
+                </a:solidFill>
+                <a:latin typeface="Consolas"/>
+                <a:cs typeface="Consolas"/>
+              </a:rPr>
+              <a:t xml:space="preserve">DataProperty:</a:t>
+            </a:r>
+            <a:r>
+              <a:rPr lang="en-US" sz="1300" b="0" i="0" dirty="0">
+                <a:solidFill>
+                  <a:srgbClr val="1F2328"/>
+                </a:solidFill>
+                <a:latin typeface="Consolas"/>
+                <a:cs typeface="Consolas"/>
+              </a:rPr>
+              <a:t xml:space="preserve"> </a:t>
+            </a:r>
+            <a:r>
+              <a:rPr lang="en-US" sz="1300" b="0" i="0" dirty="0">
+                <a:solidFill>
+                  <a:srgbClr val="1F2328"/>
+                </a:solidFill>
+                <a:latin typeface="Consolas"/>
+                <a:cs typeface="Consolas"/>
+              </a:rPr>
+              <a:t xml:space="preserve">ecog_stage</a:t>
+            </a:r>
+            <a:endParaRPr lang="en-US" sz="1300"/>
+          </a:p>
+          <a:p>
+            <a:pPr>
+              <a:lnSpc>
+                <a:spcPts val="1450"/>
+              </a:lnSpc>
+              <a:spcBef>
+                <a:spcPts val="0"/>
+              </a:spcBef>
+            </a:pPr>
+            <a:r>
+              <a:rPr lang="en-US" sz="1300" b="0" i="0" dirty="0">
+                <a:solidFill>
+                  <a:srgbClr val="1F2328"/>
+                </a:solidFill>
+                <a:latin typeface="Consolas"/>
+                <a:cs typeface="Consolas"/>
+              </a:rPr>
+              <a:t xml:space="preserve">  </a:t>
+            </a:r>
+            <a:r>
+              <a:rPr lang="en-US" sz="1300" b="1" i="0" dirty="0">
+                <a:solidFill>
+                  <a:srgbClr val="0B6E4F"/>
+                </a:solidFill>
+                <a:latin typeface="Consolas"/>
+                <a:cs typeface="Consolas"/>
+              </a:rPr>
+              <a:t xml:space="preserve">Annotations:</a:t>
+            </a:r>
+            <a:endParaRPr lang="en-US" sz="1300"/>
+          </a:p>
+          <a:p>
+            <a:pPr>
+              <a:lnSpc>
+                <a:spcPts val="1450"/>
+              </a:lnSpc>
+              <a:spcBef>
+                <a:spcPts val="0"/>
+              </a:spcBef>
+            </a:pPr>
+            <a:r>
+              <a:rPr lang="en-US" sz="1300" b="0" i="0" dirty="0">
+                <a:solidFill>
+                  <a:srgbClr val="1F2328"/>
+                </a:solidFill>
+                <a:latin typeface="Consolas"/>
+                <a:cs typeface="Consolas"/>
+              </a:rPr>
+              <a:t xml:space="preserve">    </a:t>
+            </a:r>
+            <a:r>
+              <a:rPr lang="en-US" sz="1300" b="0" i="0" dirty="0">
+                <a:solidFill>
+                  <a:srgbClr val="5B6770"/>
+                </a:solidFill>
+                <a:latin typeface="Consolas"/>
+                <a:cs typeface="Consolas"/>
+              </a:rPr>
+              <a:t xml:space="preserve">rdfs:comment</a:t>
+            </a:r>
+            <a:r>
+              <a:rPr lang="en-US" sz="1300" b="0" i="0" dirty="0">
+                <a:solidFill>
+                  <a:srgbClr val="1F2328"/>
+                </a:solidFill>
+                <a:latin typeface="Consolas"/>
+                <a:cs typeface="Consolas"/>
+              </a:rPr>
+              <a:t xml:space="preserve"> </a:t>
+            </a:r>
+            <a:r>
+              <a:rPr lang="en-US" sz="1300" b="0" i="0" dirty="0">
+                <a:solidFill>
+                  <a:srgbClr val="A3401E"/>
+                </a:solidFill>
+                <a:latin typeface="Consolas"/>
+                <a:cs typeface="Consolas"/>
+              </a:rPr>
+              <a:t xml:space="preserve">"ECOG 0 = fully active,</a:t>
+            </a:r>
+            <a:endParaRPr lang="en-US" sz="1300"/>
+          </a:p>
+          <a:p>
+            <a:pPr>
+              <a:lnSpc>
+                <a:spcPts val="1450"/>
+              </a:lnSpc>
+              <a:spcBef>
+                <a:spcPts val="0"/>
+              </a:spcBef>
+            </a:pPr>
+            <a:r>
+              <a:rPr lang="en-US" sz="1300" b="0" i="0" dirty="0">
+                <a:solidFill>
+                  <a:srgbClr val="A3401E"/>
+                </a:solidFill>
+                <a:latin typeface="Consolas"/>
+                <a:cs typeface="Consolas"/>
+              </a:rPr>
+              <a:t xml:space="preserve">      1 = restricted, 2 = ambulatory,</a:t>
+            </a:r>
+            <a:endParaRPr lang="en-US" sz="1300"/>
+          </a:p>
+          <a:p>
+            <a:pPr>
+              <a:lnSpc>
+                <a:spcPts val="1450"/>
+              </a:lnSpc>
+              <a:spcBef>
+                <a:spcPts val="0"/>
+              </a:spcBef>
+            </a:pPr>
+            <a:r>
+              <a:rPr lang="en-US" sz="1300" b="0" i="0" dirty="0">
+                <a:solidFill>
+                  <a:srgbClr val="A3401E"/>
+                </a:solidFill>
+                <a:latin typeface="Consolas"/>
+                <a:cs typeface="Consolas"/>
+              </a:rPr>
+              <a:t xml:space="preserve">      3 = limited self-care,</a:t>
+            </a:r>
+            <a:endParaRPr lang="en-US" sz="1300"/>
+          </a:p>
+          <a:p>
+            <a:pPr>
+              <a:lnSpc>
+                <a:spcPts val="1450"/>
+              </a:lnSpc>
+              <a:spcBef>
+                <a:spcPts val="0"/>
+              </a:spcBef>
+            </a:pPr>
+            <a:r>
+              <a:rPr lang="en-US" sz="1300" b="0" i="0" dirty="0">
+                <a:solidFill>
+                  <a:srgbClr val="A3401E"/>
+                </a:solidFill>
+                <a:latin typeface="Consolas"/>
+                <a:cs typeface="Consolas"/>
+              </a:rPr>
+              <a:t xml:space="preserve">      4 = completely disabled, 5 = dead"@en</a:t>
+            </a:r>
+            <a:r>
+              <a:rPr lang="en-US" sz="1300" b="0" i="0" dirty="0">
+                <a:solidFill>
+                  <a:srgbClr val="1F2328"/>
+                </a:solidFill>
+                <a:latin typeface="Consolas"/>
+                <a:cs typeface="Consolas"/>
+              </a:rPr>
+              <a:t xml:space="preserve">,</a:t>
+            </a:r>
+            <a:endParaRPr lang="en-US" sz="1300"/>
+          </a:p>
+          <a:p>
+            <a:pPr>
+              <a:lnSpc>
+                <a:spcPts val="1450"/>
+              </a:lnSpc>
+              <a:spcBef>
+                <a:spcPts val="0"/>
+              </a:spcBef>
+            </a:pPr>
+            <a:r>
+              <a:rPr lang="en-US" sz="1300" b="0" i="0" dirty="0">
+                <a:solidFill>
+                  <a:srgbClr val="1F2328"/>
+                </a:solidFill>
+                <a:latin typeface="Consolas"/>
+                <a:cs typeface="Consolas"/>
+              </a:rPr>
+              <a:t xml:space="preserve">    </a:t>
+            </a:r>
+            <a:r>
+              <a:rPr lang="en-US" sz="1300" b="0" i="0" dirty="0">
+                <a:solidFill>
+                  <a:srgbClr val="5B6770"/>
+                </a:solidFill>
+                <a:latin typeface="Consolas"/>
+                <a:cs typeface="Consolas"/>
+              </a:rPr>
+              <a:t xml:space="preserve">prov:wasDerivedFrom</a:t>
+            </a:r>
+            <a:r>
+              <a:rPr lang="en-US" sz="1300" b="0" i="0" dirty="0">
+                <a:solidFill>
+                  <a:srgbClr val="1F2328"/>
+                </a:solidFill>
+                <a:latin typeface="Consolas"/>
+                <a:cs typeface="Consolas"/>
+              </a:rPr>
+              <a:t xml:space="preserve"> </a:t>
+            </a:r>
+            <a:r>
+              <a:rPr lang="en-US" sz="1300" b="0" i="0" dirty="0">
+                <a:solidFill>
+                  <a:srgbClr val="2F6B78"/>
+                </a:solidFill>
+                <a:latin typeface="Consolas"/>
+                <a:cs typeface="Consolas"/>
+              </a:rPr>
+              <a:t xml:space="preserve">src:ecog_stage</a:t>
+            </a:r>
+            <a:endParaRPr lang="en-US" sz="1300"/>
+          </a:p>
+        </p:txBody>
+      </p:sp>
+      <p:sp>
+        <p:nvSpPr>
+          <p:cNvPr id="372" name="Rounded Rectangle 371"/>
           <p:cNvSpPr/>
           <p:nvPr/>
         </p:nvSpPr>
         <p:spPr>
           <a:xfrm>
-            <a:off x="4937760" y="2697480"/>
-            <a:ext cx="6117336" cy="9144"/>
-          </a:xfrm>
-          <a:prstGeom prst="rect">
+            <a:off x="10104120" y="2789555"/>
+            <a:ext cx="914400" cy="201168"/>
+          </a:xfrm>
+          <a:prstGeom prst="roundRect">
             <a:avLst/>
           </a:prstGeom>
           <a:solidFill>
-            <a:srgbClr val="D3DAD6"/>
+            <a:srgbClr val="FFFFFF"/>
           </a:solidFill>
-          <a:ln>
-            <a:noFill/>
+          <a:ln w="11430">
+            <a:solidFill>
+              <a:srgbClr val="3A7D8C"/>
+            </a:solidFill>
           </a:ln>
         </p:spPr>
         <p:style>
@@ -55169,158 +56197,43 @@
           </a:fontRef>
         </p:style>
         <p:txBody>
-          <a:bodyPr rtlCol="0" anchor="ctr"/>
+          <a:bodyPr rtlCol="0" anchor="ctr" lIns="0" rIns="0" tIns="0" bIns="0"/>
           <a:lstStyle/>
           <a:p>
             <a:pPr algn="ctr"/>
-          </a:p>
-        </p:txBody>
-      </p:sp>
-      <p:sp>
-        <p:nvSpPr>
-          <p:cNvPr id="366" name="TextBox 365"/>
-          <p:cNvSpPr txBox="1"/>
-          <p:nvPr/>
-        </p:nvSpPr>
-        <p:spPr>
-          <a:xfrm>
-            <a:off x="4956048" y="2788920"/>
-            <a:ext cx="1234440" cy="173736"/>
-          </a:xfrm>
-          <a:prstGeom prst="rect">
-            <a:avLst/>
-          </a:prstGeom>
-          <a:noFill/>
-        </p:spPr>
-        <p:txBody>
-          <a:bodyPr wrap="square" lIns="0" rIns="0" tIns="0" bIns="0" anchor="ctr">
-            <a:spAutoFit/>
-          </a:bodyPr>
-          <a:lstStyle/>
-          <a:p>
-            <a:pPr algn="l">
-              <a:spcBef>
-                <a:spcPts val="0"/>
-              </a:spcBef>
-              <a:spcAft>
-                <a:spcPts val="0"/>
-              </a:spcAft>
-            </a:pPr>
-            <a:r>
-              <a:rPr sz="1010" b="1">
-                <a:solidFill>
-                  <a:srgbClr val="3A434C"/>
+            <a:r>
+              <a:rPr sz="980" b="1">
+                <a:solidFill>
+                  <a:srgbClr val="2F6B78"/>
                 </a:solidFill>
                 <a:latin typeface="Consolas"/>
               </a:rPr>
-              <a:t>ONTOLOGY TERM</a:t>
-            </a:r>
-          </a:p>
-        </p:txBody>
-      </p:sp>
-      <p:sp>
-        <p:nvSpPr>
-          <p:cNvPr id="367" name="TextBox 366"/>
-          <p:cNvSpPr txBox="1"/>
-          <p:nvPr/>
-        </p:nvSpPr>
-        <p:spPr>
-          <a:xfrm>
-            <a:off x="6455664" y="2788920"/>
-            <a:ext cx="3410712" cy="173736"/>
-          </a:xfrm>
-          <a:prstGeom prst="rect">
-            <a:avLst/>
-          </a:prstGeom>
-          <a:noFill/>
-        </p:spPr>
-        <p:txBody>
-          <a:bodyPr wrap="square" lIns="0" rIns="0" tIns="0" bIns="0" anchor="ctr">
-            <a:spAutoFit/>
-          </a:bodyPr>
-          <a:lstStyle/>
-          <a:p>
-            <a:pPr algn="l">
-              <a:spcBef>
-                <a:spcPts val="0"/>
-              </a:spcBef>
-              <a:spcAft>
-                <a:spcPts val="0"/>
-              </a:spcAft>
-            </a:pPr>
-            <a:r>
-              <a:rPr sz="1010" b="1">
-                <a:solidFill>
-                  <a:srgbClr val="3A434C"/>
-                </a:solidFill>
-                <a:latin typeface="Consolas"/>
-              </a:rPr>
-              <a:t>GENERATED STATEMENT</a:t>
-            </a:r>
-          </a:p>
-        </p:txBody>
-      </p:sp>
-      <p:sp>
-        <p:nvSpPr>
-          <p:cNvPr id="368" name="TextBox 367"/>
-          <p:cNvSpPr txBox="1"/>
-          <p:nvPr/>
-        </p:nvSpPr>
-        <p:spPr>
-          <a:xfrm>
-            <a:off x="9994392" y="2788920"/>
-            <a:ext cx="1033271" cy="173736"/>
-          </a:xfrm>
-          <a:prstGeom prst="rect">
-            <a:avLst/>
-          </a:prstGeom>
-          <a:noFill/>
-        </p:spPr>
-        <p:txBody>
-          <a:bodyPr wrap="square" lIns="0" rIns="0" tIns="0" bIns="0" anchor="ctr">
-            <a:spAutoFit/>
-          </a:bodyPr>
-          <a:lstStyle/>
-          <a:p>
-            <a:pPr algn="l">
-              <a:spcBef>
-                <a:spcPts val="0"/>
-              </a:spcBef>
-              <a:spcAft>
-                <a:spcPts val="0"/>
-              </a:spcAft>
-            </a:pPr>
-            <a:r>
-              <a:rPr sz="1010" b="1">
-                <a:solidFill>
-                  <a:srgbClr val="3A434C"/>
-                </a:solidFill>
-                <a:latin typeface="Consolas"/>
-              </a:rPr>
-              <a:t>EVIDENCE</a:t>
-            </a:r>
-          </a:p>
-        </p:txBody>
-      </p:sp>
-      <p:sp>
-        <p:nvSpPr>
-          <p:cNvPr id="369" name="Rectangle 368"/>
+              <a:t>SCHEMA</a:t>
+            </a:r>
+          </a:p>
+        </p:txBody>
+      </p:sp>
+      <p:sp>
+        <p:nvSpPr>
+          <p:cNvPr id="376" name="Rounded Rectangle 375"/>
           <p:cNvSpPr/>
           <p:nvPr/>
         </p:nvSpPr>
         <p:spPr>
           <a:xfrm>
-            <a:off x="4937760" y="2999232"/>
-            <a:ext cx="6117336" cy="9144"/>
-          </a:xfrm>
-          <a:prstGeom prst="rect">
+            <a:off x="10104120" y="3342005"/>
+            <a:ext cx="914400" cy="201168"/>
+          </a:xfrm>
+          <a:prstGeom prst="roundRect">
             <a:avLst/>
           </a:prstGeom>
           <a:solidFill>
-            <a:srgbClr val="D3DAD6"/>
+            <a:srgbClr val="FFFFFF"/>
           </a:solidFill>
-          <a:ln>
-            <a:noFill/>
+          <a:ln w="11430">
+            <a:solidFill>
+              <a:srgbClr val="0B6E4F"/>
+            </a:solidFill>
           </a:ln>
         </p:spPr>
         <p:style>
@@ -55338,107 +56251,32 @@
           </a:fontRef>
         </p:style>
         <p:txBody>
-          <a:bodyPr rtlCol="0" anchor="ctr"/>
+          <a:bodyPr rtlCol="0" anchor="ctr" lIns="0" rIns="0" tIns="0" bIns="0"/>
           <a:lstStyle/>
           <a:p>
             <a:pPr algn="ctr"/>
-          </a:p>
-        </p:txBody>
-      </p:sp>
-      <p:sp>
-        <p:nvSpPr>
-          <p:cNvPr id="370" name="TextBox 369"/>
-          <p:cNvSpPr txBox="1"/>
-          <p:nvPr/>
-        </p:nvSpPr>
-        <p:spPr>
-          <a:xfrm>
-            <a:off x="4965192" y="3072384"/>
-            <a:ext cx="1399032" cy="320040"/>
-          </a:xfrm>
-          <a:prstGeom prst="rect">
-            <a:avLst/>
-          </a:prstGeom>
-          <a:noFill/>
-        </p:spPr>
-        <p:txBody>
-          <a:bodyPr wrap="square" lIns="0" rIns="0" tIns="0" bIns="0" anchor="ctr">
-            <a:spAutoFit/>
-          </a:bodyPr>
-          <a:lstStyle/>
-          <a:p>
-            <a:pPr algn="l">
-              <a:spcBef>
-                <a:spcPts val="0"/>
-              </a:spcBef>
-              <a:spcAft>
-                <a:spcPts val="0"/>
-              </a:spcAft>
-            </a:pPr>
-            <a:r>
-              <a:rPr sz="1240" b="1">
-                <a:solidFill>
-                  <a:srgbClr val="2F6B78"/>
+            <a:r>
+              <a:rPr sz="980" b="1">
+                <a:solidFill>
+                  <a:srgbClr val="0B6E4F"/>
                 </a:solidFill>
                 <a:latin typeface="Consolas"/>
               </a:rPr>
-              <a:t>hasPatientData</a:t>
-            </a:r>
-          </a:p>
-        </p:txBody>
-      </p:sp>
-      <p:sp>
-        <p:nvSpPr>
-          <p:cNvPr id="371" name="TextBox 370"/>
-          <p:cNvSpPr txBox="1"/>
-          <p:nvPr/>
-        </p:nvSpPr>
-        <p:spPr>
-          <a:xfrm>
-            <a:off x="6455664" y="3044952"/>
-            <a:ext cx="3383280" cy="374904"/>
-          </a:xfrm>
-          <a:prstGeom prst="rect">
-            <a:avLst/>
-          </a:prstGeom>
-          <a:noFill/>
-        </p:spPr>
-        <p:txBody>
-          <a:bodyPr wrap="square" lIns="0" rIns="0" tIns="0" bIns="0" anchor="ctr">
-            <a:spAutoFit/>
-          </a:bodyPr>
-          <a:lstStyle/>
-          <a:p>
-            <a:pPr algn="l">
-              <a:spcBef>
-                <a:spcPts val="0"/>
-              </a:spcBef>
-              <a:spcAft>
-                <a:spcPts val="0"/>
-              </a:spcAft>
-            </a:pPr>
-            <a:r>
-              <a:rPr sz="1250" b="0">
-                <a:solidFill>
-                  <a:srgbClr val="1F2328"/>
-                </a:solidFill>
-                <a:latin typeface="Calibri"/>
-              </a:rPr>
-              <a:t>ObjectProperty: Admission → PatientData</a:t>
-            </a:r>
-          </a:p>
-        </p:txBody>
-      </p:sp>
-      <p:sp>
-        <p:nvSpPr>
-          <p:cNvPr id="372" name="Rounded Rectangle 371"/>
+              <a:t>DOCS</a:t>
+            </a:r>
+          </a:p>
+        </p:txBody>
+      </p:sp>
+      <p:sp>
+        <p:nvSpPr>
+          <p:cNvPr id="380" name="Rounded Rectangle 379"/>
           <p:cNvSpPr/>
           <p:nvPr/>
         </p:nvSpPr>
         <p:spPr>
           <a:xfrm>
-            <a:off x="9994392" y="3081528"/>
-            <a:ext cx="1051560" cy="283464"/>
+            <a:off x="10104120" y="3894455"/>
+            <a:ext cx="914400" cy="201168"/>
           </a:xfrm>
           <a:prstGeom prst="roundRect">
             <a:avLst/>
@@ -55448,7 +56286,7 @@
           </a:solidFill>
           <a:ln w="11430">
             <a:solidFill>
-              <a:srgbClr val="3A7D8C"/>
+              <a:srgbClr val="0B6E4F"/>
             </a:solidFill>
           </a:ln>
         </p:spPr>
@@ -55474,519 +56312,11 @@
             <a:r>
               <a:rPr sz="980" b="1">
                 <a:solidFill>
-                  <a:srgbClr val="2F6B78"/>
+                  <a:srgbClr val="0B6E4F"/>
                 </a:solidFill>
                 <a:latin typeface="Consolas"/>
               </a:rPr>
-              <a:t>SCHEMA</a:t>
-            </a:r>
-          </a:p>
-        </p:txBody>
-      </p:sp>
-      <p:sp>
-        <p:nvSpPr>
-          <p:cNvPr id="373" name="Rectangle 372"/>
-          <p:cNvSpPr/>
-          <p:nvPr/>
-        </p:nvSpPr>
-        <p:spPr>
-          <a:xfrm>
-            <a:off x="4937760" y="3465576"/>
-            <a:ext cx="6117336" cy="9144"/>
-          </a:xfrm>
-          <a:prstGeom prst="rect">
-            <a:avLst/>
-          </a:prstGeom>
-          <a:solidFill>
-            <a:srgbClr val="D3DAD6"/>
-          </a:solidFill>
-          <a:ln>
-            <a:noFill/>
-          </a:ln>
-        </p:spPr>
-        <p:style>
-          <a:lnRef idx="1">
-            <a:schemeClr val="accent1"/>
-          </a:lnRef>
-          <a:fillRef idx="3">
-            <a:schemeClr val="accent1"/>
-          </a:fillRef>
-          <a:effectRef idx="2">
-            <a:schemeClr val="accent1"/>
-          </a:effectRef>
-          <a:fontRef idx="minor">
-            <a:schemeClr val="lt1"/>
-          </a:fontRef>
-        </p:style>
-        <p:txBody>
-          <a:bodyPr rtlCol="0" anchor="ctr"/>
-          <a:lstStyle/>
-          <a:p>
-            <a:pPr algn="ctr"/>
-          </a:p>
-        </p:txBody>
-      </p:sp>
-      <p:sp>
-        <p:nvSpPr>
-          <p:cNvPr id="374" name="TextBox 373"/>
-          <p:cNvSpPr txBox="1"/>
-          <p:nvPr/>
-        </p:nvSpPr>
-        <p:spPr>
-          <a:xfrm>
-            <a:off x="4965192" y="3547872"/>
-            <a:ext cx="1371600" cy="274320"/>
-          </a:xfrm>
-          <a:prstGeom prst="rect">
-            <a:avLst/>
-          </a:prstGeom>
-          <a:noFill/>
-        </p:spPr>
-        <p:txBody>
-          <a:bodyPr wrap="square" lIns="0" rIns="0" tIns="0" bIns="0" anchor="ctr">
-            <a:spAutoFit/>
-          </a:bodyPr>
-          <a:lstStyle/>
-          <a:p>
-            <a:pPr algn="l">
-              <a:spcBef>
-                <a:spcPts val="0"/>
-              </a:spcBef>
-              <a:spcAft>
-                <a:spcPts val="0"/>
-              </a:spcAft>
-            </a:pPr>
-            <a:r>
-              <a:rPr sz="1340" b="1">
-                <a:solidFill>
-                  <a:srgbClr val="2F6B78"/>
-                </a:solidFill>
-                <a:latin typeface="Consolas"/>
-              </a:rPr>
-              <a:t>BM_DEP</a:t>
-            </a:r>
-          </a:p>
-        </p:txBody>
-      </p:sp>
-      <p:sp>
-        <p:nvSpPr>
-          <p:cNvPr id="375" name="TextBox 374"/>
-          <p:cNvSpPr txBox="1"/>
-          <p:nvPr/>
-        </p:nvSpPr>
-        <p:spPr>
-          <a:xfrm>
-            <a:off x="6455664" y="3511296"/>
-            <a:ext cx="3410712" cy="365760"/>
-          </a:xfrm>
-          <a:prstGeom prst="rect">
-            <a:avLst/>
-          </a:prstGeom>
-          <a:noFill/>
-        </p:spPr>
-        <p:txBody>
-          <a:bodyPr wrap="square" lIns="0" rIns="0" tIns="0" bIns="0" anchor="ctr">
-            <a:spAutoFit/>
-          </a:bodyPr>
-          <a:lstStyle/>
-          <a:p>
-            <a:pPr algn="l">
-              <a:spcBef>
-                <a:spcPts val="0"/>
-              </a:spcBef>
-              <a:spcAft>
-                <a:spcPts val="0"/>
-              </a:spcAft>
-            </a:pPr>
-            <a:r>
-              <a:rPr sz="1240" b="0">
-                <a:solidFill>
-                  <a:srgbClr val="1F2328"/>
-                </a:solidFill>
-                <a:latin typeface="Calibri"/>
-              </a:rPr>
-              <a:t>rdfs:label "Bone Marrow Depression"</a:t>
-            </a:r>
-          </a:p>
-        </p:txBody>
-      </p:sp>
-      <p:sp>
-        <p:nvSpPr>
-          <p:cNvPr id="376" name="Rounded Rectangle 375"/>
-          <p:cNvSpPr/>
-          <p:nvPr/>
-        </p:nvSpPr>
-        <p:spPr>
-          <a:xfrm>
-            <a:off x="9994392" y="3538728"/>
-            <a:ext cx="1051560" cy="283464"/>
-          </a:xfrm>
-          <a:prstGeom prst="roundRect">
-            <a:avLst/>
-          </a:prstGeom>
-          <a:solidFill>
-            <a:srgbClr val="FFFFFF"/>
-          </a:solidFill>
-          <a:ln w="11430">
-            <a:solidFill>
-              <a:srgbClr val="0B6E4F"/>
-            </a:solidFill>
-          </a:ln>
-        </p:spPr>
-        <p:style>
-          <a:lnRef idx="1">
-            <a:schemeClr val="accent1"/>
-          </a:lnRef>
-          <a:fillRef idx="3">
-            <a:schemeClr val="accent1"/>
-          </a:fillRef>
-          <a:effectRef idx="2">
-            <a:schemeClr val="accent1"/>
-          </a:effectRef>
-          <a:fontRef idx="minor">
-            <a:schemeClr val="lt1"/>
-          </a:fontRef>
-        </p:style>
-        <p:txBody>
-          <a:bodyPr rtlCol="0" anchor="ctr" lIns="0" rIns="0" tIns="0" bIns="0"/>
-          <a:lstStyle/>
-          <a:p>
-            <a:pPr algn="ctr"/>
-            <a:r>
-              <a:rPr sz="980" b="1">
-                <a:solidFill>
-                  <a:srgbClr val="0B6E4F"/>
-                </a:solidFill>
-                <a:latin typeface="Consolas"/>
-              </a:rPr>
               <a:t>DOCS</a:t>
-            </a:r>
-          </a:p>
-        </p:txBody>
-      </p:sp>
-      <p:sp>
-        <p:nvSpPr>
-          <p:cNvPr id="377" name="Rectangle 376"/>
-          <p:cNvSpPr/>
-          <p:nvPr/>
-        </p:nvSpPr>
-        <p:spPr>
-          <a:xfrm>
-            <a:off x="4937760" y="3922776"/>
-            <a:ext cx="6117336" cy="9144"/>
-          </a:xfrm>
-          <a:prstGeom prst="rect">
-            <a:avLst/>
-          </a:prstGeom>
-          <a:solidFill>
-            <a:srgbClr val="D3DAD6"/>
-          </a:solidFill>
-          <a:ln>
-            <a:noFill/>
-          </a:ln>
-        </p:spPr>
-        <p:style>
-          <a:lnRef idx="1">
-            <a:schemeClr val="accent1"/>
-          </a:lnRef>
-          <a:fillRef idx="3">
-            <a:schemeClr val="accent1"/>
-          </a:fillRef>
-          <a:effectRef idx="2">
-            <a:schemeClr val="accent1"/>
-          </a:effectRef>
-          <a:fontRef idx="minor">
-            <a:schemeClr val="lt1"/>
-          </a:fontRef>
-        </p:style>
-        <p:txBody>
-          <a:bodyPr rtlCol="0" anchor="ctr"/>
-          <a:lstStyle/>
-          <a:p>
-            <a:pPr algn="ctr"/>
-          </a:p>
-        </p:txBody>
-      </p:sp>
-      <p:sp>
-        <p:nvSpPr>
-          <p:cNvPr id="378" name="TextBox 377"/>
-          <p:cNvSpPr txBox="1"/>
-          <p:nvPr/>
-        </p:nvSpPr>
-        <p:spPr>
-          <a:xfrm>
-            <a:off x="4965192" y="4069080"/>
-            <a:ext cx="1371600" cy="320040"/>
-          </a:xfrm>
-          <a:prstGeom prst="rect">
-            <a:avLst/>
-          </a:prstGeom>
-          <a:noFill/>
-        </p:spPr>
-        <p:txBody>
-          <a:bodyPr wrap="square" lIns="0" rIns="0" tIns="0" bIns="0" anchor="ctr">
-            <a:spAutoFit/>
-          </a:bodyPr>
-          <a:lstStyle/>
-          <a:p>
-            <a:pPr algn="l">
-              <a:spcBef>
-                <a:spcPts val="0"/>
-              </a:spcBef>
-              <a:spcAft>
-                <a:spcPts val="0"/>
-              </a:spcAft>
-            </a:pPr>
-            <a:r>
-              <a:rPr sz="1300" b="1">
-                <a:solidFill>
-                  <a:srgbClr val="2F6B78"/>
-                </a:solidFill>
-                <a:latin typeface="Consolas"/>
-              </a:rPr>
-              <a:t>ecog_stage</a:t>
-            </a:r>
-          </a:p>
-        </p:txBody>
-      </p:sp>
-      <p:sp>
-        <p:nvSpPr>
-          <p:cNvPr id="379" name="TextBox 378"/>
-          <p:cNvSpPr txBox="1"/>
-          <p:nvPr/>
-        </p:nvSpPr>
-        <p:spPr>
-          <a:xfrm>
-            <a:off x="6455664" y="3986784"/>
-            <a:ext cx="3401568" cy="758952"/>
-          </a:xfrm>
-          <a:prstGeom prst="rect">
-            <a:avLst/>
-          </a:prstGeom>
-          <a:noFill/>
-        </p:spPr>
-        <p:txBody>
-          <a:bodyPr wrap="square" lIns="0" rIns="0" tIns="0" bIns="0" anchor="ctr">
-            <a:spAutoFit/>
-          </a:bodyPr>
-          <a:lstStyle/>
-          <a:p>
-            <a:pPr algn="l">
-              <a:spcBef>
-                <a:spcPts val="0"/>
-              </a:spcBef>
-              <a:spcAft>
-                <a:spcPts val="0"/>
-              </a:spcAft>
-            </a:pPr>
-            <a:r>
-              <a:rPr sz="1170" b="0">
-                <a:solidFill>
-                  <a:srgbClr val="1F2328"/>
-                </a:solidFill>
-                <a:latin typeface="Calibri"/>
-              </a:rPr>
-              <a:t>rdfs:comment  ECOG 0 = fully active; 1 = limited strenuous activity;</a:t>
-            </a:r>
-          </a:p>
-          <a:p>
-            <a:pPr algn="l">
-              <a:spcBef>
-                <a:spcPts val="0"/>
-              </a:spcBef>
-              <a:spcAft>
-                <a:spcPts val="0"/>
-              </a:spcAft>
-            </a:pPr>
-            <a:r>
-              <a:rPr sz="1170" b="0">
-                <a:solidFill>
-                  <a:srgbClr val="1F2328"/>
-                </a:solidFill>
-                <a:latin typeface="Calibri"/>
-              </a:rPr>
-              <a:t>2 = ambulatory; 3 = limited self-care; 4 = disabled; 5 = dead</a:t>
-            </a:r>
-          </a:p>
-        </p:txBody>
-      </p:sp>
-      <p:sp>
-        <p:nvSpPr>
-          <p:cNvPr id="380" name="Rounded Rectangle 379"/>
-          <p:cNvSpPr/>
-          <p:nvPr/>
-        </p:nvSpPr>
-        <p:spPr>
-          <a:xfrm>
-            <a:off x="9994392" y="4105656"/>
-            <a:ext cx="1051560" cy="283464"/>
-          </a:xfrm>
-          <a:prstGeom prst="roundRect">
-            <a:avLst/>
-          </a:prstGeom>
-          <a:solidFill>
-            <a:srgbClr val="FFFFFF"/>
-          </a:solidFill>
-          <a:ln w="11430">
-            <a:solidFill>
-              <a:srgbClr val="0B6E4F"/>
-            </a:solidFill>
-          </a:ln>
-        </p:spPr>
-        <p:style>
-          <a:lnRef idx="1">
-            <a:schemeClr val="accent1"/>
-          </a:lnRef>
-          <a:fillRef idx="3">
-            <a:schemeClr val="accent1"/>
-          </a:fillRef>
-          <a:effectRef idx="2">
-            <a:schemeClr val="accent1"/>
-          </a:effectRef>
-          <a:fontRef idx="minor">
-            <a:schemeClr val="lt1"/>
-          </a:fontRef>
-        </p:style>
-        <p:txBody>
-          <a:bodyPr rtlCol="0" anchor="ctr" lIns="0" rIns="0" tIns="0" bIns="0"/>
-          <a:lstStyle/>
-          <a:p>
-            <a:pPr algn="ctr"/>
-            <a:r>
-              <a:rPr sz="980" b="1">
-                <a:solidFill>
-                  <a:srgbClr val="0B6E4F"/>
-                </a:solidFill>
-                <a:latin typeface="Consolas"/>
-              </a:rPr>
-              <a:t>DOCS</a:t>
-            </a:r>
-          </a:p>
-        </p:txBody>
-      </p:sp>
-      <p:sp>
-        <p:nvSpPr>
-          <p:cNvPr id="381" name="Rectangle 380"/>
-          <p:cNvSpPr/>
-          <p:nvPr/>
-        </p:nvSpPr>
-        <p:spPr>
-          <a:xfrm>
-            <a:off x="4937760" y="4754880"/>
-            <a:ext cx="6117336" cy="9144"/>
-          </a:xfrm>
-          <a:prstGeom prst="rect">
-            <a:avLst/>
-          </a:prstGeom>
-          <a:solidFill>
-            <a:srgbClr val="D3DAD6"/>
-          </a:solidFill>
-          <a:ln>
-            <a:noFill/>
-          </a:ln>
-        </p:spPr>
-        <p:style>
-          <a:lnRef idx="1">
-            <a:schemeClr val="accent1"/>
-          </a:lnRef>
-          <a:fillRef idx="3">
-            <a:schemeClr val="accent1"/>
-          </a:fillRef>
-          <a:effectRef idx="2">
-            <a:schemeClr val="accent1"/>
-          </a:effectRef>
-          <a:fontRef idx="minor">
-            <a:schemeClr val="lt1"/>
-          </a:fontRef>
-        </p:style>
-        <p:txBody>
-          <a:bodyPr rtlCol="0" anchor="ctr"/>
-          <a:lstStyle/>
-          <a:p>
-            <a:pPr algn="ctr"/>
-          </a:p>
-        </p:txBody>
-      </p:sp>
-      <p:sp>
-        <p:nvSpPr>
-          <p:cNvPr id="382" name="TextBox 381"/>
-          <p:cNvSpPr txBox="1"/>
-          <p:nvPr/>
-        </p:nvSpPr>
-        <p:spPr>
-          <a:xfrm>
-            <a:off x="4965192" y="4846320"/>
-            <a:ext cx="1371600" cy="301752"/>
-          </a:xfrm>
-          <a:prstGeom prst="rect">
-            <a:avLst/>
-          </a:prstGeom>
-          <a:noFill/>
-        </p:spPr>
-        <p:txBody>
-          <a:bodyPr wrap="square" lIns="0" rIns="0" tIns="0" bIns="0" anchor="ctr">
-            <a:spAutoFit/>
-          </a:bodyPr>
-          <a:lstStyle/>
-          <a:p>
-            <a:pPr algn="l">
-              <a:spcBef>
-                <a:spcPts val="0"/>
-              </a:spcBef>
-              <a:spcAft>
-                <a:spcPts val="0"/>
-              </a:spcAft>
-            </a:pPr>
-            <a:r>
-              <a:rPr sz="1300" b="1">
-                <a:solidFill>
-                  <a:srgbClr val="2F6B78"/>
-                </a:solidFill>
-                <a:latin typeface="Consolas"/>
-              </a:rPr>
-              <a:t>ecog_stage</a:t>
-            </a:r>
-          </a:p>
-        </p:txBody>
-      </p:sp>
-      <p:sp>
-        <p:nvSpPr>
-          <p:cNvPr id="383" name="TextBox 382"/>
-          <p:cNvSpPr txBox="1"/>
-          <p:nvPr/>
-        </p:nvSpPr>
-        <p:spPr>
-          <a:xfrm>
-            <a:off x="6455664" y="4809744"/>
-            <a:ext cx="3447288" cy="393192"/>
-          </a:xfrm>
-          <a:prstGeom prst="rect">
-            <a:avLst/>
-          </a:prstGeom>
-          <a:noFill/>
-        </p:spPr>
-        <p:txBody>
-          <a:bodyPr wrap="square" lIns="0" rIns="0" tIns="0" bIns="0" anchor="ctr">
-            <a:spAutoFit/>
-          </a:bodyPr>
-          <a:lstStyle/>
-          <a:p>
-            <a:pPr algn="l">
-              <a:spcBef>
-                <a:spcPts val="0"/>
-              </a:spcBef>
-              <a:spcAft>
-                <a:spcPts val="0"/>
-              </a:spcAft>
-            </a:pPr>
-            <a:r>
-              <a:rPr sz="1200" b="0">
-                <a:solidFill>
-                  <a:srgbClr val="1F2328"/>
-                </a:solidFill>
-                <a:latin typeface="Consolas"/>
-              </a:rPr>
-              <a:t>prov:wasDerivedFrom &lt;…/admission/ecog_stage&gt;</a:t>
             </a:r>
           </a:p>
         </p:txBody>
@@ -55999,8 +56329,8 @@
         </p:nvSpPr>
         <p:spPr>
           <a:xfrm>
-            <a:off x="9994392" y="4855464"/>
-            <a:ext cx="1051560" cy="283464"/>
+            <a:off x="10104120" y="4631055"/>
+            <a:ext cx="914400" cy="201168"/>
           </a:xfrm>
           <a:prstGeom prst="roundRect">
             <a:avLst/>

</xml_diff>

<commit_message>
Phase 4: results as R1 meaning+structure, R2 BURR explained, R3 experts
R1 replaces the pitfall grid with what each method's ontologies contain
(coverage, labels, hierarchy and provenance; Tables 7-9). R2 adds a card
explaining what BURR checks. R3 moves after BURR. The raw OOPS! table is
kept as backup slide B1.

Co-Authored-By: Claude Opus 5.5 <noreply@anthropic.com>
Claude-Session: https://claude.ai/code/session_01KcycczqUBG98FnzsgJYAW8
</commit_message>
<xml_diff>
--- a/presentation/RIGOR_ISWC2026.pptx
+++ b/presentation/RIGOR_ISWC2026.pptx
@@ -26,11 +26,12 @@
     <p:sldId id="271" r:id="rId20"/>
     <p:sldId id="272" r:id="rId21"/>
     <p:sldId id="273" r:id="rId22"/>
-    <p:sldId id="274" r:id="rId23"/>
     <p:sldId id="275" r:id="rId24"/>
     <p:sldId id="276" r:id="rId25"/>
+    <p:sldId id="274" r:id="rId23"/>
     <p:sldId id="277" r:id="rId26"/>
     <p:sldId id="278" r:id="rId27"/>
+    <p:sldId id="279" r:id="rId37"/>
   </p:sldIdLst>
   <p:sldSz cy="6858000" cx="12192000"/>
   <p:notesSz cx="6858000" cy="12192000"/>
@@ -4501,7 +4502,7 @@
                 <a:cs typeface="Calibri"/>
                 <a:sym typeface="Calibri"/>
               </a:rPr>
-              <a:t>First, what do ontology experts think? Ten experts reviewed anonymized outputs for four representative medical tables. They ranked RIGOR first in twenty-eight of forty rankings—seventy percent—with statistically significant agreement across raters. They especially valued domain enrichment, clarity, and completeness. Separately, GPT-5.4 evaluated Claude-generated fragments for all fifty-eight tables, using five competency questions per table, and ranked RIGOR first in all fifty-eight. The human sample is limited, and LLM judgments cannot replace it; together, they offer complementary evidence.</a:t>
+              <a:t>Finally, what do ontology experts think? Ten experts reviewed anonymized outputs for four representative medical tables. They ranked RIGOR first in twenty-eight of forty rankings—seventy percent—with statistically significant agreement across raters. They especially valued domain enrichment, clarity, and completeness. Separately, GPT-5.4 evaluated Claude-generated fragments for all fifty-eight tables, using five competency questions per table, and ranked RIGOR first in all fifty-eight. The human sample is limited, and LLM judgments cannot replace it; together, they offer complementary evidence.</a:t>
             </a:r>
             <a:endParaRPr/>
           </a:p>
@@ -4948,22 +4949,28 @@
           <a:lstStyle/>
           <a:p>
             <a:r>
-              <a:t>[11:02–11:57] SPOKEN SCRIPT</a:t>
-            </a:r>
-          </a:p>
-          <a:p>
-            <a:r>
-              <a:t>The OOPS! pitfall scanner gives us a much broader comparison than a single illustrative case. Here are the three databases, and four methods. For each LLM method, numbers are Claude, Mistral, and DeepSeek. Across every one of the nine matched model-and-database comparisons, RIGOR has fewer findings than the non-iterative approach. On Chinook, it has zero findings with all three models. We should interpret this correctly: a substantial portion of the reduction comes from missing annotations, which RIGOR explicitly adds, and critical P19 findings remain in three runs.</a:t>
-            </a:r>
-          </a:p>
-          <a:p>
-            <a:r>
-              <a:t>PRESENTER CUE: Explain the column convention once, emphasize 9 out of 9, then Chinook; do not read every cell.</a:t>
-            </a:r>
-          </a:p>
-          <a:p>
-            <a:r>
-              <a:t>SOURCE: Paper Table 7, OOPS! findings.</a:t>
+              <a:t>[9:05–10:00]  SPOKEN SCRIPT (interim; final wording in Phase 6)</a:t>
+            </a:r>
+          </a:p>
+          <a:p>
+            <a:r>
+              <a:t>First: does RIGOR really add meaning, and does it keep the schema? This table shows what each method's ontologies contain. Direct mapping keeps the columns but adds no meaning. Single-pass retrieval adds labels, but drops columns: in one run it keeps only six percent of them. RIGOR is the only method that produces class hierarchies and provenance in all nine runs, while keeping 77 to 100 percent of the columns. And its ontologies have the fewest modeling pitfalls in every like-for-like comparison: zero on Chinook.</a:t>
+            </a:r>
+          </a:p>
+          <a:p/>
+          <a:p>
+            <a:r>
+              <a:t>PRESENTER / POINTER: Read across the RIGOR row last. Point at Non-Iterative's 0.06 first.</a:t>
+            </a:r>
+          </a:p>
+          <a:p>
+            <a:r>
+              <a:t>AUDIENCE TAKEAWAY: Only RIGOR adds hierarchy and provenance and still keeps the schema.</a:t>
+            </a:r>
+          </a:p>
+          <a:p>
+            <a:r>
+              <a:t>SOURCE AND SCOPE: Paper Tables 7, 8, 9. Coverage is an embedding-based proxy; Direct Mapping is complete by construction. Disjointness (1/9 runs) is deliberately left for Q&amp;A.</a:t>
             </a:r>
           </a:p>
         </p:txBody>
@@ -5113,28 +5120,28 @@
           <a:lstStyle/>
           <a:p>
             <a:r>
-              <a:t>[11:57–12:52]  SPOKEN SCRIPT</a:t>
-            </a:r>
-          </a:p>
-          <a:p>
-            <a:r>
-              <a:t>Finally, BURR tests mapping fidelity against a gold standard, rather than subjective ontology quality. This is its ISWC database: nine tables, 46 columns, and 11 foreign keys. Here are all the methods compared, by name: W3C-Mapper/Ontop, RDB2Onto, OntoGenix, and RIGOR. For class, relation, and attribute mappings, RIGOR achieves the highest F1: 0.73, 0.67, and 0.52. These mappings are recovered by exporting RIGOR's source-provenance annotations as D2RQ. This is one scenario using Claude, so it does not establish universal superiority, but it supports the claim that semantic enrichment need not destroy schema correspondence.</a:t>
+              <a:t>[10:00–11:05]  SPOKEN SCRIPT (interim; final wording in Phase 6)</a:t>
+            </a:r>
+          </a:p>
+          <a:p>
+            <a:r>
+              <a:t>Second: is that link back to the data real? BURR is an external benchmark that asks exactly this. A system must say which part of the database each ontology element comes from: which table becomes a class, which foreign key becomes a relation, which column becomes an attribute. BURR compares that mapping with a gold-standard mapping and reports F1 for each type. RIGOR's provenance annotations give us this mapping directly; we export them as D2RQ. On the ISWC scenario, RIGOR has the best F1 for classes, relations and attributes. BURR's authors found that LLM methods trail rule-based systems on this task; here RIGOR leads both. It is one scenario, with Claude.</a:t>
             </a:r>
           </a:p>
           <a:p/>
           <a:p>
             <a:r>
-              <a:t>AUDIENCE TAKEAWAY</a:t>
-            </a:r>
-          </a:p>
-          <a:p>
-            <a:r>
-              <a:t>RIGOR leads all three mapping categories among four explicitly named compared systems on the single BURR ISWC scenario.</a:t>
-            </a:r>
-          </a:p>
-          <a:p>
-            <a:r>
-              <a:t>SOURCE: paper Table 13, Strategy 8, §4.6–4.7.</a:t>
+              <a:t>PRESENTER / POINTER: Walk the three mapping rows on the left first, then land on the RIGOR row.</a:t>
+            </a:r>
+          </a:p>
+          <a:p>
+            <a:r>
+              <a:t>AUDIENCE TAKEAWAY: Semantic enrichment did not break the correspondence that OBDA and KG population need.</a:t>
+            </a:r>
+          </a:p>
+          <a:p>
+            <a:r>
+              <a:t>SOURCE AND SCOPE: Paper Table 13, Strategy 8. BURR = Laskowski et al., PACMMOD 2025. Left-card elements are illustrative, not the gold standard's actual names.</a:t>
             </a:r>
           </a:p>
         </p:txBody>
@@ -34363,7 +34370,7 @@
                 <a:cs typeface="Consolas"/>
                 <a:sym typeface="Consolas"/>
               </a:rPr>
-              <a:t>RESULT 1  /  HUMAN AND LLM EVALUATION</a:t>
+              <a:t>RESULT 3  /  HUMAN AND LLM EVALUATION</a:t>
             </a:r>
             <a:endParaRPr/>
           </a:p>
@@ -34416,7 +34423,7 @@
                 <a:cs typeface="Calibri"/>
                 <a:sym typeface="Calibri"/>
               </a:rPr>
-              <a:t>Does the ontology look better to experts?</a:t>
+              <a:t>Experts prefer RIGOR's ontologies.</a:t>
             </a:r>
             <a:endParaRPr/>
           </a:p>
@@ -38073,7 +38080,7 @@
                 </a:solidFill>
                 <a:latin typeface="Consolas"/>
               </a:rPr>
-              <a:t>RESULT 2  /  ONTOLOGY QUALITY</a:t>
+              <a:t>RESULT 1  /  MEANING AND STRUCTURE</a:t>
             </a:r>
           </a:p>
         </p:txBody>
@@ -38108,7 +38115,7 @@
                 </a:solidFill>
                 <a:latin typeface="Cambria"/>
               </a:rPr>
-              <a:t>RIGOR has the fewest modeling pitfalls in all nine comparisons.</a:t>
+              <a:t>Only RIGOR adds meaning without losing structure.</a:t>
             </a:r>
           </a:p>
         </p:txBody>
@@ -38143,7 +38150,7 @@
                 </a:solidFill>
                 <a:latin typeface="Calibri"/>
               </a:rPr>
-              <a:t>OOPS! findings per ontology (lower is better) · Same dataset and generator model in each comparison</a:t>
+              <a:t>What the generated ontologies contain  ·  3 databases × 3 LLMs  ·  Direct Mapping: one ontology per database</a:t>
             </a:r>
           </a:p>
         </p:txBody>
@@ -38217,7 +38224,7 @@
           <a:p>
             <a:pPr algn="l"/>
             <a:r>
-              <a:rPr sz="1500" b="1">
+              <a:rPr sz="1200" b="1">
                 <a:solidFill>
                   <a:srgbClr val="2F6B78"/>
                 </a:solidFill>
@@ -38297,13 +38304,13 @@
           <a:p>
             <a:pPr algn="l"/>
             <a:r>
-              <a:rPr sz="1500" b="1">
+              <a:rPr sz="1200" b="1">
                 <a:solidFill>
                   <a:srgbClr val="2F6B78"/>
                 </a:solidFill>
                 <a:latin typeface="Calibri"/>
               </a:rPr>
-              <a:t>LIVER CANCER</a:t>
+              <a:t>COLUMNS KEPT</a:t>
             </a:r>
           </a:p>
         </p:txBody>
@@ -38338,7 +38345,7 @@
                 </a:solidFill>
                 <a:latin typeface="Calibri"/>
               </a:rPr>
-              <a:t>16 tables</a:t>
+              <a:t>final schema coverage</a:t>
             </a:r>
           </a:p>
         </p:txBody>
@@ -38412,13 +38419,13 @@
           <a:p>
             <a:pPr algn="l"/>
             <a:r>
-              <a:rPr sz="1500" b="1">
+              <a:rPr sz="1200" b="1">
                 <a:solidFill>
                   <a:srgbClr val="2F6B78"/>
                 </a:solidFill>
                 <a:latin typeface="Calibri"/>
               </a:rPr>
-              <a:t>eICU-CRD</a:t>
+              <a:t>LABELS &amp; COMMENTS</a:t>
             </a:r>
           </a:p>
         </p:txBody>
@@ -38453,7 +38460,7 @@
                 </a:solidFill>
                 <a:latin typeface="Calibri"/>
               </a:rPr>
-              <a:t>31 tables</a:t>
+              <a:t>runs that have them</a:t>
             </a:r>
           </a:p>
         </p:txBody>
@@ -38527,13 +38534,13 @@
           <a:p>
             <a:pPr algn="l"/>
             <a:r>
-              <a:rPr sz="1500" b="1">
+              <a:rPr sz="1200" b="1">
                 <a:solidFill>
                   <a:srgbClr val="2F6B78"/>
                 </a:solidFill>
                 <a:latin typeface="Calibri"/>
               </a:rPr>
-              <a:t>CHINOOK</a:t>
+              <a:t>HIERARCHY + PROVENANCE</a:t>
             </a:r>
           </a:p>
         </p:txBody>
@@ -38568,7 +38575,7 @@
                 </a:solidFill>
                 <a:latin typeface="Calibri"/>
               </a:rPr>
-              <a:t>11 tables</a:t>
+              <a:t>runs that have them</a:t>
             </a:r>
           </a:p>
         </p:txBody>
@@ -38728,7 +38735,7 @@
                 </a:solidFill>
                 <a:latin typeface="Calibri"/>
               </a:rPr>
-              <a:t>731</a:t>
+              <a:t>0.78–0.99</a:t>
             </a:r>
           </a:p>
         </p:txBody>
@@ -38804,11 +38811,11 @@
             <a:r>
               <a:rPr sz="1900" b="0">
                 <a:solidFill>
-                  <a:srgbClr val="1F2328"/>
+                  <a:srgbClr val="8A949B"/>
                 </a:solidFill>
                 <a:latin typeface="Calibri"/>
               </a:rPr>
-              <a:t>665</a:t>
+              <a:t>0 / 3</a:t>
             </a:r>
           </a:p>
         </p:txBody>
@@ -38884,11 +38891,11 @@
             <a:r>
               <a:rPr sz="1900" b="0">
                 <a:solidFill>
-                  <a:srgbClr val="1F2328"/>
+                  <a:srgbClr val="8A949B"/>
                 </a:solidFill>
                 <a:latin typeface="Calibri"/>
               </a:rPr>
-              <a:t>102</a:t>
+              <a:t>0 / 3</a:t>
             </a:r>
           </a:p>
         </p:txBody>
@@ -39048,7 +39055,7 @@
                 </a:solidFill>
                 <a:latin typeface="Calibri"/>
               </a:rPr>
-              <a:t>422 / 397 / 403</a:t>
+              <a:t>0.31–1.00</a:t>
             </a:r>
           </a:p>
         </p:txBody>
@@ -39124,11 +39131,11 @@
             <a:r>
               <a:rPr sz="1900" b="0">
                 <a:solidFill>
-                  <a:srgbClr val="1F2328"/>
+                  <a:srgbClr val="8A949B"/>
                 </a:solidFill>
                 <a:latin typeface="Calibri"/>
               </a:rPr>
-              <a:t>434 / 440 / 421</a:t>
+              <a:t>0 / 9</a:t>
             </a:r>
           </a:p>
         </p:txBody>
@@ -39204,11 +39211,11 @@
             <a:r>
               <a:rPr sz="1900" b="0">
                 <a:solidFill>
-                  <a:srgbClr val="1F2328"/>
+                  <a:srgbClr val="8A949B"/>
                 </a:solidFill>
                 <a:latin typeface="Calibri"/>
               </a:rPr>
-              <a:t>95 / 74 / 81</a:t>
+              <a:t>0 / 9</a:t>
             </a:r>
           </a:p>
         </p:txBody>
@@ -39362,13 +39369,13 @@
           <a:p>
             <a:pPr algn="ctr"/>
             <a:r>
-              <a:rPr sz="1800" b="0">
-                <a:solidFill>
-                  <a:srgbClr val="1F2328"/>
+              <a:rPr sz="1800" b="1">
+                <a:solidFill>
+                  <a:srgbClr val="B23A1E"/>
                 </a:solidFill>
                 <a:latin typeface="Calibri"/>
               </a:rPr>
-              <a:t>29 / 61 / 18</a:t>
+              <a:t>0.06–0.78</a:t>
             </a:r>
           </a:p>
         </p:txBody>
@@ -39448,7 +39455,7 @@
                 </a:solidFill>
                 <a:latin typeface="Calibri"/>
               </a:rPr>
-              <a:t>39 / 220 / 27</a:t>
+              <a:t>9 / 9</a:t>
             </a:r>
           </a:p>
         </p:txBody>
@@ -39524,11 +39531,11 @@
             <a:r>
               <a:rPr sz="1800" b="0">
                 <a:solidFill>
-                  <a:srgbClr val="1F2328"/>
+                  <a:srgbClr val="8A949B"/>
                 </a:solidFill>
                 <a:latin typeface="Calibri"/>
               </a:rPr>
-              <a:t>24 / 35 / 14</a:t>
+              <a:t>0 / 9</a:t>
             </a:r>
           </a:p>
         </p:txBody>
@@ -39688,7 +39695,7 @@
                 </a:solidFill>
                 <a:latin typeface="Calibri"/>
               </a:rPr>
-              <a:t>20 / 23 / 3</a:t>
+              <a:t>0.77–1.00</a:t>
             </a:r>
           </a:p>
         </p:txBody>
@@ -39768,7 +39775,7 @@
                 </a:solidFill>
                 <a:latin typeface="Calibri"/>
               </a:rPr>
-              <a:t>2 / 2 / 26</a:t>
+              <a:t>9 / 9</a:t>
             </a:r>
           </a:p>
         </p:txBody>
@@ -39848,7 +39855,7 @@
                 </a:solidFill>
                 <a:latin typeface="Calibri"/>
               </a:rPr>
-              <a:t>0 / 0 / 0</a:t>
+              <a:t>9 / 9</a:t>
             </a:r>
           </a:p>
         </p:txBody>
@@ -39922,13 +39929,22 @@
           <a:p>
             <a:pPr algn="l"/>
             <a:r>
-              <a:rPr sz="1700" b="1">
+              <a:rPr sz="1400" b="1">
+                <a:solidFill>
+                  <a:srgbClr val="0B6E4F"/>
+                </a:solidFill>
+                <a:latin typeface="Calibri"/>
+              </a:rPr>
+              <a:t>MODELING PITFALLS (OOPS!)   </a:t>
+            </a:r>
+            <a:r>
+              <a:rPr sz="1400" b="0">
                 <a:solidFill>
                   <a:srgbClr val="1F2328"/>
                 </a:solidFill>
                 <a:latin typeface="Calibri"/>
               </a:rPr>
-              <a:t>RIGOR improves on Non-Iterative in 9/9 matched runs; Chinook has zero findings in all 3.</a:t>
+              <a:t>Fewer than every other method in 9/9 like-for-like runs  ·  zero on Chinook with all three LLMs</a:t>
             </a:r>
           </a:p>
         </p:txBody>
@@ -39963,7 +39979,7 @@
                 </a:solidFill>
                 <a:latin typeface="Calibri"/>
               </a:rPr>
-              <a:t>Numbers in each LLM cell: Claude / Mistral / DeepSeek. Direct Mapping uses no LLM.</a:t>
+              <a:t>Coverage = embedding-based proxy (cosine ≥ 0.55); Direct Mapping is complete by construction. Like-for-like = same database and same LLM.</a:t>
             </a:r>
           </a:p>
         </p:txBody>
@@ -39998,8 +40014,272 @@
                 </a:solidFill>
                 <a:latin typeface="Calibri"/>
               </a:rPr>
-              <a:t>Interpret carefully: many findings concern missing annotations; critical P19 remains in 3/9 RIGOR runs. Source: Table 7.</a:t>
-            </a:r>
+              <a:t>Sources: paper Tables 7 (pitfalls), 8 (labels, SubClassOf, provenance), 9 (coverage). Raw pitfall counts: backup slide B1.</a:t>
+            </a:r>
+          </a:p>
+        </p:txBody>
+      </p:sp>
+      <p:sp>
+        <p:nvSpPr>
+          <p:cNvPr id="996" name="Marker 965" descr="absent"/>
+          <p:cNvSpPr/>
+          <p:nvPr/>
+        </p:nvSpPr>
+        <p:spPr>
+          <a:xfrm>
+            <a:off x="6935723" y="2651760"/>
+            <a:ext cx="164592" cy="164592"/>
+          </a:xfrm>
+          <a:prstGeom prst="ellipse">
+            <a:avLst/>
+          </a:prstGeom>
+          <a:solidFill>
+            <a:srgbClr val="FFFFFF"/>
+          </a:solidFill>
+          <a:ln w="9525">
+            <a:solidFill>
+              <a:srgbClr val="8A949B"/>
+            </a:solidFill>
+          </a:ln>
+        </p:spPr>
+        <p:txBody>
+          <a:bodyPr wrap="square" lIns="0" tIns="0" rIns="0" bIns="0" anchor="t">
+            <a:noAutofit/>
+          </a:bodyPr>
+          <a:lstStyle/>
+          <a:p>
+            <a:pPr algn="l"/>
+          </a:p>
+        </p:txBody>
+      </p:sp>
+      <p:sp>
+        <p:nvSpPr>
+          <p:cNvPr id="997" name="Marker 967" descr="absent"/>
+          <p:cNvSpPr/>
+          <p:nvPr/>
+        </p:nvSpPr>
+        <p:spPr>
+          <a:xfrm>
+            <a:off x="9587483" y="2651760"/>
+            <a:ext cx="164592" cy="164592"/>
+          </a:xfrm>
+          <a:prstGeom prst="ellipse">
+            <a:avLst/>
+          </a:prstGeom>
+          <a:solidFill>
+            <a:srgbClr val="FFFFFF"/>
+          </a:solidFill>
+          <a:ln w="9525">
+            <a:solidFill>
+              <a:srgbClr val="8A949B"/>
+            </a:solidFill>
+          </a:ln>
+        </p:spPr>
+        <p:txBody>
+          <a:bodyPr wrap="square" lIns="0" tIns="0" rIns="0" bIns="0" anchor="t">
+            <a:noAutofit/>
+          </a:bodyPr>
+          <a:lstStyle/>
+          <a:p>
+            <a:pPr algn="l"/>
+          </a:p>
+        </p:txBody>
+      </p:sp>
+      <p:sp>
+        <p:nvSpPr>
+          <p:cNvPr id="998" name="Marker 973" descr="absent"/>
+          <p:cNvSpPr/>
+          <p:nvPr/>
+        </p:nvSpPr>
+        <p:spPr>
+          <a:xfrm>
+            <a:off x="6935723" y="3310128"/>
+            <a:ext cx="164592" cy="164592"/>
+          </a:xfrm>
+          <a:prstGeom prst="ellipse">
+            <a:avLst/>
+          </a:prstGeom>
+          <a:solidFill>
+            <a:srgbClr val="FFFFFF"/>
+          </a:solidFill>
+          <a:ln w="9525">
+            <a:solidFill>
+              <a:srgbClr val="8A949B"/>
+            </a:solidFill>
+          </a:ln>
+        </p:spPr>
+        <p:txBody>
+          <a:bodyPr wrap="square" lIns="0" tIns="0" rIns="0" bIns="0" anchor="t">
+            <a:noAutofit/>
+          </a:bodyPr>
+          <a:lstStyle/>
+          <a:p>
+            <a:pPr algn="l"/>
+          </a:p>
+        </p:txBody>
+      </p:sp>
+      <p:sp>
+        <p:nvSpPr>
+          <p:cNvPr id="999" name="Marker 975" descr="absent"/>
+          <p:cNvSpPr/>
+          <p:nvPr/>
+        </p:nvSpPr>
+        <p:spPr>
+          <a:xfrm>
+            <a:off x="9587483" y="3310128"/>
+            <a:ext cx="164592" cy="164592"/>
+          </a:xfrm>
+          <a:prstGeom prst="ellipse">
+            <a:avLst/>
+          </a:prstGeom>
+          <a:solidFill>
+            <a:srgbClr val="FFFFFF"/>
+          </a:solidFill>
+          <a:ln w="9525">
+            <a:solidFill>
+              <a:srgbClr val="8A949B"/>
+            </a:solidFill>
+          </a:ln>
+        </p:spPr>
+        <p:txBody>
+          <a:bodyPr wrap="square" lIns="0" tIns="0" rIns="0" bIns="0" anchor="t">
+            <a:noAutofit/>
+          </a:bodyPr>
+          <a:lstStyle/>
+          <a:p>
+            <a:pPr algn="l"/>
+          </a:p>
+        </p:txBody>
+      </p:sp>
+      <p:sp>
+        <p:nvSpPr>
+          <p:cNvPr id="1000" name="Marker 981" descr="present"/>
+          <p:cNvSpPr/>
+          <p:nvPr/>
+        </p:nvSpPr>
+        <p:spPr>
+          <a:xfrm>
+            <a:off x="6935723" y="3968496"/>
+            <a:ext cx="164592" cy="164592"/>
+          </a:xfrm>
+          <a:prstGeom prst="ellipse">
+            <a:avLst/>
+          </a:prstGeom>
+          <a:solidFill>
+            <a:srgbClr val="0B6E4F"/>
+          </a:solidFill>
+          <a:ln w="9525">
+            <a:solidFill>
+              <a:srgbClr val="0B6E4F"/>
+            </a:solidFill>
+          </a:ln>
+        </p:spPr>
+        <p:txBody>
+          <a:bodyPr wrap="square" lIns="0" tIns="0" rIns="0" bIns="0" anchor="t">
+            <a:noAutofit/>
+          </a:bodyPr>
+          <a:lstStyle/>
+          <a:p>
+            <a:pPr algn="l"/>
+          </a:p>
+        </p:txBody>
+      </p:sp>
+      <p:sp>
+        <p:nvSpPr>
+          <p:cNvPr id="1001" name="Marker 983" descr="absent"/>
+          <p:cNvSpPr/>
+          <p:nvPr/>
+        </p:nvSpPr>
+        <p:spPr>
+          <a:xfrm>
+            <a:off x="9587483" y="3968496"/>
+            <a:ext cx="164592" cy="164592"/>
+          </a:xfrm>
+          <a:prstGeom prst="ellipse">
+            <a:avLst/>
+          </a:prstGeom>
+          <a:solidFill>
+            <a:srgbClr val="FFFFFF"/>
+          </a:solidFill>
+          <a:ln w="9525">
+            <a:solidFill>
+              <a:srgbClr val="8A949B"/>
+            </a:solidFill>
+          </a:ln>
+        </p:spPr>
+        <p:txBody>
+          <a:bodyPr wrap="square" lIns="0" tIns="0" rIns="0" bIns="0" anchor="t">
+            <a:noAutofit/>
+          </a:bodyPr>
+          <a:lstStyle/>
+          <a:p>
+            <a:pPr algn="l"/>
+          </a:p>
+        </p:txBody>
+      </p:sp>
+      <p:sp>
+        <p:nvSpPr>
+          <p:cNvPr id="1002" name="Marker 989" descr="present"/>
+          <p:cNvSpPr/>
+          <p:nvPr/>
+        </p:nvSpPr>
+        <p:spPr>
+          <a:xfrm>
+            <a:off x="6935723" y="4626864"/>
+            <a:ext cx="164592" cy="164592"/>
+          </a:xfrm>
+          <a:prstGeom prst="ellipse">
+            <a:avLst/>
+          </a:prstGeom>
+          <a:solidFill>
+            <a:srgbClr val="0B6E4F"/>
+          </a:solidFill>
+          <a:ln w="9525">
+            <a:solidFill>
+              <a:srgbClr val="0B6E4F"/>
+            </a:solidFill>
+          </a:ln>
+        </p:spPr>
+        <p:txBody>
+          <a:bodyPr wrap="square" lIns="0" tIns="0" rIns="0" bIns="0" anchor="t">
+            <a:noAutofit/>
+          </a:bodyPr>
+          <a:lstStyle/>
+          <a:p>
+            <a:pPr algn="l"/>
+          </a:p>
+        </p:txBody>
+      </p:sp>
+      <p:sp>
+        <p:nvSpPr>
+          <p:cNvPr id="1003" name="Marker 991" descr="present"/>
+          <p:cNvSpPr/>
+          <p:nvPr/>
+        </p:nvSpPr>
+        <p:spPr>
+          <a:xfrm>
+            <a:off x="9587483" y="4626864"/>
+            <a:ext cx="164592" cy="164592"/>
+          </a:xfrm>
+          <a:prstGeom prst="ellipse">
+            <a:avLst/>
+          </a:prstGeom>
+          <a:solidFill>
+            <a:srgbClr val="0B6E4F"/>
+          </a:solidFill>
+          <a:ln w="9525">
+            <a:solidFill>
+              <a:srgbClr val="0B6E4F"/>
+            </a:solidFill>
+          </a:ln>
+        </p:spPr>
+        <p:txBody>
+          <a:bodyPr wrap="square" lIns="0" tIns="0" rIns="0" bIns="0" anchor="t">
+            <a:noAutofit/>
+          </a:bodyPr>
+          <a:lstStyle/>
+          <a:p>
+            <a:pPr algn="l"/>
           </a:p>
         </p:txBody>
       </p:sp>
@@ -40082,7 +40362,7 @@
                 <a:cs typeface="Consolas"/>
                 <a:sym typeface="Consolas"/>
               </a:rPr>
-              <a:t>RESULT 3  /  EXTERNAL BENCHMARK</a:t>
+              <a:t>RESULT 2  /  EXTERNAL BENCHMARK</a:t>
             </a:r>
             <a:endParaRPr/>
           </a:p>
@@ -40135,7 +40415,7 @@
                 <a:cs typeface="Calibri"/>
                 <a:sym typeface="Calibri"/>
               </a:rPr>
-              <a:t>RIGOR leads the compared systems on BURR.</a:t>
+              <a:t>RIGOR keeps the link to the data: best on BURR.</a:t>
             </a:r>
             <a:endParaRPr/>
           </a:p>
@@ -40188,7 +40468,7 @@
                 <a:cs typeface="Calibri"/>
                 <a:sym typeface="Calibri"/>
               </a:rPr>
-              <a:t>ISWC benchmark scenario · Mapping-based F1 against a gold standard (higher is better).</a:t>
+              <a:t>BURR (Laskowski et al., 2025) scores ontology learning against a gold standard  ·  ISWC scenario</a:t>
             </a:r>
             <a:endParaRPr/>
           </a:p>
@@ -40202,8 +40482,8 @@
         </p:nvSpPr>
         <p:spPr>
           <a:xfrm>
-            <a:off x="841248" y="2139696"/>
-            <a:ext cx="10497312" cy="3063240"/>
+            <a:off x="5870448" y="2139696"/>
+            <a:ext cx="5468112" cy="3063240"/>
           </a:xfrm>
           <a:prstGeom prst="roundRect">
             <a:avLst/>
@@ -40247,8 +40527,8 @@
         </p:nvSpPr>
         <p:spPr>
           <a:xfrm>
-            <a:off x="1097280" y="2322576"/>
-            <a:ext cx="4069080" cy="329184"/>
+            <a:off x="6099048" y="2322576"/>
+            <a:ext cx="1828800" cy="329184"/>
           </a:xfrm>
           <a:prstGeom prst="rect">
             <a:avLst/>
@@ -40262,7 +40542,7 @@
           <a:lstStyle/>
           <a:p>
             <a:r>
-              <a:rPr sz="1550" b="1">
+              <a:rPr sz="1150" b="1">
                 <a:solidFill>
                   <a:srgbClr val="2F6B78"/>
                 </a:solidFill>
@@ -40281,8 +40561,8 @@
         </p:nvSpPr>
         <p:spPr>
           <a:xfrm>
-            <a:off x="5504688" y="2322576"/>
-            <a:ext cx="1627632" cy="329184"/>
+            <a:off x="8156447" y="2322576"/>
+            <a:ext cx="1051560" cy="329184"/>
           </a:xfrm>
           <a:prstGeom prst="rect">
             <a:avLst/>
@@ -40297,7 +40577,7 @@
           <a:p>
             <a:pPr algn="ctr"/>
             <a:r>
-              <a:rPr sz="1500" b="1">
+              <a:rPr sz="1150" b="1">
                 <a:solidFill>
                   <a:srgbClr val="2F6B78"/>
                 </a:solidFill>
@@ -40316,8 +40596,8 @@
         </p:nvSpPr>
         <p:spPr>
           <a:xfrm>
-            <a:off x="7443216" y="2322576"/>
-            <a:ext cx="1627632" cy="329184"/>
+            <a:off x="9208008" y="2322576"/>
+            <a:ext cx="1051560" cy="329184"/>
           </a:xfrm>
           <a:prstGeom prst="rect">
             <a:avLst/>
@@ -40332,7 +40612,7 @@
           <a:p>
             <a:pPr algn="ctr"/>
             <a:r>
-              <a:rPr sz="1500" b="1">
+              <a:rPr sz="1150" b="1">
                 <a:solidFill>
                   <a:srgbClr val="2F6B78"/>
                 </a:solidFill>
@@ -40351,8 +40631,8 @@
         </p:nvSpPr>
         <p:spPr>
           <a:xfrm>
-            <a:off x="9427464" y="2322576"/>
-            <a:ext cx="1627632" cy="329184"/>
+            <a:off x="10259567" y="2322576"/>
+            <a:ext cx="1051560" cy="329184"/>
           </a:xfrm>
           <a:prstGeom prst="rect">
             <a:avLst/>
@@ -40367,7 +40647,7 @@
           <a:p>
             <a:pPr algn="ctr"/>
             <a:r>
-              <a:rPr sz="1500" b="1">
+              <a:rPr sz="1150" b="1">
                 <a:solidFill>
                   <a:srgbClr val="2F6B78"/>
                 </a:solidFill>
@@ -40386,8 +40666,8 @@
         </p:nvCxnSpPr>
         <p:spPr>
           <a:xfrm>
-            <a:off x="1097280" y="2761488"/>
-            <a:ext cx="9976104" cy="0"/>
+            <a:off x="6071616" y="2761488"/>
+            <a:ext cx="5065776" cy="0"/>
           </a:xfrm>
           <a:prstGeom prst="line">
             <a:avLst/>
@@ -40421,8 +40701,8 @@
         </p:nvSpPr>
         <p:spPr>
           <a:xfrm>
-            <a:off x="1143000" y="2871216"/>
-            <a:ext cx="3456432" cy="274320"/>
+            <a:off x="6117336" y="2798064"/>
+            <a:ext cx="2011680" cy="274320"/>
           </a:xfrm>
           <a:prstGeom prst="rect">
             <a:avLst/>
@@ -40455,8 +40735,8 @@
         </p:nvSpPr>
         <p:spPr>
           <a:xfrm>
-            <a:off x="4389120" y="2907792"/>
-            <a:ext cx="1005840" cy="246888"/>
+            <a:off x="6117336" y="3054096"/>
+            <a:ext cx="1828800" cy="201168"/>
           </a:xfrm>
           <a:prstGeom prst="rect">
             <a:avLst/>
@@ -40489,8 +40769,8 @@
         </p:nvSpPr>
         <p:spPr>
           <a:xfrm>
-            <a:off x="5541264" y="2857500"/>
-            <a:ext cx="1572768" cy="320040"/>
+            <a:off x="8202167" y="2857500"/>
+            <a:ext cx="960120" cy="320040"/>
           </a:xfrm>
           <a:prstGeom prst="rect">
             <a:avLst/>
@@ -40524,8 +40804,8 @@
         </p:nvSpPr>
         <p:spPr>
           <a:xfrm>
-            <a:off x="7488936" y="2857500"/>
-            <a:ext cx="1572768" cy="320040"/>
+            <a:off x="9253728" y="2857500"/>
+            <a:ext cx="960120" cy="320040"/>
           </a:xfrm>
           <a:prstGeom prst="rect">
             <a:avLst/>
@@ -40559,8 +40839,8 @@
         </p:nvSpPr>
         <p:spPr>
           <a:xfrm>
-            <a:off x="9482328" y="2857500"/>
-            <a:ext cx="1572768" cy="320040"/>
+            <a:off x="10305288" y="2857500"/>
+            <a:ext cx="960120" cy="320040"/>
           </a:xfrm>
           <a:prstGeom prst="rect">
             <a:avLst/>
@@ -40594,8 +40874,8 @@
         </p:nvSpPr>
         <p:spPr>
           <a:xfrm>
-            <a:off x="1143000" y="3429000"/>
-            <a:ext cx="3456432" cy="274320"/>
+            <a:off x="6117336" y="3355848"/>
+            <a:ext cx="2011680" cy="274320"/>
           </a:xfrm>
           <a:prstGeom prst="rect">
             <a:avLst/>
@@ -40628,8 +40908,8 @@
         </p:nvSpPr>
         <p:spPr>
           <a:xfrm>
-            <a:off x="4389120" y="3465576"/>
-            <a:ext cx="1005840" cy="246888"/>
+            <a:off x="6117336" y="3611880"/>
+            <a:ext cx="1828800" cy="201168"/>
           </a:xfrm>
           <a:prstGeom prst="rect">
             <a:avLst/>
@@ -40662,8 +40942,8 @@
         </p:nvSpPr>
         <p:spPr>
           <a:xfrm>
-            <a:off x="5541264" y="3415284"/>
-            <a:ext cx="1572768" cy="320040"/>
+            <a:off x="8202167" y="3415284"/>
+            <a:ext cx="960120" cy="320040"/>
           </a:xfrm>
           <a:prstGeom prst="rect">
             <a:avLst/>
@@ -40697,8 +40977,8 @@
         </p:nvSpPr>
         <p:spPr>
           <a:xfrm>
-            <a:off x="7488936" y="3415284"/>
-            <a:ext cx="1572768" cy="320040"/>
+            <a:off x="9253728" y="3415284"/>
+            <a:ext cx="960120" cy="320040"/>
           </a:xfrm>
           <a:prstGeom prst="rect">
             <a:avLst/>
@@ -40732,8 +41012,8 @@
         </p:nvSpPr>
         <p:spPr>
           <a:xfrm>
-            <a:off x="9482328" y="3415284"/>
-            <a:ext cx="1572768" cy="320040"/>
+            <a:off x="10305288" y="3415284"/>
+            <a:ext cx="960120" cy="320040"/>
           </a:xfrm>
           <a:prstGeom prst="rect">
             <a:avLst/>
@@ -40767,8 +41047,8 @@
         </p:nvSpPr>
         <p:spPr>
           <a:xfrm>
-            <a:off x="1143000" y="3986784"/>
-            <a:ext cx="3456432" cy="274320"/>
+            <a:off x="6117336" y="3913632"/>
+            <a:ext cx="2011680" cy="274320"/>
           </a:xfrm>
           <a:prstGeom prst="rect">
             <a:avLst/>
@@ -40801,8 +41081,8 @@
         </p:nvSpPr>
         <p:spPr>
           <a:xfrm>
-            <a:off x="4389120" y="4023360"/>
-            <a:ext cx="1005840" cy="246888"/>
+            <a:off x="6117336" y="4169664"/>
+            <a:ext cx="1828800" cy="201168"/>
           </a:xfrm>
           <a:prstGeom prst="rect">
             <a:avLst/>
@@ -40835,8 +41115,8 @@
         </p:nvSpPr>
         <p:spPr>
           <a:xfrm>
-            <a:off x="5541264" y="3973068"/>
-            <a:ext cx="1572768" cy="320040"/>
+            <a:off x="8202167" y="3973068"/>
+            <a:ext cx="960120" cy="320040"/>
           </a:xfrm>
           <a:prstGeom prst="rect">
             <a:avLst/>
@@ -40870,8 +41150,8 @@
         </p:nvSpPr>
         <p:spPr>
           <a:xfrm>
-            <a:off x="7488936" y="3973068"/>
-            <a:ext cx="1572768" cy="320040"/>
+            <a:off x="9253728" y="3973068"/>
+            <a:ext cx="960120" cy="320040"/>
           </a:xfrm>
           <a:prstGeom prst="rect">
             <a:avLst/>
@@ -40905,8 +41185,8 @@
         </p:nvSpPr>
         <p:spPr>
           <a:xfrm>
-            <a:off x="9482328" y="3973068"/>
-            <a:ext cx="1572768" cy="320040"/>
+            <a:off x="10305288" y="3973068"/>
+            <a:ext cx="960120" cy="320040"/>
           </a:xfrm>
           <a:prstGeom prst="rect">
             <a:avLst/>
@@ -40940,8 +41220,8 @@
         </p:nvSpPr>
         <p:spPr>
           <a:xfrm>
-            <a:off x="1014984" y="4507992"/>
-            <a:ext cx="10094976" cy="512064"/>
+            <a:off x="5980176" y="4507992"/>
+            <a:ext cx="5248656" cy="512064"/>
           </a:xfrm>
           <a:prstGeom prst="rect">
             <a:avLst/>
@@ -40985,8 +41265,8 @@
         </p:nvSpPr>
         <p:spPr>
           <a:xfrm>
-            <a:off x="1143000" y="4544568"/>
-            <a:ext cx="3456432" cy="274320"/>
+            <a:off x="6117336" y="4471416"/>
+            <a:ext cx="2011680" cy="274320"/>
           </a:xfrm>
           <a:prstGeom prst="rect">
             <a:avLst/>
@@ -41019,8 +41299,8 @@
         </p:nvSpPr>
         <p:spPr>
           <a:xfrm>
-            <a:off x="4389120" y="4581144"/>
-            <a:ext cx="1005840" cy="246888"/>
+            <a:off x="6117336" y="4727448"/>
+            <a:ext cx="1828800" cy="201168"/>
           </a:xfrm>
           <a:prstGeom prst="rect">
             <a:avLst/>
@@ -41053,8 +41333,8 @@
         </p:nvSpPr>
         <p:spPr>
           <a:xfrm>
-            <a:off x="5541264" y="4530852"/>
-            <a:ext cx="1572768" cy="320040"/>
+            <a:off x="8202167" y="4530852"/>
+            <a:ext cx="960120" cy="320040"/>
           </a:xfrm>
           <a:prstGeom prst="rect">
             <a:avLst/>
@@ -41088,8 +41368,8 @@
         </p:nvSpPr>
         <p:spPr>
           <a:xfrm>
-            <a:off x="7488936" y="4530852"/>
-            <a:ext cx="1572768" cy="320040"/>
+            <a:off x="9253728" y="4530852"/>
+            <a:ext cx="960120" cy="320040"/>
           </a:xfrm>
           <a:prstGeom prst="rect">
             <a:avLst/>
@@ -41123,8 +41403,8 @@
         </p:nvSpPr>
         <p:spPr>
           <a:xfrm>
-            <a:off x="9482328" y="4530852"/>
-            <a:ext cx="1572768" cy="320040"/>
+            <a:off x="10305288" y="4530852"/>
+            <a:ext cx="960120" cy="320040"/>
           </a:xfrm>
           <a:prstGeom prst="rect">
             <a:avLst/>
@@ -41224,7 +41504,780 @@
                 </a:solidFill>
                 <a:latin typeface="Calibri"/>
               </a:rPr>
-              <a:t>One scenario · 9 tables · 46 columns · 11 FKs · Claude · provenance exported as D2RQ mappings</a:t>
+              <a:t>BURR's own finding: LLM-based methods trail rule-based ones.   </a:t>
+            </a:r>
+            <a:r>
+              <a:rPr sz="1280" b="1">
+                <a:solidFill>
+                  <a:srgbClr val="0B6E4F"/>
+                </a:solidFill>
+                <a:latin typeface="Calibri"/>
+              </a:rPr>
+              <a:t>Here RIGOR leads both.</a:t>
+            </a:r>
+          </a:p>
+        </p:txBody>
+      </p:sp>
+      <p:sp>
+        <p:nvSpPr>
+          <p:cNvPr id="1007" name="BURR card"/>
+          <p:cNvSpPr/>
+          <p:nvPr/>
+        </p:nvSpPr>
+        <p:spPr>
+          <a:xfrm>
+            <a:off x="841248" y="2139696"/>
+            <a:ext cx="4846320" cy="3063240"/>
+          </a:xfrm>
+          <a:prstGeom prst="roundRect">
+            <a:avLst>
+              <a:gd name="adj" fmla="val 12000"/>
+            </a:avLst>
+          </a:prstGeom>
+          <a:solidFill>
+            <a:srgbClr val="F3F5F4"/>
+          </a:solidFill>
+          <a:ln w="9525">
+            <a:solidFill>
+              <a:srgbClr val="D9DEDB"/>
+            </a:solidFill>
+          </a:ln>
+        </p:spPr>
+        <p:txBody>
+          <a:bodyPr wrap="square" lIns="0" tIns="0" rIns="0" bIns="0" anchor="t">
+            <a:noAutofit/>
+          </a:bodyPr>
+          <a:lstStyle/>
+          <a:p>
+            <a:pPr algn="l"/>
+          </a:p>
+        </p:txBody>
+      </p:sp>
+      <p:sp>
+        <p:nvSpPr>
+          <p:cNvPr id="1008" name="BURR card label"/>
+          <p:cNvSpPr txBox="1"/>
+          <p:nvPr/>
+        </p:nvSpPr>
+        <p:spPr>
+          <a:xfrm>
+            <a:off x="1069848" y="2322576"/>
+            <a:ext cx="4389120" cy="274320"/>
+          </a:xfrm>
+          <a:prstGeom prst="rect">
+            <a:avLst/>
+          </a:prstGeom>
+          <a:noFill/>
+          <a:ln>
+            <a:noFill/>
+          </a:ln>
+        </p:spPr>
+        <p:txBody>
+          <a:bodyPr wrap="square" lIns="0" tIns="0" rIns="0" bIns="0" anchor="t">
+            <a:noAutofit/>
+          </a:bodyPr>
+          <a:lstStyle/>
+          <a:p>
+            <a:pPr algn="l"/>
+            <a:r>
+              <a:rPr lang="en-US" sz="1300" b="1" dirty="0">
+                <a:solidFill>
+                  <a:srgbClr val="2F6B78"/>
+                </a:solidFill>
+                <a:latin typeface="Consolas"/>
+                <a:cs typeface="Consolas"/>
+              </a:rPr>
+              <a:t xml:space="preserve">WHAT BURR CHECKS</a:t>
+            </a:r>
+          </a:p>
+        </p:txBody>
+      </p:sp>
+      <p:sp>
+        <p:nvSpPr>
+          <p:cNvPr id="1009" name="BURR card lead"/>
+          <p:cNvSpPr txBox="1"/>
+          <p:nvPr/>
+        </p:nvSpPr>
+        <p:spPr>
+          <a:xfrm>
+            <a:off x="1069848" y="2651760"/>
+            <a:ext cx="4389120" cy="310896"/>
+          </a:xfrm>
+          <a:prstGeom prst="rect">
+            <a:avLst/>
+          </a:prstGeom>
+          <a:noFill/>
+          <a:ln>
+            <a:noFill/>
+          </a:ln>
+        </p:spPr>
+        <p:txBody>
+          <a:bodyPr wrap="square" lIns="0" tIns="0" rIns="0" bIns="0" anchor="t">
+            <a:noAutofit/>
+          </a:bodyPr>
+          <a:lstStyle/>
+          <a:p>
+            <a:pPr algn="l"/>
+            <a:r>
+              <a:rPr lang="en-US" sz="1500" b="0" dirty="0">
+                <a:solidFill>
+                  <a:srgbClr val="1F2328"/>
+                </a:solidFill>
+                <a:latin typeface="Calibri"/>
+                <a:cs typeface="Calibri"/>
+              </a:rPr>
+              <a:t xml:space="preserve">Every ontology element must map back to the database.</a:t>
+            </a:r>
+          </a:p>
+        </p:txBody>
+      </p:sp>
+      <p:sp>
+        <p:nvSpPr>
+          <p:cNvPr id="1010" name="BURR kind 0"/>
+          <p:cNvSpPr txBox="1"/>
+          <p:nvPr/>
+        </p:nvSpPr>
+        <p:spPr>
+          <a:xfrm>
+            <a:off x="1069848" y="3127248"/>
+            <a:ext cx="1005840" cy="329184"/>
+          </a:xfrm>
+          <a:prstGeom prst="rect">
+            <a:avLst/>
+          </a:prstGeom>
+          <a:noFill/>
+          <a:ln>
+            <a:noFill/>
+          </a:ln>
+        </p:spPr>
+        <p:txBody>
+          <a:bodyPr wrap="square" lIns="0" tIns="0" rIns="0" bIns="0" anchor="ctr">
+            <a:noAutofit/>
+          </a:bodyPr>
+          <a:lstStyle/>
+          <a:p>
+            <a:pPr algn="l"/>
+            <a:r>
+              <a:rPr lang="en-US" sz="1050" b="1" dirty="0">
+                <a:solidFill>
+                  <a:srgbClr val="2F6B78"/>
+                </a:solidFill>
+                <a:latin typeface="Consolas"/>
+                <a:cs typeface="Consolas"/>
+              </a:rPr>
+              <a:t xml:space="preserve">CLASSES</a:t>
+            </a:r>
+          </a:p>
+        </p:txBody>
+      </p:sp>
+      <p:sp>
+        <p:nvSpPr>
+          <p:cNvPr id="1011" name="BURR db 0" descr="database element"/>
+          <p:cNvSpPr/>
+          <p:nvPr/>
+        </p:nvSpPr>
+        <p:spPr>
+          <a:xfrm>
+            <a:off x="2075688" y="3127248"/>
+            <a:ext cx="1298448" cy="329184"/>
+          </a:xfrm>
+          <a:prstGeom prst="roundRect">
+            <a:avLst>
+              <a:gd name="adj" fmla="val 12000"/>
+            </a:avLst>
+          </a:prstGeom>
+          <a:solidFill>
+            <a:srgbClr val="FFFFFF"/>
+          </a:solidFill>
+          <a:ln w="9525">
+            <a:solidFill>
+              <a:srgbClr val="D0D7DE"/>
+            </a:solidFill>
+          </a:ln>
+        </p:spPr>
+        <p:txBody>
+          <a:bodyPr wrap="square" lIns="73152" tIns="0" rIns="73152" bIns="0" anchor="ctr">
+            <a:noAutofit/>
+          </a:bodyPr>
+          <a:lstStyle/>
+          <a:p>
+            <a:pPr algn="l"/>
+            <a:r>
+              <a:rPr lang="en-US" sz="1050" b="0" dirty="0">
+                <a:solidFill>
+                  <a:srgbClr val="1F2328"/>
+                </a:solidFill>
+                <a:latin typeface="Consolas"/>
+                <a:cs typeface="Consolas"/>
+              </a:rPr>
+              <a:t xml:space="preserve">person</a:t>
+            </a:r>
+          </a:p>
+        </p:txBody>
+      </p:sp>
+      <p:sp>
+        <p:nvSpPr>
+          <p:cNvPr id="1012" name="BURR arrow 0"/>
+          <p:cNvSpPr txBox="1"/>
+          <p:nvPr/>
+        </p:nvSpPr>
+        <p:spPr>
+          <a:xfrm>
+            <a:off x="3392424" y="3127248"/>
+            <a:ext cx="237744" cy="329184"/>
+          </a:xfrm>
+          <a:prstGeom prst="rect">
+            <a:avLst/>
+          </a:prstGeom>
+          <a:noFill/>
+          <a:ln>
+            <a:noFill/>
+          </a:ln>
+        </p:spPr>
+        <p:txBody>
+          <a:bodyPr wrap="square" lIns="0" tIns="0" rIns="0" bIns="0" anchor="ctr">
+            <a:noAutofit/>
+          </a:bodyPr>
+          <a:lstStyle/>
+          <a:p>
+            <a:pPr algn="ctr"/>
+            <a:r>
+              <a:rPr lang="en-US" sz="1400" b="0" dirty="0">
+                <a:solidFill>
+                  <a:srgbClr val="5B6770"/>
+                </a:solidFill>
+                <a:latin typeface="Calibri"/>
+                <a:cs typeface="Calibri"/>
+              </a:rPr>
+              <a:t xml:space="preserve">→</a:t>
+            </a:r>
+          </a:p>
+        </p:txBody>
+      </p:sp>
+      <p:sp>
+        <p:nvSpPr>
+          <p:cNvPr id="1013" name="BURR onto 0" descr="ontology element"/>
+          <p:cNvSpPr/>
+          <p:nvPr/>
+        </p:nvSpPr>
+        <p:spPr>
+          <a:xfrm>
+            <a:off x="3648456" y="3127248"/>
+            <a:ext cx="1856231" cy="329184"/>
+          </a:xfrm>
+          <a:prstGeom prst="roundRect">
+            <a:avLst>
+              <a:gd name="adj" fmla="val 12000"/>
+            </a:avLst>
+          </a:prstGeom>
+          <a:solidFill>
+            <a:srgbClr val="FFFFFF"/>
+          </a:solidFill>
+          <a:ln w="9525">
+            <a:solidFill>
+              <a:srgbClr val="D0D7DE"/>
+            </a:solidFill>
+          </a:ln>
+        </p:spPr>
+        <p:txBody>
+          <a:bodyPr wrap="square" lIns="73152" tIns="0" rIns="73152" bIns="0" anchor="ctr">
+            <a:noAutofit/>
+          </a:bodyPr>
+          <a:lstStyle/>
+          <a:p>
+            <a:pPr algn="l"/>
+            <a:r>
+              <a:rPr lang="en-US" sz="1050" b="1" dirty="0">
+                <a:solidFill>
+                  <a:srgbClr val="0B6E4F"/>
+                </a:solidFill>
+                <a:latin typeface="Consolas"/>
+                <a:cs typeface="Consolas"/>
+              </a:rPr>
+              <a:t xml:space="preserve">Class: </a:t>
+            </a:r>
+            <a:r>
+              <a:rPr lang="en-US" sz="1050" b="0" dirty="0">
+                <a:solidFill>
+                  <a:srgbClr val="1F2328"/>
+                </a:solidFill>
+                <a:latin typeface="Consolas"/>
+                <a:cs typeface="Consolas"/>
+              </a:rPr>
+              <a:t xml:space="preserve">Person</a:t>
+            </a:r>
+          </a:p>
+        </p:txBody>
+      </p:sp>
+      <p:sp>
+        <p:nvSpPr>
+          <p:cNvPr id="1014" name="BURR kind 1"/>
+          <p:cNvSpPr txBox="1"/>
+          <p:nvPr/>
+        </p:nvSpPr>
+        <p:spPr>
+          <a:xfrm>
+            <a:off x="1069848" y="3584448"/>
+            <a:ext cx="1005840" cy="329184"/>
+          </a:xfrm>
+          <a:prstGeom prst="rect">
+            <a:avLst/>
+          </a:prstGeom>
+          <a:noFill/>
+          <a:ln>
+            <a:noFill/>
+          </a:ln>
+        </p:spPr>
+        <p:txBody>
+          <a:bodyPr wrap="square" lIns="0" tIns="0" rIns="0" bIns="0" anchor="ctr">
+            <a:noAutofit/>
+          </a:bodyPr>
+          <a:lstStyle/>
+          <a:p>
+            <a:pPr algn="l"/>
+            <a:r>
+              <a:rPr lang="en-US" sz="1050" b="1" dirty="0">
+                <a:solidFill>
+                  <a:srgbClr val="2F6B78"/>
+                </a:solidFill>
+                <a:latin typeface="Consolas"/>
+                <a:cs typeface="Consolas"/>
+              </a:rPr>
+              <a:t xml:space="preserve">RELATIONS</a:t>
+            </a:r>
+          </a:p>
+        </p:txBody>
+      </p:sp>
+      <p:sp>
+        <p:nvSpPr>
+          <p:cNvPr id="1015" name="BURR db 1" descr="database element"/>
+          <p:cNvSpPr/>
+          <p:nvPr/>
+        </p:nvSpPr>
+        <p:spPr>
+          <a:xfrm>
+            <a:off x="2075688" y="3584448"/>
+            <a:ext cx="1298448" cy="329184"/>
+          </a:xfrm>
+          <a:prstGeom prst="roundRect">
+            <a:avLst>
+              <a:gd name="adj" fmla="val 12000"/>
+            </a:avLst>
+          </a:prstGeom>
+          <a:solidFill>
+            <a:srgbClr val="FFFFFF"/>
+          </a:solidFill>
+          <a:ln w="9525">
+            <a:solidFill>
+              <a:srgbClr val="D0D7DE"/>
+            </a:solidFill>
+          </a:ln>
+        </p:spPr>
+        <p:txBody>
+          <a:bodyPr wrap="square" lIns="73152" tIns="0" rIns="73152" bIns="0" anchor="ctr">
+            <a:noAutofit/>
+          </a:bodyPr>
+          <a:lstStyle/>
+          <a:p>
+            <a:pPr algn="l"/>
+            <a:r>
+              <a:rPr lang="en-US" sz="1050" b="0" dirty="0">
+                <a:solidFill>
+                  <a:srgbClr val="1F2328"/>
+                </a:solidFill>
+                <a:latin typeface="Consolas"/>
+                <a:cs typeface="Consolas"/>
+              </a:rPr>
+              <a:t xml:space="preserve">paper.author_id</a:t>
+            </a:r>
+          </a:p>
+        </p:txBody>
+      </p:sp>
+      <p:sp>
+        <p:nvSpPr>
+          <p:cNvPr id="1016" name="BURR arrow 1"/>
+          <p:cNvSpPr txBox="1"/>
+          <p:nvPr/>
+        </p:nvSpPr>
+        <p:spPr>
+          <a:xfrm>
+            <a:off x="3392424" y="3584448"/>
+            <a:ext cx="237744" cy="329184"/>
+          </a:xfrm>
+          <a:prstGeom prst="rect">
+            <a:avLst/>
+          </a:prstGeom>
+          <a:noFill/>
+          <a:ln>
+            <a:noFill/>
+          </a:ln>
+        </p:spPr>
+        <p:txBody>
+          <a:bodyPr wrap="square" lIns="0" tIns="0" rIns="0" bIns="0" anchor="ctr">
+            <a:noAutofit/>
+          </a:bodyPr>
+          <a:lstStyle/>
+          <a:p>
+            <a:pPr algn="ctr"/>
+            <a:r>
+              <a:rPr lang="en-US" sz="1400" b="0" dirty="0">
+                <a:solidFill>
+                  <a:srgbClr val="5B6770"/>
+                </a:solidFill>
+                <a:latin typeface="Calibri"/>
+                <a:cs typeface="Calibri"/>
+              </a:rPr>
+              <a:t xml:space="preserve">→</a:t>
+            </a:r>
+          </a:p>
+        </p:txBody>
+      </p:sp>
+      <p:sp>
+        <p:nvSpPr>
+          <p:cNvPr id="1017" name="BURR onto 1" descr="ontology element"/>
+          <p:cNvSpPr/>
+          <p:nvPr/>
+        </p:nvSpPr>
+        <p:spPr>
+          <a:xfrm>
+            <a:off x="3648456" y="3584448"/>
+            <a:ext cx="1856231" cy="329184"/>
+          </a:xfrm>
+          <a:prstGeom prst="roundRect">
+            <a:avLst>
+              <a:gd name="adj" fmla="val 12000"/>
+            </a:avLst>
+          </a:prstGeom>
+          <a:solidFill>
+            <a:srgbClr val="FFFFFF"/>
+          </a:solidFill>
+          <a:ln w="9525">
+            <a:solidFill>
+              <a:srgbClr val="D0D7DE"/>
+            </a:solidFill>
+          </a:ln>
+        </p:spPr>
+        <p:txBody>
+          <a:bodyPr wrap="square" lIns="73152" tIns="0" rIns="73152" bIns="0" anchor="ctr">
+            <a:noAutofit/>
+          </a:bodyPr>
+          <a:lstStyle/>
+          <a:p>
+            <a:pPr algn="l"/>
+            <a:r>
+              <a:rPr lang="en-US" sz="1050" b="1" dirty="0">
+                <a:solidFill>
+                  <a:srgbClr val="0B6E4F"/>
+                </a:solidFill>
+                <a:latin typeface="Consolas"/>
+                <a:cs typeface="Consolas"/>
+              </a:rPr>
+              <a:t xml:space="preserve">ObjectProperty: </a:t>
+            </a:r>
+            <a:r>
+              <a:rPr lang="en-US" sz="1050" b="0" dirty="0">
+                <a:solidFill>
+                  <a:srgbClr val="1F2328"/>
+                </a:solidFill>
+                <a:latin typeface="Consolas"/>
+                <a:cs typeface="Consolas"/>
+              </a:rPr>
+              <a:t xml:space="preserve">author</a:t>
+            </a:r>
+          </a:p>
+        </p:txBody>
+      </p:sp>
+      <p:sp>
+        <p:nvSpPr>
+          <p:cNvPr id="1018" name="BURR kind 2"/>
+          <p:cNvSpPr txBox="1"/>
+          <p:nvPr/>
+        </p:nvSpPr>
+        <p:spPr>
+          <a:xfrm>
+            <a:off x="1069848" y="4041648"/>
+            <a:ext cx="1005840" cy="329184"/>
+          </a:xfrm>
+          <a:prstGeom prst="rect">
+            <a:avLst/>
+          </a:prstGeom>
+          <a:noFill/>
+          <a:ln>
+            <a:noFill/>
+          </a:ln>
+        </p:spPr>
+        <p:txBody>
+          <a:bodyPr wrap="square" lIns="0" tIns="0" rIns="0" bIns="0" anchor="ctr">
+            <a:noAutofit/>
+          </a:bodyPr>
+          <a:lstStyle/>
+          <a:p>
+            <a:pPr algn="l"/>
+            <a:r>
+              <a:rPr lang="en-US" sz="1050" b="1" dirty="0">
+                <a:solidFill>
+                  <a:srgbClr val="2F6B78"/>
+                </a:solidFill>
+                <a:latin typeface="Consolas"/>
+                <a:cs typeface="Consolas"/>
+              </a:rPr>
+              <a:t xml:space="preserve">ATTRIBUTES</a:t>
+            </a:r>
+          </a:p>
+        </p:txBody>
+      </p:sp>
+      <p:sp>
+        <p:nvSpPr>
+          <p:cNvPr id="1019" name="BURR db 2" descr="database element"/>
+          <p:cNvSpPr/>
+          <p:nvPr/>
+        </p:nvSpPr>
+        <p:spPr>
+          <a:xfrm>
+            <a:off x="2075688" y="4041648"/>
+            <a:ext cx="1298448" cy="329184"/>
+          </a:xfrm>
+          <a:prstGeom prst="roundRect">
+            <a:avLst>
+              <a:gd name="adj" fmla="val 12000"/>
+            </a:avLst>
+          </a:prstGeom>
+          <a:solidFill>
+            <a:srgbClr val="FFFFFF"/>
+          </a:solidFill>
+          <a:ln w="9525">
+            <a:solidFill>
+              <a:srgbClr val="D0D7DE"/>
+            </a:solidFill>
+          </a:ln>
+        </p:spPr>
+        <p:txBody>
+          <a:bodyPr wrap="square" lIns="73152" tIns="0" rIns="73152" bIns="0" anchor="ctr">
+            <a:noAutofit/>
+          </a:bodyPr>
+          <a:lstStyle/>
+          <a:p>
+            <a:pPr algn="l"/>
+            <a:r>
+              <a:rPr lang="en-US" sz="1050" b="0" dirty="0">
+                <a:solidFill>
+                  <a:srgbClr val="1F2328"/>
+                </a:solidFill>
+                <a:latin typeface="Consolas"/>
+                <a:cs typeface="Consolas"/>
+              </a:rPr>
+              <a:t xml:space="preserve">person.name</a:t>
+            </a:r>
+          </a:p>
+        </p:txBody>
+      </p:sp>
+      <p:sp>
+        <p:nvSpPr>
+          <p:cNvPr id="1020" name="BURR arrow 2"/>
+          <p:cNvSpPr txBox="1"/>
+          <p:nvPr/>
+        </p:nvSpPr>
+        <p:spPr>
+          <a:xfrm>
+            <a:off x="3392424" y="4041648"/>
+            <a:ext cx="237744" cy="329184"/>
+          </a:xfrm>
+          <a:prstGeom prst="rect">
+            <a:avLst/>
+          </a:prstGeom>
+          <a:noFill/>
+          <a:ln>
+            <a:noFill/>
+          </a:ln>
+        </p:spPr>
+        <p:txBody>
+          <a:bodyPr wrap="square" lIns="0" tIns="0" rIns="0" bIns="0" anchor="ctr">
+            <a:noAutofit/>
+          </a:bodyPr>
+          <a:lstStyle/>
+          <a:p>
+            <a:pPr algn="ctr"/>
+            <a:r>
+              <a:rPr lang="en-US" sz="1400" b="0" dirty="0">
+                <a:solidFill>
+                  <a:srgbClr val="5B6770"/>
+                </a:solidFill>
+                <a:latin typeface="Calibri"/>
+                <a:cs typeface="Calibri"/>
+              </a:rPr>
+              <a:t xml:space="preserve">→</a:t>
+            </a:r>
+          </a:p>
+        </p:txBody>
+      </p:sp>
+      <p:sp>
+        <p:nvSpPr>
+          <p:cNvPr id="1021" name="BURR onto 2" descr="ontology element"/>
+          <p:cNvSpPr/>
+          <p:nvPr/>
+        </p:nvSpPr>
+        <p:spPr>
+          <a:xfrm>
+            <a:off x="3648456" y="4041648"/>
+            <a:ext cx="1856231" cy="329184"/>
+          </a:xfrm>
+          <a:prstGeom prst="roundRect">
+            <a:avLst>
+              <a:gd name="adj" fmla="val 12000"/>
+            </a:avLst>
+          </a:prstGeom>
+          <a:solidFill>
+            <a:srgbClr val="FFFFFF"/>
+          </a:solidFill>
+          <a:ln w="9525">
+            <a:solidFill>
+              <a:srgbClr val="D0D7DE"/>
+            </a:solidFill>
+          </a:ln>
+        </p:spPr>
+        <p:txBody>
+          <a:bodyPr wrap="square" lIns="73152" tIns="0" rIns="73152" bIns="0" anchor="ctr">
+            <a:noAutofit/>
+          </a:bodyPr>
+          <a:lstStyle/>
+          <a:p>
+            <a:pPr algn="l"/>
+            <a:r>
+              <a:rPr lang="en-US" sz="1050" b="1" dirty="0">
+                <a:solidFill>
+                  <a:srgbClr val="0B6E4F"/>
+                </a:solidFill>
+                <a:latin typeface="Consolas"/>
+                <a:cs typeface="Consolas"/>
+              </a:rPr>
+              <a:t xml:space="preserve">DataProperty: </a:t>
+            </a:r>
+            <a:r>
+              <a:rPr lang="en-US" sz="1050" b="0" dirty="0">
+                <a:solidFill>
+                  <a:srgbClr val="1F2328"/>
+                </a:solidFill>
+                <a:latin typeface="Consolas"/>
+                <a:cs typeface="Consolas"/>
+              </a:rPr>
+              <a:t xml:space="preserve">name</a:t>
+            </a:r>
+          </a:p>
+        </p:txBody>
+      </p:sp>
+      <p:sp>
+        <p:nvSpPr>
+          <p:cNvPr id="1022" name="BURR card how"/>
+          <p:cNvSpPr txBox="1"/>
+          <p:nvPr/>
+        </p:nvSpPr>
+        <p:spPr>
+          <a:xfrm>
+            <a:off x="1069848" y="4443983"/>
+            <a:ext cx="4389120" cy="438912"/>
+          </a:xfrm>
+          <a:prstGeom prst="rect">
+            <a:avLst/>
+          </a:prstGeom>
+          <a:noFill/>
+          <a:ln>
+            <a:noFill/>
+          </a:ln>
+        </p:spPr>
+        <p:txBody>
+          <a:bodyPr wrap="square" lIns="0" tIns="0" rIns="0" bIns="0" anchor="t">
+            <a:noAutofit/>
+          </a:bodyPr>
+          <a:lstStyle/>
+          <a:p>
+            <a:pPr algn="l"/>
+            <a:r>
+              <a:rPr lang="en-US" sz="1300" b="0" dirty="0">
+                <a:solidFill>
+                  <a:srgbClr val="3A434C"/>
+                </a:solidFill>
+                <a:latin typeface="Calibri"/>
+                <a:cs typeface="Calibri"/>
+              </a:rPr>
+              <a:t xml:space="preserve">BURR compares each system's mapping with a gold-standard mapping and reports F1 per element type.</a:t>
+            </a:r>
+          </a:p>
+        </p:txBody>
+      </p:sp>
+      <p:sp>
+        <p:nvSpPr>
+          <p:cNvPr id="1023" name="BURR card note"/>
+          <p:cNvSpPr txBox="1"/>
+          <p:nvPr/>
+        </p:nvSpPr>
+        <p:spPr>
+          <a:xfrm>
+            <a:off x="1069848" y="4937760"/>
+            <a:ext cx="4389120" cy="182880"/>
+          </a:xfrm>
+          <a:prstGeom prst="rect">
+            <a:avLst/>
+          </a:prstGeom>
+          <a:noFill/>
+          <a:ln>
+            <a:noFill/>
+          </a:ln>
+        </p:spPr>
+        <p:txBody>
+          <a:bodyPr wrap="square" lIns="0" tIns="0" rIns="0" bIns="0" anchor="t">
+            <a:noAutofit/>
+          </a:bodyPr>
+          <a:lstStyle/>
+          <a:p>
+            <a:pPr algn="l"/>
+            <a:r>
+              <a:rPr lang="en-US" sz="1000" b="0" dirty="0">
+                <a:solidFill>
+                  <a:srgbClr val="5B6770"/>
+                </a:solidFill>
+                <a:latin typeface="Calibri"/>
+                <a:cs typeface="Calibri"/>
+              </a:rPr>
+              <a:t xml:space="preserve">Illustrative elements from the ISWC domain</a:t>
+            </a:r>
+          </a:p>
+        </p:txBody>
+      </p:sp>
+      <p:sp>
+        <p:nvSpPr>
+          <p:cNvPr id="1024" name="BURR caption"/>
+          <p:cNvSpPr txBox="1"/>
+          <p:nvPr/>
+        </p:nvSpPr>
+        <p:spPr>
+          <a:xfrm>
+            <a:off x="850392" y="5943600"/>
+            <a:ext cx="10488168" cy="246888"/>
+          </a:xfrm>
+          <a:prstGeom prst="rect">
+            <a:avLst/>
+          </a:prstGeom>
+          <a:noFill/>
+          <a:ln>
+            <a:noFill/>
+          </a:ln>
+        </p:spPr>
+        <p:txBody>
+          <a:bodyPr wrap="square" lIns="0" tIns="0" rIns="0" bIns="0" anchor="t">
+            <a:noAutofit/>
+          </a:bodyPr>
+          <a:lstStyle/>
+          <a:p>
+            <a:pPr algn="l"/>
+            <a:r>
+              <a:rPr lang="en-US" sz="1050" b="0" dirty="0">
+                <a:solidFill>
+                  <a:srgbClr val="5B6770"/>
+                </a:solidFill>
+                <a:latin typeface="Calibri"/>
+                <a:cs typeface="Calibri"/>
+              </a:rPr>
+              <a:t xml:space="preserve">One scenario  ·  9 tables · 46 columns · 11 FKs  ·  RIGOR with Claude  ·  its prov:wasDerivedFrom links exported as a D2RQ mapping  ·  Source: paper Table 13</a:t>
             </a:r>
           </a:p>
         </p:txBody>
@@ -43071,6 +44124,1998 @@
                 <a:latin typeface="Calibri"/>
               </a:rPr>
               <a:t>ISWC 2026 · Bari</a:t>
+            </a:r>
+          </a:p>
+        </p:txBody>
+      </p:sp>
+    </p:spTree>
+  </p:cSld>
+  <p:clrMapOvr>
+    <a:masterClrMapping/>
+  </p:clrMapOvr>
+</p:sld>
+</file>
+
+<file path=ppt/slides/slide24.xml><?xml version="1.0" encoding="utf-8"?>
+<p:sld xmlns:a="http://schemas.openxmlformats.org/drawingml/2006/main" xmlns:r="http://schemas.openxmlformats.org/officeDocument/2006/relationships" xmlns:mc="http://schemas.openxmlformats.org/markup-compatibility/2006" xmlns:mv="urn:schemas-microsoft-com:mac:vml" xmlns:p="http://schemas.openxmlformats.org/presentationml/2006/main" xmlns:c="http://schemas.openxmlformats.org/drawingml/2006/chart" xmlns:dgm="http://schemas.openxmlformats.org/drawingml/2006/diagram" xmlns:o="urn:schemas-microsoft-com:office:office" xmlns:v="urn:schemas-microsoft-com:vml" xmlns:pvml="urn:schemas-microsoft-com:office:powerpoint" xmlns:com="http://schemas.openxmlformats.org/drawingml/2006/compatibility" xmlns:p14="http://schemas.microsoft.com/office/powerpoint/2010/main" xmlns:p15="http://schemas.microsoft.com/office/powerpoint/2012/main" xmlns:ahyp="http://schemas.microsoft.com/office/drawing/2018/hyperlinkcolor">
+  <p:cSld>
+    <p:bg>
+      <p:bgPr>
+        <a:solidFill>
+          <a:srgbClr val="FFFFFF"/>
+        </a:solidFill>
+      </p:bgPr>
+    </p:bg>
+    <p:spTree>
+      <p:nvGrpSpPr>
+        <p:cNvPr id="945" name="Shape 945"/>
+        <p:cNvGrpSpPr/>
+        <p:nvPr/>
+      </p:nvGrpSpPr>
+      <p:grpSpPr>
+        <a:xfrm>
+          <a:off x="0" y="0"/>
+          <a:ext cx="0" cy="0"/>
+          <a:chOff x="0" y="0"/>
+          <a:chExt cx="0" cy="0"/>
+        </a:xfrm>
+      </p:grpSpPr>
+      <p:sp>
+        <p:nvSpPr>
+          <p:cNvPr id="946" name="TextBox 945"/>
+          <p:cNvSpPr txBox="1"/>
+          <p:nvPr/>
+        </p:nvSpPr>
+        <p:spPr>
+          <a:xfrm>
+            <a:off x="777240" y="347472"/>
+            <a:ext cx="10058400" cy="292608"/>
+          </a:xfrm>
+          <a:prstGeom prst="rect">
+            <a:avLst/>
+          </a:prstGeom>
+          <a:noFill/>
+        </p:spPr>
+        <p:txBody>
+          <a:bodyPr wrap="square" lIns="0" rIns="0" tIns="0" bIns="0">
+            <a:spAutoFit/>
+          </a:bodyPr>
+          <a:lstStyle/>
+          <a:p>
+            <a:pPr algn="l"/>
+            <a:r>
+              <a:rPr sz="1500" b="1">
+                <a:solidFill>
+                  <a:srgbClr val="0B6E4F"/>
+                </a:solidFill>
+                <a:latin typeface="Consolas"/>
+              </a:rPr>
+              <a:t>BACKUP  /  B1</a:t>
+            </a:r>
+          </a:p>
+        </p:txBody>
+      </p:sp>
+      <p:sp>
+        <p:nvSpPr>
+          <p:cNvPr id="947" name="TextBox 946"/>
+          <p:cNvSpPr txBox="1"/>
+          <p:nvPr/>
+        </p:nvSpPr>
+        <p:spPr>
+          <a:xfrm>
+            <a:off x="777240" y="768096"/>
+            <a:ext cx="10881360" cy="530352"/>
+          </a:xfrm>
+          <a:prstGeom prst="rect">
+            <a:avLst/>
+          </a:prstGeom>
+          <a:noFill/>
+        </p:spPr>
+        <p:txBody>
+          <a:bodyPr wrap="square" lIns="0" rIns="0" tIns="0" bIns="0">
+            <a:spAutoFit/>
+          </a:bodyPr>
+          <a:lstStyle/>
+          <a:p>
+            <a:pPr algn="l"/>
+            <a:r>
+              <a:rPr sz="2600" b="1">
+                <a:solidFill>
+                  <a:srgbClr val="1F2328"/>
+                </a:solidFill>
+                <a:latin typeface="Cambria"/>
+              </a:rPr>
+              <a:t>Raw OOPS! pitfall counts (paper Table 7).</a:t>
+            </a:r>
+          </a:p>
+        </p:txBody>
+      </p:sp>
+      <p:sp>
+        <p:nvSpPr>
+          <p:cNvPr id="948" name="TextBox 947"/>
+          <p:cNvSpPr txBox="1"/>
+          <p:nvPr/>
+        </p:nvSpPr>
+        <p:spPr>
+          <a:xfrm>
+            <a:off x="777240" y="1371600"/>
+            <a:ext cx="10789920" cy="347472"/>
+          </a:xfrm>
+          <a:prstGeom prst="rect">
+            <a:avLst/>
+          </a:prstGeom>
+          <a:noFill/>
+        </p:spPr>
+        <p:txBody>
+          <a:bodyPr wrap="square" lIns="0" rIns="0" tIns="0" bIns="0">
+            <a:spAutoFit/>
+          </a:bodyPr>
+          <a:lstStyle/>
+          <a:p>
+            <a:pPr algn="l"/>
+            <a:r>
+              <a:rPr sz="1400" b="0">
+                <a:solidFill>
+                  <a:srgbClr val="5B6770"/>
+                </a:solidFill>
+                <a:latin typeface="Calibri"/>
+              </a:rPr>
+              <a:t>OOPS! findings per ontology (lower is better) · Same dataset and generator model in each comparison</a:t>
+            </a:r>
+          </a:p>
+        </p:txBody>
+      </p:sp>
+      <p:sp>
+        <p:nvSpPr>
+          <p:cNvPr id="949" name="Rectangle 948"/>
+          <p:cNvSpPr/>
+          <p:nvPr/>
+        </p:nvSpPr>
+        <p:spPr>
+          <a:xfrm>
+            <a:off x="822960" y="1874519"/>
+            <a:ext cx="2514600" cy="475488"/>
+          </a:xfrm>
+          <a:prstGeom prst="rect">
+            <a:avLst/>
+          </a:prstGeom>
+          <a:solidFill>
+            <a:srgbClr val="FFFFFF"/>
+          </a:solidFill>
+          <a:ln>
+            <a:solidFill>
+              <a:srgbClr val="D9DEDB"/>
+            </a:solidFill>
+          </a:ln>
+        </p:spPr>
+        <p:style>
+          <a:lnRef idx="1">
+            <a:schemeClr val="accent1"/>
+          </a:lnRef>
+          <a:fillRef idx="3">
+            <a:schemeClr val="accent1"/>
+          </a:fillRef>
+          <a:effectRef idx="2">
+            <a:schemeClr val="accent1"/>
+          </a:effectRef>
+          <a:fontRef idx="minor">
+            <a:schemeClr val="lt1"/>
+          </a:fontRef>
+        </p:style>
+        <p:txBody>
+          <a:bodyPr rtlCol="0" anchor="ctr"/>
+          <a:lstStyle/>
+          <a:p>
+            <a:pPr algn="ctr"/>
+          </a:p>
+        </p:txBody>
+      </p:sp>
+      <p:sp>
+        <p:nvSpPr>
+          <p:cNvPr id="950" name="TextBox 949"/>
+          <p:cNvSpPr txBox="1"/>
+          <p:nvPr/>
+        </p:nvSpPr>
+        <p:spPr>
+          <a:xfrm>
+            <a:off x="969264" y="1984248"/>
+            <a:ext cx="2258568" cy="237744"/>
+          </a:xfrm>
+          <a:prstGeom prst="rect">
+            <a:avLst/>
+          </a:prstGeom>
+          <a:noFill/>
+        </p:spPr>
+        <p:txBody>
+          <a:bodyPr wrap="square" lIns="0" rIns="0" tIns="0" bIns="0">
+            <a:spAutoFit/>
+          </a:bodyPr>
+          <a:lstStyle/>
+          <a:p>
+            <a:pPr algn="l"/>
+            <a:r>
+              <a:rPr sz="1500" b="1">
+                <a:solidFill>
+                  <a:srgbClr val="2F6B78"/>
+                </a:solidFill>
+                <a:latin typeface="Calibri"/>
+              </a:rPr>
+              <a:t>METHOD</a:t>
+            </a:r>
+          </a:p>
+        </p:txBody>
+      </p:sp>
+      <p:sp>
+        <p:nvSpPr>
+          <p:cNvPr id="951" name="Rectangle 950"/>
+          <p:cNvSpPr/>
+          <p:nvPr/>
+        </p:nvSpPr>
+        <p:spPr>
+          <a:xfrm>
+            <a:off x="3474720" y="1874519"/>
+            <a:ext cx="2606040" cy="475488"/>
+          </a:xfrm>
+          <a:prstGeom prst="rect">
+            <a:avLst/>
+          </a:prstGeom>
+          <a:solidFill>
+            <a:srgbClr val="FFFFFF"/>
+          </a:solidFill>
+          <a:ln>
+            <a:solidFill>
+              <a:srgbClr val="D9DEDB"/>
+            </a:solidFill>
+          </a:ln>
+        </p:spPr>
+        <p:style>
+          <a:lnRef idx="1">
+            <a:schemeClr val="accent1"/>
+          </a:lnRef>
+          <a:fillRef idx="3">
+            <a:schemeClr val="accent1"/>
+          </a:fillRef>
+          <a:effectRef idx="2">
+            <a:schemeClr val="accent1"/>
+          </a:effectRef>
+          <a:fontRef idx="minor">
+            <a:schemeClr val="lt1"/>
+          </a:fontRef>
+        </p:style>
+        <p:txBody>
+          <a:bodyPr rtlCol="0" anchor="ctr"/>
+          <a:lstStyle/>
+          <a:p>
+            <a:pPr algn="ctr"/>
+          </a:p>
+        </p:txBody>
+      </p:sp>
+      <p:sp>
+        <p:nvSpPr>
+          <p:cNvPr id="952" name="TextBox 951"/>
+          <p:cNvSpPr txBox="1"/>
+          <p:nvPr/>
+        </p:nvSpPr>
+        <p:spPr>
+          <a:xfrm>
+            <a:off x="3621024" y="1984248"/>
+            <a:ext cx="2350008" cy="237744"/>
+          </a:xfrm>
+          <a:prstGeom prst="rect">
+            <a:avLst/>
+          </a:prstGeom>
+          <a:noFill/>
+        </p:spPr>
+        <p:txBody>
+          <a:bodyPr wrap="square" lIns="0" rIns="0" tIns="0" bIns="0">
+            <a:spAutoFit/>
+          </a:bodyPr>
+          <a:lstStyle/>
+          <a:p>
+            <a:pPr algn="l"/>
+            <a:r>
+              <a:rPr sz="1500" b="1">
+                <a:solidFill>
+                  <a:srgbClr val="2F6B78"/>
+                </a:solidFill>
+                <a:latin typeface="Calibri"/>
+              </a:rPr>
+              <a:t>LIVER CANCER</a:t>
+            </a:r>
+          </a:p>
+        </p:txBody>
+      </p:sp>
+      <p:sp>
+        <p:nvSpPr>
+          <p:cNvPr id="953" name="TextBox 952"/>
+          <p:cNvSpPr txBox="1"/>
+          <p:nvPr/>
+        </p:nvSpPr>
+        <p:spPr>
+          <a:xfrm>
+            <a:off x="3621024" y="2212848"/>
+            <a:ext cx="2350008" cy="182880"/>
+          </a:xfrm>
+          <a:prstGeom prst="rect">
+            <a:avLst/>
+          </a:prstGeom>
+          <a:noFill/>
+        </p:spPr>
+        <p:txBody>
+          <a:bodyPr wrap="square" lIns="0" rIns="0" tIns="0" bIns="0">
+            <a:spAutoFit/>
+          </a:bodyPr>
+          <a:lstStyle/>
+          <a:p>
+            <a:pPr algn="l"/>
+            <a:r>
+              <a:rPr sz="1000" b="0">
+                <a:solidFill>
+                  <a:srgbClr val="5B6770"/>
+                </a:solidFill>
+                <a:latin typeface="Calibri"/>
+              </a:rPr>
+              <a:t>16 tables</a:t>
+            </a:r>
+          </a:p>
+        </p:txBody>
+      </p:sp>
+      <p:sp>
+        <p:nvSpPr>
+          <p:cNvPr id="954" name="Rectangle 953"/>
+          <p:cNvSpPr/>
+          <p:nvPr/>
+        </p:nvSpPr>
+        <p:spPr>
+          <a:xfrm>
+            <a:off x="6217920" y="1874519"/>
+            <a:ext cx="2606040" cy="475488"/>
+          </a:xfrm>
+          <a:prstGeom prst="rect">
+            <a:avLst/>
+          </a:prstGeom>
+          <a:solidFill>
+            <a:srgbClr val="FFFFFF"/>
+          </a:solidFill>
+          <a:ln>
+            <a:solidFill>
+              <a:srgbClr val="D9DEDB"/>
+            </a:solidFill>
+          </a:ln>
+        </p:spPr>
+        <p:style>
+          <a:lnRef idx="1">
+            <a:schemeClr val="accent1"/>
+          </a:lnRef>
+          <a:fillRef idx="3">
+            <a:schemeClr val="accent1"/>
+          </a:fillRef>
+          <a:effectRef idx="2">
+            <a:schemeClr val="accent1"/>
+          </a:effectRef>
+          <a:fontRef idx="minor">
+            <a:schemeClr val="lt1"/>
+          </a:fontRef>
+        </p:style>
+        <p:txBody>
+          <a:bodyPr rtlCol="0" anchor="ctr"/>
+          <a:lstStyle/>
+          <a:p>
+            <a:pPr algn="ctr"/>
+          </a:p>
+        </p:txBody>
+      </p:sp>
+      <p:sp>
+        <p:nvSpPr>
+          <p:cNvPr id="955" name="TextBox 954"/>
+          <p:cNvSpPr txBox="1"/>
+          <p:nvPr/>
+        </p:nvSpPr>
+        <p:spPr>
+          <a:xfrm>
+            <a:off x="6364224" y="1984248"/>
+            <a:ext cx="2350008" cy="237744"/>
+          </a:xfrm>
+          <a:prstGeom prst="rect">
+            <a:avLst/>
+          </a:prstGeom>
+          <a:noFill/>
+        </p:spPr>
+        <p:txBody>
+          <a:bodyPr wrap="square" lIns="0" rIns="0" tIns="0" bIns="0">
+            <a:spAutoFit/>
+          </a:bodyPr>
+          <a:lstStyle/>
+          <a:p>
+            <a:pPr algn="l"/>
+            <a:r>
+              <a:rPr sz="1500" b="1">
+                <a:solidFill>
+                  <a:srgbClr val="2F6B78"/>
+                </a:solidFill>
+                <a:latin typeface="Calibri"/>
+              </a:rPr>
+              <a:t>eICU-CRD</a:t>
+            </a:r>
+          </a:p>
+        </p:txBody>
+      </p:sp>
+      <p:sp>
+        <p:nvSpPr>
+          <p:cNvPr id="956" name="TextBox 955"/>
+          <p:cNvSpPr txBox="1"/>
+          <p:nvPr/>
+        </p:nvSpPr>
+        <p:spPr>
+          <a:xfrm>
+            <a:off x="6364224" y="2212848"/>
+            <a:ext cx="2350008" cy="182880"/>
+          </a:xfrm>
+          <a:prstGeom prst="rect">
+            <a:avLst/>
+          </a:prstGeom>
+          <a:noFill/>
+        </p:spPr>
+        <p:txBody>
+          <a:bodyPr wrap="square" lIns="0" rIns="0" tIns="0" bIns="0">
+            <a:spAutoFit/>
+          </a:bodyPr>
+          <a:lstStyle/>
+          <a:p>
+            <a:pPr algn="l"/>
+            <a:r>
+              <a:rPr sz="1000" b="0">
+                <a:solidFill>
+                  <a:srgbClr val="5B6770"/>
+                </a:solidFill>
+                <a:latin typeface="Calibri"/>
+              </a:rPr>
+              <a:t>31 tables</a:t>
+            </a:r>
+          </a:p>
+        </p:txBody>
+      </p:sp>
+      <p:sp>
+        <p:nvSpPr>
+          <p:cNvPr id="957" name="Rectangle 956"/>
+          <p:cNvSpPr/>
+          <p:nvPr/>
+        </p:nvSpPr>
+        <p:spPr>
+          <a:xfrm>
+            <a:off x="8961120" y="1874519"/>
+            <a:ext cx="2423160" cy="475488"/>
+          </a:xfrm>
+          <a:prstGeom prst="rect">
+            <a:avLst/>
+          </a:prstGeom>
+          <a:solidFill>
+            <a:srgbClr val="FFFFFF"/>
+          </a:solidFill>
+          <a:ln>
+            <a:solidFill>
+              <a:srgbClr val="D9DEDB"/>
+            </a:solidFill>
+          </a:ln>
+        </p:spPr>
+        <p:style>
+          <a:lnRef idx="1">
+            <a:schemeClr val="accent1"/>
+          </a:lnRef>
+          <a:fillRef idx="3">
+            <a:schemeClr val="accent1"/>
+          </a:fillRef>
+          <a:effectRef idx="2">
+            <a:schemeClr val="accent1"/>
+          </a:effectRef>
+          <a:fontRef idx="minor">
+            <a:schemeClr val="lt1"/>
+          </a:fontRef>
+        </p:style>
+        <p:txBody>
+          <a:bodyPr rtlCol="0" anchor="ctr"/>
+          <a:lstStyle/>
+          <a:p>
+            <a:pPr algn="ctr"/>
+          </a:p>
+        </p:txBody>
+      </p:sp>
+      <p:sp>
+        <p:nvSpPr>
+          <p:cNvPr id="958" name="TextBox 957"/>
+          <p:cNvSpPr txBox="1"/>
+          <p:nvPr/>
+        </p:nvSpPr>
+        <p:spPr>
+          <a:xfrm>
+            <a:off x="9107424" y="1984248"/>
+            <a:ext cx="2167128" cy="237744"/>
+          </a:xfrm>
+          <a:prstGeom prst="rect">
+            <a:avLst/>
+          </a:prstGeom>
+          <a:noFill/>
+        </p:spPr>
+        <p:txBody>
+          <a:bodyPr wrap="square" lIns="0" rIns="0" tIns="0" bIns="0">
+            <a:spAutoFit/>
+          </a:bodyPr>
+          <a:lstStyle/>
+          <a:p>
+            <a:pPr algn="l"/>
+            <a:r>
+              <a:rPr sz="1500" b="1">
+                <a:solidFill>
+                  <a:srgbClr val="2F6B78"/>
+                </a:solidFill>
+                <a:latin typeface="Calibri"/>
+              </a:rPr>
+              <a:t>CHINOOK</a:t>
+            </a:r>
+          </a:p>
+        </p:txBody>
+      </p:sp>
+      <p:sp>
+        <p:nvSpPr>
+          <p:cNvPr id="959" name="TextBox 958"/>
+          <p:cNvSpPr txBox="1"/>
+          <p:nvPr/>
+        </p:nvSpPr>
+        <p:spPr>
+          <a:xfrm>
+            <a:off x="9107424" y="2212848"/>
+            <a:ext cx="2167128" cy="182880"/>
+          </a:xfrm>
+          <a:prstGeom prst="rect">
+            <a:avLst/>
+          </a:prstGeom>
+          <a:noFill/>
+        </p:spPr>
+        <p:txBody>
+          <a:bodyPr wrap="square" lIns="0" rIns="0" tIns="0" bIns="0">
+            <a:spAutoFit/>
+          </a:bodyPr>
+          <a:lstStyle/>
+          <a:p>
+            <a:pPr algn="l"/>
+            <a:r>
+              <a:rPr sz="1000" b="0">
+                <a:solidFill>
+                  <a:srgbClr val="5B6770"/>
+                </a:solidFill>
+                <a:latin typeface="Calibri"/>
+              </a:rPr>
+              <a:t>11 tables</a:t>
+            </a:r>
+          </a:p>
+        </p:txBody>
+      </p:sp>
+      <p:sp>
+        <p:nvSpPr>
+          <p:cNvPr id="960" name="Rounded Rectangle 959"/>
+          <p:cNvSpPr/>
+          <p:nvPr/>
+        </p:nvSpPr>
+        <p:spPr>
+          <a:xfrm>
+            <a:off x="822960" y="2432304"/>
+            <a:ext cx="2514600" cy="603504"/>
+          </a:xfrm>
+          <a:prstGeom prst="roundRect">
+            <a:avLst/>
+          </a:prstGeom>
+          <a:solidFill>
+            <a:srgbClr val="FFFFFF"/>
+          </a:solidFill>
+          <a:ln>
+            <a:solidFill>
+              <a:srgbClr val="D9DEDB"/>
+            </a:solidFill>
+          </a:ln>
+        </p:spPr>
+        <p:style>
+          <a:lnRef idx="1">
+            <a:schemeClr val="accent1"/>
+          </a:lnRef>
+          <a:fillRef idx="3">
+            <a:schemeClr val="accent1"/>
+          </a:fillRef>
+          <a:effectRef idx="2">
+            <a:schemeClr val="accent1"/>
+          </a:effectRef>
+          <a:fontRef idx="minor">
+            <a:schemeClr val="lt1"/>
+          </a:fontRef>
+        </p:style>
+        <p:txBody>
+          <a:bodyPr rtlCol="0" anchor="ctr"/>
+          <a:lstStyle/>
+          <a:p>
+            <a:pPr algn="ctr"/>
+          </a:p>
+        </p:txBody>
+      </p:sp>
+      <p:sp>
+        <p:nvSpPr>
+          <p:cNvPr id="961" name="TextBox 960"/>
+          <p:cNvSpPr txBox="1"/>
+          <p:nvPr/>
+        </p:nvSpPr>
+        <p:spPr>
+          <a:xfrm>
+            <a:off x="996696" y="2578608"/>
+            <a:ext cx="2240280" cy="292608"/>
+          </a:xfrm>
+          <a:prstGeom prst="rect">
+            <a:avLst/>
+          </a:prstGeom>
+          <a:noFill/>
+        </p:spPr>
+        <p:txBody>
+          <a:bodyPr wrap="square" lIns="0" rIns="0" tIns="0" bIns="0">
+            <a:spAutoFit/>
+          </a:bodyPr>
+          <a:lstStyle/>
+          <a:p>
+            <a:pPr algn="l"/>
+            <a:r>
+              <a:rPr sz="1700" b="1">
+                <a:solidFill>
+                  <a:srgbClr val="1F2328"/>
+                </a:solidFill>
+                <a:latin typeface="Calibri"/>
+              </a:rPr>
+              <a:t>Direct Mapping</a:t>
+            </a:r>
+          </a:p>
+        </p:txBody>
+      </p:sp>
+      <p:sp>
+        <p:nvSpPr>
+          <p:cNvPr id="962" name="Rounded Rectangle 961"/>
+          <p:cNvSpPr/>
+          <p:nvPr/>
+        </p:nvSpPr>
+        <p:spPr>
+          <a:xfrm>
+            <a:off x="3474720" y="2432304"/>
+            <a:ext cx="2606040" cy="603504"/>
+          </a:xfrm>
+          <a:prstGeom prst="roundRect">
+            <a:avLst/>
+          </a:prstGeom>
+          <a:solidFill>
+            <a:srgbClr val="FFFFFF"/>
+          </a:solidFill>
+          <a:ln>
+            <a:solidFill>
+              <a:srgbClr val="D9DEDB"/>
+            </a:solidFill>
+          </a:ln>
+        </p:spPr>
+        <p:style>
+          <a:lnRef idx="1">
+            <a:schemeClr val="accent1"/>
+          </a:lnRef>
+          <a:fillRef idx="3">
+            <a:schemeClr val="accent1"/>
+          </a:fillRef>
+          <a:effectRef idx="2">
+            <a:schemeClr val="accent1"/>
+          </a:effectRef>
+          <a:fontRef idx="minor">
+            <a:schemeClr val="lt1"/>
+          </a:fontRef>
+        </p:style>
+        <p:txBody>
+          <a:bodyPr rtlCol="0" anchor="ctr"/>
+          <a:lstStyle/>
+          <a:p>
+            <a:pPr algn="ctr"/>
+          </a:p>
+        </p:txBody>
+      </p:sp>
+      <p:sp>
+        <p:nvSpPr>
+          <p:cNvPr id="963" name="TextBox 962"/>
+          <p:cNvSpPr txBox="1"/>
+          <p:nvPr/>
+        </p:nvSpPr>
+        <p:spPr>
+          <a:xfrm>
+            <a:off x="3611879" y="2569464"/>
+            <a:ext cx="2368296" cy="329184"/>
+          </a:xfrm>
+          <a:prstGeom prst="rect">
+            <a:avLst/>
+          </a:prstGeom>
+          <a:noFill/>
+        </p:spPr>
+        <p:txBody>
+          <a:bodyPr wrap="square" lIns="0" rIns="0" tIns="0" bIns="0">
+            <a:spAutoFit/>
+          </a:bodyPr>
+          <a:lstStyle/>
+          <a:p>
+            <a:pPr algn="ctr"/>
+            <a:r>
+              <a:rPr sz="1900" b="0">
+                <a:solidFill>
+                  <a:srgbClr val="1F2328"/>
+                </a:solidFill>
+                <a:latin typeface="Calibri"/>
+              </a:rPr>
+              <a:t>731</a:t>
+            </a:r>
+          </a:p>
+        </p:txBody>
+      </p:sp>
+      <p:sp>
+        <p:nvSpPr>
+          <p:cNvPr id="964" name="Rounded Rectangle 963"/>
+          <p:cNvSpPr/>
+          <p:nvPr/>
+        </p:nvSpPr>
+        <p:spPr>
+          <a:xfrm>
+            <a:off x="6217920" y="2432304"/>
+            <a:ext cx="2606040" cy="603504"/>
+          </a:xfrm>
+          <a:prstGeom prst="roundRect">
+            <a:avLst/>
+          </a:prstGeom>
+          <a:solidFill>
+            <a:srgbClr val="FFFFFF"/>
+          </a:solidFill>
+          <a:ln>
+            <a:solidFill>
+              <a:srgbClr val="D9DEDB"/>
+            </a:solidFill>
+          </a:ln>
+        </p:spPr>
+        <p:style>
+          <a:lnRef idx="1">
+            <a:schemeClr val="accent1"/>
+          </a:lnRef>
+          <a:fillRef idx="3">
+            <a:schemeClr val="accent1"/>
+          </a:fillRef>
+          <a:effectRef idx="2">
+            <a:schemeClr val="accent1"/>
+          </a:effectRef>
+          <a:fontRef idx="minor">
+            <a:schemeClr val="lt1"/>
+          </a:fontRef>
+        </p:style>
+        <p:txBody>
+          <a:bodyPr rtlCol="0" anchor="ctr"/>
+          <a:lstStyle/>
+          <a:p>
+            <a:pPr algn="ctr"/>
+          </a:p>
+        </p:txBody>
+      </p:sp>
+      <p:sp>
+        <p:nvSpPr>
+          <p:cNvPr id="965" name="TextBox 964"/>
+          <p:cNvSpPr txBox="1"/>
+          <p:nvPr/>
+        </p:nvSpPr>
+        <p:spPr>
+          <a:xfrm>
+            <a:off x="6355080" y="2569464"/>
+            <a:ext cx="2368296" cy="329184"/>
+          </a:xfrm>
+          <a:prstGeom prst="rect">
+            <a:avLst/>
+          </a:prstGeom>
+          <a:noFill/>
+        </p:spPr>
+        <p:txBody>
+          <a:bodyPr wrap="square" lIns="0" rIns="0" tIns="0" bIns="0">
+            <a:spAutoFit/>
+          </a:bodyPr>
+          <a:lstStyle/>
+          <a:p>
+            <a:pPr algn="ctr"/>
+            <a:r>
+              <a:rPr sz="1900" b="0">
+                <a:solidFill>
+                  <a:srgbClr val="1F2328"/>
+                </a:solidFill>
+                <a:latin typeface="Calibri"/>
+              </a:rPr>
+              <a:t>665</a:t>
+            </a:r>
+          </a:p>
+        </p:txBody>
+      </p:sp>
+      <p:sp>
+        <p:nvSpPr>
+          <p:cNvPr id="966" name="Rounded Rectangle 965"/>
+          <p:cNvSpPr/>
+          <p:nvPr/>
+        </p:nvSpPr>
+        <p:spPr>
+          <a:xfrm>
+            <a:off x="8961120" y="2432304"/>
+            <a:ext cx="2423160" cy="603504"/>
+          </a:xfrm>
+          <a:prstGeom prst="roundRect">
+            <a:avLst/>
+          </a:prstGeom>
+          <a:solidFill>
+            <a:srgbClr val="FFFFFF"/>
+          </a:solidFill>
+          <a:ln>
+            <a:solidFill>
+              <a:srgbClr val="D9DEDB"/>
+            </a:solidFill>
+          </a:ln>
+        </p:spPr>
+        <p:style>
+          <a:lnRef idx="1">
+            <a:schemeClr val="accent1"/>
+          </a:lnRef>
+          <a:fillRef idx="3">
+            <a:schemeClr val="accent1"/>
+          </a:fillRef>
+          <a:effectRef idx="2">
+            <a:schemeClr val="accent1"/>
+          </a:effectRef>
+          <a:fontRef idx="minor">
+            <a:schemeClr val="lt1"/>
+          </a:fontRef>
+        </p:style>
+        <p:txBody>
+          <a:bodyPr rtlCol="0" anchor="ctr"/>
+          <a:lstStyle/>
+          <a:p>
+            <a:pPr algn="ctr"/>
+          </a:p>
+        </p:txBody>
+      </p:sp>
+      <p:sp>
+        <p:nvSpPr>
+          <p:cNvPr id="967" name="TextBox 966"/>
+          <p:cNvSpPr txBox="1"/>
+          <p:nvPr/>
+        </p:nvSpPr>
+        <p:spPr>
+          <a:xfrm>
+            <a:off x="9098280" y="2569464"/>
+            <a:ext cx="2185415" cy="329184"/>
+          </a:xfrm>
+          <a:prstGeom prst="rect">
+            <a:avLst/>
+          </a:prstGeom>
+          <a:noFill/>
+        </p:spPr>
+        <p:txBody>
+          <a:bodyPr wrap="square" lIns="0" rIns="0" tIns="0" bIns="0">
+            <a:spAutoFit/>
+          </a:bodyPr>
+          <a:lstStyle/>
+          <a:p>
+            <a:pPr algn="ctr"/>
+            <a:r>
+              <a:rPr sz="1900" b="0">
+                <a:solidFill>
+                  <a:srgbClr val="1F2328"/>
+                </a:solidFill>
+                <a:latin typeface="Calibri"/>
+              </a:rPr>
+              <a:t>102</a:t>
+            </a:r>
+          </a:p>
+        </p:txBody>
+      </p:sp>
+      <p:sp>
+        <p:nvSpPr>
+          <p:cNvPr id="968" name="Rounded Rectangle 967"/>
+          <p:cNvSpPr/>
+          <p:nvPr/>
+        </p:nvSpPr>
+        <p:spPr>
+          <a:xfrm>
+            <a:off x="822960" y="3090672"/>
+            <a:ext cx="2514600" cy="603504"/>
+          </a:xfrm>
+          <a:prstGeom prst="roundRect">
+            <a:avLst/>
+          </a:prstGeom>
+          <a:solidFill>
+            <a:srgbClr val="FFFFFF"/>
+          </a:solidFill>
+          <a:ln>
+            <a:solidFill>
+              <a:srgbClr val="D9DEDB"/>
+            </a:solidFill>
+          </a:ln>
+        </p:spPr>
+        <p:style>
+          <a:lnRef idx="1">
+            <a:schemeClr val="accent1"/>
+          </a:lnRef>
+          <a:fillRef idx="3">
+            <a:schemeClr val="accent1"/>
+          </a:fillRef>
+          <a:effectRef idx="2">
+            <a:schemeClr val="accent1"/>
+          </a:effectRef>
+          <a:fontRef idx="minor">
+            <a:schemeClr val="lt1"/>
+          </a:fontRef>
+        </p:style>
+        <p:txBody>
+          <a:bodyPr rtlCol="0" anchor="ctr"/>
+          <a:lstStyle/>
+          <a:p>
+            <a:pPr algn="ctr"/>
+          </a:p>
+        </p:txBody>
+      </p:sp>
+      <p:sp>
+        <p:nvSpPr>
+          <p:cNvPr id="969" name="TextBox 968"/>
+          <p:cNvSpPr txBox="1"/>
+          <p:nvPr/>
+        </p:nvSpPr>
+        <p:spPr>
+          <a:xfrm>
+            <a:off x="996696" y="3236976"/>
+            <a:ext cx="2240280" cy="292608"/>
+          </a:xfrm>
+          <a:prstGeom prst="rect">
+            <a:avLst/>
+          </a:prstGeom>
+          <a:noFill/>
+        </p:spPr>
+        <p:txBody>
+          <a:bodyPr wrap="square" lIns="0" rIns="0" tIns="0" bIns="0">
+            <a:spAutoFit/>
+          </a:bodyPr>
+          <a:lstStyle/>
+          <a:p>
+            <a:pPr algn="l"/>
+            <a:r>
+              <a:rPr sz="1700" b="1">
+                <a:solidFill>
+                  <a:srgbClr val="1F2328"/>
+                </a:solidFill>
+                <a:latin typeface="Calibri"/>
+              </a:rPr>
+              <a:t>LLM baseline</a:t>
+            </a:r>
+          </a:p>
+        </p:txBody>
+      </p:sp>
+      <p:sp>
+        <p:nvSpPr>
+          <p:cNvPr id="970" name="Rounded Rectangle 969"/>
+          <p:cNvSpPr/>
+          <p:nvPr/>
+        </p:nvSpPr>
+        <p:spPr>
+          <a:xfrm>
+            <a:off x="3474720" y="3090672"/>
+            <a:ext cx="2606040" cy="603504"/>
+          </a:xfrm>
+          <a:prstGeom prst="roundRect">
+            <a:avLst/>
+          </a:prstGeom>
+          <a:solidFill>
+            <a:srgbClr val="FFFFFF"/>
+          </a:solidFill>
+          <a:ln>
+            <a:solidFill>
+              <a:srgbClr val="D9DEDB"/>
+            </a:solidFill>
+          </a:ln>
+        </p:spPr>
+        <p:style>
+          <a:lnRef idx="1">
+            <a:schemeClr val="accent1"/>
+          </a:lnRef>
+          <a:fillRef idx="3">
+            <a:schemeClr val="accent1"/>
+          </a:fillRef>
+          <a:effectRef idx="2">
+            <a:schemeClr val="accent1"/>
+          </a:effectRef>
+          <a:fontRef idx="minor">
+            <a:schemeClr val="lt1"/>
+          </a:fontRef>
+        </p:style>
+        <p:txBody>
+          <a:bodyPr rtlCol="0" anchor="ctr"/>
+          <a:lstStyle/>
+          <a:p>
+            <a:pPr algn="ctr"/>
+          </a:p>
+        </p:txBody>
+      </p:sp>
+      <p:sp>
+        <p:nvSpPr>
+          <p:cNvPr id="971" name="TextBox 970"/>
+          <p:cNvSpPr txBox="1"/>
+          <p:nvPr/>
+        </p:nvSpPr>
+        <p:spPr>
+          <a:xfrm>
+            <a:off x="3611879" y="3227832"/>
+            <a:ext cx="2368296" cy="329184"/>
+          </a:xfrm>
+          <a:prstGeom prst="rect">
+            <a:avLst/>
+          </a:prstGeom>
+          <a:noFill/>
+        </p:spPr>
+        <p:txBody>
+          <a:bodyPr wrap="square" lIns="0" rIns="0" tIns="0" bIns="0">
+            <a:spAutoFit/>
+          </a:bodyPr>
+          <a:lstStyle/>
+          <a:p>
+            <a:pPr algn="ctr"/>
+            <a:r>
+              <a:rPr sz="1900" b="0">
+                <a:solidFill>
+                  <a:srgbClr val="1F2328"/>
+                </a:solidFill>
+                <a:latin typeface="Calibri"/>
+              </a:rPr>
+              <a:t>422 / 397 / 403</a:t>
+            </a:r>
+          </a:p>
+        </p:txBody>
+      </p:sp>
+      <p:sp>
+        <p:nvSpPr>
+          <p:cNvPr id="972" name="Rounded Rectangle 971"/>
+          <p:cNvSpPr/>
+          <p:nvPr/>
+        </p:nvSpPr>
+        <p:spPr>
+          <a:xfrm>
+            <a:off x="6217920" y="3090672"/>
+            <a:ext cx="2606040" cy="603504"/>
+          </a:xfrm>
+          <a:prstGeom prst="roundRect">
+            <a:avLst/>
+          </a:prstGeom>
+          <a:solidFill>
+            <a:srgbClr val="FFFFFF"/>
+          </a:solidFill>
+          <a:ln>
+            <a:solidFill>
+              <a:srgbClr val="D9DEDB"/>
+            </a:solidFill>
+          </a:ln>
+        </p:spPr>
+        <p:style>
+          <a:lnRef idx="1">
+            <a:schemeClr val="accent1"/>
+          </a:lnRef>
+          <a:fillRef idx="3">
+            <a:schemeClr val="accent1"/>
+          </a:fillRef>
+          <a:effectRef idx="2">
+            <a:schemeClr val="accent1"/>
+          </a:effectRef>
+          <a:fontRef idx="minor">
+            <a:schemeClr val="lt1"/>
+          </a:fontRef>
+        </p:style>
+        <p:txBody>
+          <a:bodyPr rtlCol="0" anchor="ctr"/>
+          <a:lstStyle/>
+          <a:p>
+            <a:pPr algn="ctr"/>
+          </a:p>
+        </p:txBody>
+      </p:sp>
+      <p:sp>
+        <p:nvSpPr>
+          <p:cNvPr id="973" name="TextBox 972"/>
+          <p:cNvSpPr txBox="1"/>
+          <p:nvPr/>
+        </p:nvSpPr>
+        <p:spPr>
+          <a:xfrm>
+            <a:off x="6355080" y="3227832"/>
+            <a:ext cx="2368296" cy="329184"/>
+          </a:xfrm>
+          <a:prstGeom prst="rect">
+            <a:avLst/>
+          </a:prstGeom>
+          <a:noFill/>
+        </p:spPr>
+        <p:txBody>
+          <a:bodyPr wrap="square" lIns="0" rIns="0" tIns="0" bIns="0">
+            <a:spAutoFit/>
+          </a:bodyPr>
+          <a:lstStyle/>
+          <a:p>
+            <a:pPr algn="ctr"/>
+            <a:r>
+              <a:rPr sz="1900" b="0">
+                <a:solidFill>
+                  <a:srgbClr val="1F2328"/>
+                </a:solidFill>
+                <a:latin typeface="Calibri"/>
+              </a:rPr>
+              <a:t>434 / 440 / 421</a:t>
+            </a:r>
+          </a:p>
+        </p:txBody>
+      </p:sp>
+      <p:sp>
+        <p:nvSpPr>
+          <p:cNvPr id="974" name="Rounded Rectangle 973"/>
+          <p:cNvSpPr/>
+          <p:nvPr/>
+        </p:nvSpPr>
+        <p:spPr>
+          <a:xfrm>
+            <a:off x="8961120" y="3090672"/>
+            <a:ext cx="2423160" cy="603504"/>
+          </a:xfrm>
+          <a:prstGeom prst="roundRect">
+            <a:avLst/>
+          </a:prstGeom>
+          <a:solidFill>
+            <a:srgbClr val="FFFFFF"/>
+          </a:solidFill>
+          <a:ln>
+            <a:solidFill>
+              <a:srgbClr val="D9DEDB"/>
+            </a:solidFill>
+          </a:ln>
+        </p:spPr>
+        <p:style>
+          <a:lnRef idx="1">
+            <a:schemeClr val="accent1"/>
+          </a:lnRef>
+          <a:fillRef idx="3">
+            <a:schemeClr val="accent1"/>
+          </a:fillRef>
+          <a:effectRef idx="2">
+            <a:schemeClr val="accent1"/>
+          </a:effectRef>
+          <a:fontRef idx="minor">
+            <a:schemeClr val="lt1"/>
+          </a:fontRef>
+        </p:style>
+        <p:txBody>
+          <a:bodyPr rtlCol="0" anchor="ctr"/>
+          <a:lstStyle/>
+          <a:p>
+            <a:pPr algn="ctr"/>
+          </a:p>
+        </p:txBody>
+      </p:sp>
+      <p:sp>
+        <p:nvSpPr>
+          <p:cNvPr id="975" name="TextBox 974"/>
+          <p:cNvSpPr txBox="1"/>
+          <p:nvPr/>
+        </p:nvSpPr>
+        <p:spPr>
+          <a:xfrm>
+            <a:off x="9098280" y="3227832"/>
+            <a:ext cx="2185415" cy="329184"/>
+          </a:xfrm>
+          <a:prstGeom prst="rect">
+            <a:avLst/>
+          </a:prstGeom>
+          <a:noFill/>
+        </p:spPr>
+        <p:txBody>
+          <a:bodyPr wrap="square" lIns="0" rIns="0" tIns="0" bIns="0">
+            <a:spAutoFit/>
+          </a:bodyPr>
+          <a:lstStyle/>
+          <a:p>
+            <a:pPr algn="ctr"/>
+            <a:r>
+              <a:rPr sz="1900" b="0">
+                <a:solidFill>
+                  <a:srgbClr val="1F2328"/>
+                </a:solidFill>
+                <a:latin typeface="Calibri"/>
+              </a:rPr>
+              <a:t>95 / 74 / 81</a:t>
+            </a:r>
+          </a:p>
+        </p:txBody>
+      </p:sp>
+      <p:sp>
+        <p:nvSpPr>
+          <p:cNvPr id="976" name="Rounded Rectangle 975"/>
+          <p:cNvSpPr/>
+          <p:nvPr/>
+        </p:nvSpPr>
+        <p:spPr>
+          <a:xfrm>
+            <a:off x="822960" y="3749039"/>
+            <a:ext cx="2514600" cy="603504"/>
+          </a:xfrm>
+          <a:prstGeom prst="roundRect">
+            <a:avLst/>
+          </a:prstGeom>
+          <a:solidFill>
+            <a:srgbClr val="FFFFFF"/>
+          </a:solidFill>
+          <a:ln>
+            <a:solidFill>
+              <a:srgbClr val="D9DEDB"/>
+            </a:solidFill>
+          </a:ln>
+        </p:spPr>
+        <p:style>
+          <a:lnRef idx="1">
+            <a:schemeClr val="accent1"/>
+          </a:lnRef>
+          <a:fillRef idx="3">
+            <a:schemeClr val="accent1"/>
+          </a:fillRef>
+          <a:effectRef idx="2">
+            <a:schemeClr val="accent1"/>
+          </a:effectRef>
+          <a:fontRef idx="minor">
+            <a:schemeClr val="lt1"/>
+          </a:fontRef>
+        </p:style>
+        <p:txBody>
+          <a:bodyPr rtlCol="0" anchor="ctr"/>
+          <a:lstStyle/>
+          <a:p>
+            <a:pPr algn="ctr"/>
+          </a:p>
+        </p:txBody>
+      </p:sp>
+      <p:sp>
+        <p:nvSpPr>
+          <p:cNvPr id="977" name="TextBox 976"/>
+          <p:cNvSpPr txBox="1"/>
+          <p:nvPr/>
+        </p:nvSpPr>
+        <p:spPr>
+          <a:xfrm>
+            <a:off x="996696" y="3895344"/>
+            <a:ext cx="2240280" cy="292608"/>
+          </a:xfrm>
+          <a:prstGeom prst="rect">
+            <a:avLst/>
+          </a:prstGeom>
+          <a:noFill/>
+        </p:spPr>
+        <p:txBody>
+          <a:bodyPr wrap="square" lIns="0" rIns="0" tIns="0" bIns="0">
+            <a:spAutoFit/>
+          </a:bodyPr>
+          <a:lstStyle/>
+          <a:p>
+            <a:pPr algn="l"/>
+            <a:r>
+              <a:rPr sz="1700" b="1">
+                <a:solidFill>
+                  <a:srgbClr val="1F2328"/>
+                </a:solidFill>
+                <a:latin typeface="Calibri"/>
+              </a:rPr>
+              <a:t>Non-Iterative</a:t>
+            </a:r>
+          </a:p>
+        </p:txBody>
+      </p:sp>
+      <p:sp>
+        <p:nvSpPr>
+          <p:cNvPr id="978" name="Rounded Rectangle 977"/>
+          <p:cNvSpPr/>
+          <p:nvPr/>
+        </p:nvSpPr>
+        <p:spPr>
+          <a:xfrm>
+            <a:off x="3474720" y="3749039"/>
+            <a:ext cx="2606040" cy="603504"/>
+          </a:xfrm>
+          <a:prstGeom prst="roundRect">
+            <a:avLst/>
+          </a:prstGeom>
+          <a:solidFill>
+            <a:srgbClr val="FFFFFF"/>
+          </a:solidFill>
+          <a:ln>
+            <a:solidFill>
+              <a:srgbClr val="D9DEDB"/>
+            </a:solidFill>
+          </a:ln>
+        </p:spPr>
+        <p:style>
+          <a:lnRef idx="1">
+            <a:schemeClr val="accent1"/>
+          </a:lnRef>
+          <a:fillRef idx="3">
+            <a:schemeClr val="accent1"/>
+          </a:fillRef>
+          <a:effectRef idx="2">
+            <a:schemeClr val="accent1"/>
+          </a:effectRef>
+          <a:fontRef idx="minor">
+            <a:schemeClr val="lt1"/>
+          </a:fontRef>
+        </p:style>
+        <p:txBody>
+          <a:bodyPr rtlCol="0" anchor="ctr"/>
+          <a:lstStyle/>
+          <a:p>
+            <a:pPr algn="ctr"/>
+          </a:p>
+        </p:txBody>
+      </p:sp>
+      <p:sp>
+        <p:nvSpPr>
+          <p:cNvPr id="979" name="TextBox 978"/>
+          <p:cNvSpPr txBox="1"/>
+          <p:nvPr/>
+        </p:nvSpPr>
+        <p:spPr>
+          <a:xfrm>
+            <a:off x="3611879" y="3886200"/>
+            <a:ext cx="2368296" cy="329184"/>
+          </a:xfrm>
+          <a:prstGeom prst="rect">
+            <a:avLst/>
+          </a:prstGeom>
+          <a:noFill/>
+        </p:spPr>
+        <p:txBody>
+          <a:bodyPr wrap="square" lIns="0" rIns="0" tIns="0" bIns="0">
+            <a:spAutoFit/>
+          </a:bodyPr>
+          <a:lstStyle/>
+          <a:p>
+            <a:pPr algn="ctr"/>
+            <a:r>
+              <a:rPr sz="1800" b="0">
+                <a:solidFill>
+                  <a:srgbClr val="1F2328"/>
+                </a:solidFill>
+                <a:latin typeface="Calibri"/>
+              </a:rPr>
+              <a:t>29 / 61 / 18</a:t>
+            </a:r>
+          </a:p>
+        </p:txBody>
+      </p:sp>
+      <p:sp>
+        <p:nvSpPr>
+          <p:cNvPr id="980" name="Rounded Rectangle 979"/>
+          <p:cNvSpPr/>
+          <p:nvPr/>
+        </p:nvSpPr>
+        <p:spPr>
+          <a:xfrm>
+            <a:off x="6217920" y="3749039"/>
+            <a:ext cx="2606040" cy="603504"/>
+          </a:xfrm>
+          <a:prstGeom prst="roundRect">
+            <a:avLst/>
+          </a:prstGeom>
+          <a:solidFill>
+            <a:srgbClr val="FFFFFF"/>
+          </a:solidFill>
+          <a:ln>
+            <a:solidFill>
+              <a:srgbClr val="D9DEDB"/>
+            </a:solidFill>
+          </a:ln>
+        </p:spPr>
+        <p:style>
+          <a:lnRef idx="1">
+            <a:schemeClr val="accent1"/>
+          </a:lnRef>
+          <a:fillRef idx="3">
+            <a:schemeClr val="accent1"/>
+          </a:fillRef>
+          <a:effectRef idx="2">
+            <a:schemeClr val="accent1"/>
+          </a:effectRef>
+          <a:fontRef idx="minor">
+            <a:schemeClr val="lt1"/>
+          </a:fontRef>
+        </p:style>
+        <p:txBody>
+          <a:bodyPr rtlCol="0" anchor="ctr"/>
+          <a:lstStyle/>
+          <a:p>
+            <a:pPr algn="ctr"/>
+          </a:p>
+        </p:txBody>
+      </p:sp>
+      <p:sp>
+        <p:nvSpPr>
+          <p:cNvPr id="981" name="TextBox 980"/>
+          <p:cNvSpPr txBox="1"/>
+          <p:nvPr/>
+        </p:nvSpPr>
+        <p:spPr>
+          <a:xfrm>
+            <a:off x="6355080" y="3886200"/>
+            <a:ext cx="2368296" cy="329184"/>
+          </a:xfrm>
+          <a:prstGeom prst="rect">
+            <a:avLst/>
+          </a:prstGeom>
+          <a:noFill/>
+        </p:spPr>
+        <p:txBody>
+          <a:bodyPr wrap="square" lIns="0" rIns="0" tIns="0" bIns="0">
+            <a:spAutoFit/>
+          </a:bodyPr>
+          <a:lstStyle/>
+          <a:p>
+            <a:pPr algn="ctr"/>
+            <a:r>
+              <a:rPr sz="1800" b="0">
+                <a:solidFill>
+                  <a:srgbClr val="1F2328"/>
+                </a:solidFill>
+                <a:latin typeface="Calibri"/>
+              </a:rPr>
+              <a:t>39 / 220 / 27</a:t>
+            </a:r>
+          </a:p>
+        </p:txBody>
+      </p:sp>
+      <p:sp>
+        <p:nvSpPr>
+          <p:cNvPr id="982" name="Rounded Rectangle 981"/>
+          <p:cNvSpPr/>
+          <p:nvPr/>
+        </p:nvSpPr>
+        <p:spPr>
+          <a:xfrm>
+            <a:off x="8961120" y="3749039"/>
+            <a:ext cx="2423160" cy="603504"/>
+          </a:xfrm>
+          <a:prstGeom prst="roundRect">
+            <a:avLst/>
+          </a:prstGeom>
+          <a:solidFill>
+            <a:srgbClr val="FFFFFF"/>
+          </a:solidFill>
+          <a:ln>
+            <a:solidFill>
+              <a:srgbClr val="D9DEDB"/>
+            </a:solidFill>
+          </a:ln>
+        </p:spPr>
+        <p:style>
+          <a:lnRef idx="1">
+            <a:schemeClr val="accent1"/>
+          </a:lnRef>
+          <a:fillRef idx="3">
+            <a:schemeClr val="accent1"/>
+          </a:fillRef>
+          <a:effectRef idx="2">
+            <a:schemeClr val="accent1"/>
+          </a:effectRef>
+          <a:fontRef idx="minor">
+            <a:schemeClr val="lt1"/>
+          </a:fontRef>
+        </p:style>
+        <p:txBody>
+          <a:bodyPr rtlCol="0" anchor="ctr"/>
+          <a:lstStyle/>
+          <a:p>
+            <a:pPr algn="ctr"/>
+          </a:p>
+        </p:txBody>
+      </p:sp>
+      <p:sp>
+        <p:nvSpPr>
+          <p:cNvPr id="983" name="TextBox 982"/>
+          <p:cNvSpPr txBox="1"/>
+          <p:nvPr/>
+        </p:nvSpPr>
+        <p:spPr>
+          <a:xfrm>
+            <a:off x="9098280" y="3886200"/>
+            <a:ext cx="2185415" cy="329184"/>
+          </a:xfrm>
+          <a:prstGeom prst="rect">
+            <a:avLst/>
+          </a:prstGeom>
+          <a:noFill/>
+        </p:spPr>
+        <p:txBody>
+          <a:bodyPr wrap="square" lIns="0" rIns="0" tIns="0" bIns="0">
+            <a:spAutoFit/>
+          </a:bodyPr>
+          <a:lstStyle/>
+          <a:p>
+            <a:pPr algn="ctr"/>
+            <a:r>
+              <a:rPr sz="1800" b="0">
+                <a:solidFill>
+                  <a:srgbClr val="1F2328"/>
+                </a:solidFill>
+                <a:latin typeface="Calibri"/>
+              </a:rPr>
+              <a:t>24 / 35 / 14</a:t>
+            </a:r>
+          </a:p>
+        </p:txBody>
+      </p:sp>
+      <p:sp>
+        <p:nvSpPr>
+          <p:cNvPr id="984" name="Rounded Rectangle 983"/>
+          <p:cNvSpPr/>
+          <p:nvPr/>
+        </p:nvSpPr>
+        <p:spPr>
+          <a:xfrm>
+            <a:off x="822960" y="4407408"/>
+            <a:ext cx="2514600" cy="603504"/>
+          </a:xfrm>
+          <a:prstGeom prst="roundRect">
+            <a:avLst/>
+          </a:prstGeom>
+          <a:solidFill>
+            <a:srgbClr val="E9EEEB"/>
+          </a:solidFill>
+          <a:ln>
+            <a:solidFill>
+              <a:srgbClr val="D9DEDB"/>
+            </a:solidFill>
+          </a:ln>
+        </p:spPr>
+        <p:style>
+          <a:lnRef idx="1">
+            <a:schemeClr val="accent1"/>
+          </a:lnRef>
+          <a:fillRef idx="3">
+            <a:schemeClr val="accent1"/>
+          </a:fillRef>
+          <a:effectRef idx="2">
+            <a:schemeClr val="accent1"/>
+          </a:effectRef>
+          <a:fontRef idx="minor">
+            <a:schemeClr val="lt1"/>
+          </a:fontRef>
+        </p:style>
+        <p:txBody>
+          <a:bodyPr rtlCol="0" anchor="ctr"/>
+          <a:lstStyle/>
+          <a:p>
+            <a:pPr algn="ctr"/>
+          </a:p>
+        </p:txBody>
+      </p:sp>
+      <p:sp>
+        <p:nvSpPr>
+          <p:cNvPr id="985" name="TextBox 984"/>
+          <p:cNvSpPr txBox="1"/>
+          <p:nvPr/>
+        </p:nvSpPr>
+        <p:spPr>
+          <a:xfrm>
+            <a:off x="996696" y="4553712"/>
+            <a:ext cx="2240280" cy="292608"/>
+          </a:xfrm>
+          <a:prstGeom prst="rect">
+            <a:avLst/>
+          </a:prstGeom>
+          <a:noFill/>
+        </p:spPr>
+        <p:txBody>
+          <a:bodyPr wrap="square" lIns="0" rIns="0" tIns="0" bIns="0">
+            <a:spAutoFit/>
+          </a:bodyPr>
+          <a:lstStyle/>
+          <a:p>
+            <a:pPr algn="l"/>
+            <a:r>
+              <a:rPr sz="1700" b="1">
+                <a:solidFill>
+                  <a:srgbClr val="0B6E4F"/>
+                </a:solidFill>
+                <a:latin typeface="Calibri"/>
+              </a:rPr>
+              <a:t>RIGOR</a:t>
+            </a:r>
+          </a:p>
+        </p:txBody>
+      </p:sp>
+      <p:sp>
+        <p:nvSpPr>
+          <p:cNvPr id="986" name="Rounded Rectangle 985"/>
+          <p:cNvSpPr/>
+          <p:nvPr/>
+        </p:nvSpPr>
+        <p:spPr>
+          <a:xfrm>
+            <a:off x="3474720" y="4407408"/>
+            <a:ext cx="2606040" cy="603504"/>
+          </a:xfrm>
+          <a:prstGeom prst="roundRect">
+            <a:avLst/>
+          </a:prstGeom>
+          <a:solidFill>
+            <a:srgbClr val="E9EEEB"/>
+          </a:solidFill>
+          <a:ln>
+            <a:solidFill>
+              <a:srgbClr val="D9DEDB"/>
+            </a:solidFill>
+          </a:ln>
+        </p:spPr>
+        <p:style>
+          <a:lnRef idx="1">
+            <a:schemeClr val="accent1"/>
+          </a:lnRef>
+          <a:fillRef idx="3">
+            <a:schemeClr val="accent1"/>
+          </a:fillRef>
+          <a:effectRef idx="2">
+            <a:schemeClr val="accent1"/>
+          </a:effectRef>
+          <a:fontRef idx="minor">
+            <a:schemeClr val="lt1"/>
+          </a:fontRef>
+        </p:style>
+        <p:txBody>
+          <a:bodyPr rtlCol="0" anchor="ctr"/>
+          <a:lstStyle/>
+          <a:p>
+            <a:pPr algn="ctr"/>
+          </a:p>
+        </p:txBody>
+      </p:sp>
+      <p:sp>
+        <p:nvSpPr>
+          <p:cNvPr id="987" name="TextBox 986"/>
+          <p:cNvSpPr txBox="1"/>
+          <p:nvPr/>
+        </p:nvSpPr>
+        <p:spPr>
+          <a:xfrm>
+            <a:off x="3611879" y="4544568"/>
+            <a:ext cx="2368296" cy="329184"/>
+          </a:xfrm>
+          <a:prstGeom prst="rect">
+            <a:avLst/>
+          </a:prstGeom>
+          <a:noFill/>
+        </p:spPr>
+        <p:txBody>
+          <a:bodyPr wrap="square" lIns="0" rIns="0" tIns="0" bIns="0">
+            <a:spAutoFit/>
+          </a:bodyPr>
+          <a:lstStyle/>
+          <a:p>
+            <a:pPr algn="ctr"/>
+            <a:r>
+              <a:rPr sz="1800" b="1">
+                <a:solidFill>
+                  <a:srgbClr val="0B6E4F"/>
+                </a:solidFill>
+                <a:latin typeface="Calibri"/>
+              </a:rPr>
+              <a:t>20 / 23 / 3</a:t>
+            </a:r>
+          </a:p>
+        </p:txBody>
+      </p:sp>
+      <p:sp>
+        <p:nvSpPr>
+          <p:cNvPr id="988" name="Rounded Rectangle 987"/>
+          <p:cNvSpPr/>
+          <p:nvPr/>
+        </p:nvSpPr>
+        <p:spPr>
+          <a:xfrm>
+            <a:off x="6217920" y="4407408"/>
+            <a:ext cx="2606040" cy="603504"/>
+          </a:xfrm>
+          <a:prstGeom prst="roundRect">
+            <a:avLst/>
+          </a:prstGeom>
+          <a:solidFill>
+            <a:srgbClr val="E9EEEB"/>
+          </a:solidFill>
+          <a:ln>
+            <a:solidFill>
+              <a:srgbClr val="D9DEDB"/>
+            </a:solidFill>
+          </a:ln>
+        </p:spPr>
+        <p:style>
+          <a:lnRef idx="1">
+            <a:schemeClr val="accent1"/>
+          </a:lnRef>
+          <a:fillRef idx="3">
+            <a:schemeClr val="accent1"/>
+          </a:fillRef>
+          <a:effectRef idx="2">
+            <a:schemeClr val="accent1"/>
+          </a:effectRef>
+          <a:fontRef idx="minor">
+            <a:schemeClr val="lt1"/>
+          </a:fontRef>
+        </p:style>
+        <p:txBody>
+          <a:bodyPr rtlCol="0" anchor="ctr"/>
+          <a:lstStyle/>
+          <a:p>
+            <a:pPr algn="ctr"/>
+          </a:p>
+        </p:txBody>
+      </p:sp>
+      <p:sp>
+        <p:nvSpPr>
+          <p:cNvPr id="989" name="TextBox 988"/>
+          <p:cNvSpPr txBox="1"/>
+          <p:nvPr/>
+        </p:nvSpPr>
+        <p:spPr>
+          <a:xfrm>
+            <a:off x="6355080" y="4544568"/>
+            <a:ext cx="2368296" cy="329184"/>
+          </a:xfrm>
+          <a:prstGeom prst="rect">
+            <a:avLst/>
+          </a:prstGeom>
+          <a:noFill/>
+        </p:spPr>
+        <p:txBody>
+          <a:bodyPr wrap="square" lIns="0" rIns="0" tIns="0" bIns="0">
+            <a:spAutoFit/>
+          </a:bodyPr>
+          <a:lstStyle/>
+          <a:p>
+            <a:pPr algn="ctr"/>
+            <a:r>
+              <a:rPr sz="1800" b="1">
+                <a:solidFill>
+                  <a:srgbClr val="0B6E4F"/>
+                </a:solidFill>
+                <a:latin typeface="Calibri"/>
+              </a:rPr>
+              <a:t>2 / 2 / 26</a:t>
+            </a:r>
+          </a:p>
+        </p:txBody>
+      </p:sp>
+      <p:sp>
+        <p:nvSpPr>
+          <p:cNvPr id="990" name="Rounded Rectangle 989"/>
+          <p:cNvSpPr/>
+          <p:nvPr/>
+        </p:nvSpPr>
+        <p:spPr>
+          <a:xfrm>
+            <a:off x="8961120" y="4407408"/>
+            <a:ext cx="2423160" cy="603504"/>
+          </a:xfrm>
+          <a:prstGeom prst="roundRect">
+            <a:avLst/>
+          </a:prstGeom>
+          <a:solidFill>
+            <a:srgbClr val="E9EEEB"/>
+          </a:solidFill>
+          <a:ln>
+            <a:solidFill>
+              <a:srgbClr val="D9DEDB"/>
+            </a:solidFill>
+          </a:ln>
+        </p:spPr>
+        <p:style>
+          <a:lnRef idx="1">
+            <a:schemeClr val="accent1"/>
+          </a:lnRef>
+          <a:fillRef idx="3">
+            <a:schemeClr val="accent1"/>
+          </a:fillRef>
+          <a:effectRef idx="2">
+            <a:schemeClr val="accent1"/>
+          </a:effectRef>
+          <a:fontRef idx="minor">
+            <a:schemeClr val="lt1"/>
+          </a:fontRef>
+        </p:style>
+        <p:txBody>
+          <a:bodyPr rtlCol="0" anchor="ctr"/>
+          <a:lstStyle/>
+          <a:p>
+            <a:pPr algn="ctr"/>
+          </a:p>
+        </p:txBody>
+      </p:sp>
+      <p:sp>
+        <p:nvSpPr>
+          <p:cNvPr id="991" name="TextBox 990"/>
+          <p:cNvSpPr txBox="1"/>
+          <p:nvPr/>
+        </p:nvSpPr>
+        <p:spPr>
+          <a:xfrm>
+            <a:off x="9098280" y="4544568"/>
+            <a:ext cx="2185415" cy="329184"/>
+          </a:xfrm>
+          <a:prstGeom prst="rect">
+            <a:avLst/>
+          </a:prstGeom>
+          <a:noFill/>
+        </p:spPr>
+        <p:txBody>
+          <a:bodyPr wrap="square" lIns="0" rIns="0" tIns="0" bIns="0">
+            <a:spAutoFit/>
+          </a:bodyPr>
+          <a:lstStyle/>
+          <a:p>
+            <a:pPr algn="ctr"/>
+            <a:r>
+              <a:rPr sz="1800" b="1">
+                <a:solidFill>
+                  <a:srgbClr val="0B6E4F"/>
+                </a:solidFill>
+                <a:latin typeface="Calibri"/>
+              </a:rPr>
+              <a:t>0 / 0 / 0</a:t>
+            </a:r>
+          </a:p>
+        </p:txBody>
+      </p:sp>
+      <p:sp>
+        <p:nvSpPr>
+          <p:cNvPr id="992" name="Rounded Rectangle 991"/>
+          <p:cNvSpPr/>
+          <p:nvPr/>
+        </p:nvSpPr>
+        <p:spPr>
+          <a:xfrm>
+            <a:off x="822960" y="5221224"/>
+            <a:ext cx="10561320" cy="530352"/>
+          </a:xfrm>
+          <a:prstGeom prst="roundRect">
+            <a:avLst/>
+          </a:prstGeom>
+          <a:solidFill>
+            <a:srgbClr val="FFFFFF"/>
+          </a:solidFill>
+          <a:ln>
+            <a:solidFill>
+              <a:srgbClr val="D9DEDB"/>
+            </a:solidFill>
+          </a:ln>
+        </p:spPr>
+        <p:style>
+          <a:lnRef idx="1">
+            <a:schemeClr val="accent1"/>
+          </a:lnRef>
+          <a:fillRef idx="3">
+            <a:schemeClr val="accent1"/>
+          </a:fillRef>
+          <a:effectRef idx="2">
+            <a:schemeClr val="accent1"/>
+          </a:effectRef>
+          <a:fontRef idx="minor">
+            <a:schemeClr val="lt1"/>
+          </a:fontRef>
+        </p:style>
+        <p:txBody>
+          <a:bodyPr rtlCol="0" anchor="ctr"/>
+          <a:lstStyle/>
+          <a:p>
+            <a:pPr algn="ctr"/>
+          </a:p>
+        </p:txBody>
+      </p:sp>
+      <p:sp>
+        <p:nvSpPr>
+          <p:cNvPr id="993" name="TextBox 992"/>
+          <p:cNvSpPr txBox="1"/>
+          <p:nvPr/>
+        </p:nvSpPr>
+        <p:spPr>
+          <a:xfrm>
+            <a:off x="1024128" y="5340096"/>
+            <a:ext cx="10149840" cy="329184"/>
+          </a:xfrm>
+          <a:prstGeom prst="rect">
+            <a:avLst/>
+          </a:prstGeom>
+          <a:noFill/>
+        </p:spPr>
+        <p:txBody>
+          <a:bodyPr wrap="square" lIns="0" rIns="0" tIns="0" bIns="0">
+            <a:spAutoFit/>
+          </a:bodyPr>
+          <a:lstStyle/>
+          <a:p>
+            <a:pPr algn="l"/>
+            <a:r>
+              <a:rPr sz="1700" b="1">
+                <a:solidFill>
+                  <a:srgbClr val="1F2328"/>
+                </a:solidFill>
+                <a:latin typeface="Calibri"/>
+              </a:rPr>
+              <a:t>RIGOR improves on Non-Iterative in 9/9 matched runs; Chinook has zero findings in all 3.</a:t>
+            </a:r>
+          </a:p>
+        </p:txBody>
+      </p:sp>
+      <p:sp>
+        <p:nvSpPr>
+          <p:cNvPr id="994" name="TextBox 993"/>
+          <p:cNvSpPr txBox="1"/>
+          <p:nvPr/>
+        </p:nvSpPr>
+        <p:spPr>
+          <a:xfrm>
+            <a:off x="850392" y="5925312"/>
+            <a:ext cx="10789920" cy="246888"/>
+          </a:xfrm>
+          <a:prstGeom prst="rect">
+            <a:avLst/>
+          </a:prstGeom>
+          <a:noFill/>
+        </p:spPr>
+        <p:txBody>
+          <a:bodyPr wrap="square" lIns="0" rIns="0" tIns="0" bIns="0">
+            <a:spAutoFit/>
+          </a:bodyPr>
+          <a:lstStyle/>
+          <a:p>
+            <a:pPr algn="l"/>
+            <a:r>
+              <a:rPr sz="1200" b="0">
+                <a:solidFill>
+                  <a:srgbClr val="5B6770"/>
+                </a:solidFill>
+                <a:latin typeface="Calibri"/>
+              </a:rPr>
+              <a:t>Numbers in each LLM cell: Claude / Mistral / DeepSeek. Direct Mapping uses no LLM.</a:t>
+            </a:r>
+          </a:p>
+        </p:txBody>
+      </p:sp>
+      <p:sp>
+        <p:nvSpPr>
+          <p:cNvPr id="995" name="TextBox 994"/>
+          <p:cNvSpPr txBox="1"/>
+          <p:nvPr/>
+        </p:nvSpPr>
+        <p:spPr>
+          <a:xfrm>
+            <a:off x="850392" y="6208776"/>
+            <a:ext cx="10789920" cy="274320"/>
+          </a:xfrm>
+          <a:prstGeom prst="rect">
+            <a:avLst/>
+          </a:prstGeom>
+          <a:noFill/>
+        </p:spPr>
+        <p:txBody>
+          <a:bodyPr wrap="square" lIns="0" rIns="0" tIns="0" bIns="0">
+            <a:spAutoFit/>
+          </a:bodyPr>
+          <a:lstStyle/>
+          <a:p>
+            <a:pPr algn="l"/>
+            <a:r>
+              <a:rPr sz="1200" b="0">
+                <a:solidFill>
+                  <a:srgbClr val="5B6770"/>
+                </a:solidFill>
+                <a:latin typeface="Calibri"/>
+              </a:rPr>
+              <a:t>Interpret carefully: many findings concern missing annotations; critical P19 remains in 3/9 RIGOR runs. Source: Table 7.</a:t>
             </a:r>
           </a:p>
         </p:txBody>

</xml_diff>

<commit_message>
Phase 5: future-work slide (schemas to instances) and BURR corrections
Slide 22 becomes a three-step flow: synthetic instance rows + drug-label
documentation -> a verified OWL candidate association with provenance and
no causal axiom. After reading the BURR paper: slide 20 now says 'highest F1
among the compared ontology-learning systems', the incorrect 'LLMs trail
rule-based' strip is removed, the matching rule follows BURR Section 4, and
the notes carry a prepared answer about Gemini 2.5 Pro. Slide 5 preview reworded.

Co-Authored-By: Claude Opus 5.5 <noreply@anthropic.com>
Claude-Session: https://claude.ai/code/session_01KcycczqUBG98FnzsgJYAW8
</commit_message>
<xml_diff>
--- a/presentation/RIGOR_ISWC2026.pptx
+++ b/presentation/RIGOR_ISWC2026.pptx
@@ -5125,7 +5125,7 @@
           </a:p>
           <a:p>
             <a:r>
-              <a:t>Second: is that link back to the data real? BURR is an external benchmark that asks exactly this. A system must say which part of the database each ontology element comes from: which table becomes a class, which foreign key becomes a relation, which column becomes an attribute. BURR compares that mapping with a gold-standard mapping and reports F1 for each type. RIGOR's provenance annotations give us this mapping directly; we export them as D2RQ. On the ISWC scenario, RIGOR has the best F1 for classes, relations and attributes. BURR's authors found that LLM methods trail rule-based systems on this task; here RIGOR leads both. It is one scenario, with Claude.</a:t>
+              <a:t>Second: is that link back to the data real? BURR is an external benchmark that asks exactly this. A system must say which part of the database each ontology element comes from: which table becomes a class, which foreign key becomes a relation, which column becomes an attribute. BURR compares that mapping with a gold-standard mapping and reports F1 for each type. RIGOR's provenance annotations give us this mapping directly; we export them as D2RQ. On the ISWC scenario, RIGOR has the highest F1 for classes, relations and attributes among the compared ontology-learning systems, including both rule-based ones. It is one scenario, with Claude.</a:t>
             </a:r>
           </a:p>
           <a:p/>
@@ -5141,7 +5141,18 @@
           </a:p>
           <a:p>
             <a:r>
-              <a:t>SOURCE AND SCOPE: Paper Table 13, Strategy 8. BURR = Laskowski et al., PACMMOD 2025. Left-card elements are illustrative, not the gold standard's actual names.</a:t>
+              <a:t>SOURCE AND SCOPE: Paper Table 13, Strategy 8. BURR = Laskowski et al., PACMMOD 2025. Matching rule: BURR Section 4, Eq. 3. Left-card elements are illustrative, not the gold standard's actual names.</a:t>
+            </a:r>
+          </a:p>
+          <a:p/>
+          <a:p>
+            <a:r>
+              <a:t>DO NOT SAY: 'BURR found LLMs trail rule-based systems'. BURR's results show Gemini 2.5 Pro ahead of the rule-based systems overall (rule-based win only on NPD).</a:t>
+            </a:r>
+          </a:p>
+          <a:p>
+            <a:r>
+              <a:t>IF ASKED ABOUT GEMINI 2.5 PRO (BURR Table 3, ISWC .65 / .68 / .56): In BURR it is a general-purpose LLM prompted with few-shot BURR-style examples and a checklist to write the D2RQ mapping directly. It is a mapping generator, not an ontology-learning system that builds an enriched ontology, so we compare with the ontology-learning systems. Against it, RIGOR's class F1 is higher, relations are on par, and attributes are lower; RIGOR additionally produces labels, hierarchy and provenance. (It is prompted, not fine-tuned.)</a:t>
             </a:r>
           </a:p>
         </p:txBody>
@@ -5286,15 +5297,6 @@
           </a:bodyPr>
           <a:lstStyle/>
           <a:p>
-            <a:pPr indent="0" lvl="0" marL="0" rtl="0" algn="l">
-              <a:spcBef>
-                <a:spcPts val="0"/>
-              </a:spcBef>
-              <a:spcAft>
-                <a:spcPts val="0"/>
-              </a:spcAft>
-              <a:buNone/>
-            </a:pPr>
             <a:r>
               <a:rPr lang="en-US" sz="1200">
                 <a:solidFill>
@@ -5305,20 +5307,10 @@
                 <a:cs typeface="Calibri"/>
                 <a:sym typeface="Calibri"/>
               </a:rPr>
-              <a:t>[12:52–13:40]  SPOKEN SCRIPT (77 words)</a:t>
-            </a:r>
-            <a:endParaRPr/>
-          </a:p>
-          <a:p>
-            <a:pPr indent="0" lvl="0" marL="0" rtl="0" algn="l">
-              <a:spcBef>
-                <a:spcPts val="0"/>
-              </a:spcBef>
-              <a:spcAft>
-                <a:spcPts val="0"/>
-              </a:spcAft>
-              <a:buNone/>
-            </a:pPr>
+              <a:t>[11:55–12:55]  SPOKEN SCRIPT (interim; final wording in Phase 6)</a:t>
+            </a:r>
+          </a:p>
+          <a:p>
             <a:r>
               <a:rPr lang="en-US" sz="1200">
                 <a:solidFill>
@@ -5329,43 +5321,11 @@
                 <a:cs typeface="Calibri"/>
                 <a:sym typeface="Calibri"/>
               </a:rPr>
-              <a:t>Two challenges remain. First, the deterministic seed covers the cleaned schema, but enrichment does not always preserve every column; our embedding-based coverage proxy ranges from 0.77 to 1.00. Second, validation still misses some modeling pitfalls, and disjointness is rare. These suggest feeding validator feedback into generation, using instance-level signals where documentation is weak, and incorporating symbolic reasoning. We have not yet measured downstream OBDA or knowledge-graph tasks, and the expert study covers only four tables.</a:t>
-            </a:r>
-            <a:endParaRPr/>
-          </a:p>
-          <a:p>
-            <a:pPr indent="0" lvl="0" marL="0" rtl="0" algn="l">
-              <a:spcBef>
-                <a:spcPts val="0"/>
-              </a:spcBef>
-              <a:spcAft>
-                <a:spcPts val="0"/>
-              </a:spcAft>
-              <a:buNone/>
-            </a:pPr>
-            <a:r>
-              <a:t/>
-            </a:r>
-            <a:endParaRPr sz="1200">
-              <a:solidFill>
-                <a:schemeClr val="dk1"/>
-              </a:solidFill>
-              <a:latin typeface="Calibri"/>
-              <a:ea typeface="Calibri"/>
-              <a:cs typeface="Calibri"/>
-              <a:sym typeface="Calibri"/>
-            </a:endParaRPr>
-          </a:p>
-          <a:p>
-            <a:pPr indent="0" lvl="0" marL="0" rtl="0" algn="l">
-              <a:spcBef>
-                <a:spcPts val="0"/>
-              </a:spcBef>
-              <a:spcAft>
-                <a:spcPts val="0"/>
-              </a:spcAft>
-              <a:buNone/>
-            </a:pPr>
+              <a:t>Where next? Today RIGOR reads schemas and documentation. The next step is to let the data speak. Imagine several patients whose records show bone marrow depression after cisplatin cycles. The rows alone show a pattern; the drug label tells us bone-marrow suppression is a known side effect of cisplatin. Together, they let RIGOR propose new knowledge: a candidate association between cisplatin and bone marrow depression, with provenance to both sources. Note the word candidate. Co-occurrence is not causation: gemcitabine, radiotherapy or cirrhosis can also suppress the marrow. So the ontology records a reviewable hypothesis, not a causal axiom, for an expert to confirm. Instance data also helps right away: it shows how BM_DEP is coded. And we want validator and reasoner feedback inside the loop.</a:t>
+            </a:r>
+          </a:p>
+          <a:p/>
+          <a:p>
             <a:r>
               <a:rPr lang="en-US" sz="1200">
                 <a:solidFill>
@@ -5376,20 +5336,10 @@
                 <a:cs typeface="Calibri"/>
                 <a:sym typeface="Calibri"/>
               </a:rPr>
-              <a:t>PRESENTER / POINTER: Two cards only. Avoid enumerating every supplementary limitation.</a:t>
-            </a:r>
-            <a:endParaRPr/>
-          </a:p>
-          <a:p>
-            <a:pPr indent="0" lvl="0" marL="0" rtl="0" algn="l">
-              <a:spcBef>
-                <a:spcPts val="0"/>
-              </a:spcBef>
-              <a:spcAft>
-                <a:spcPts val="0"/>
-              </a:spcAft>
-              <a:buNone/>
-            </a:pPr>
+              <a:t>PRESENTER / POINTER: Left to right: rows, label, code. Say 'candidate' or 'may have contributed', never 'caused'.</a:t>
+            </a:r>
+          </a:p>
+          <a:p>
             <a:r>
               <a:rPr lang="en-US" sz="1200">
                 <a:solidFill>
@@ -5400,20 +5350,10 @@
                 <a:cs typeface="Calibri"/>
                 <a:sym typeface="Calibri"/>
               </a:rPr>
-              <a:t>AUDIENCE TAKEAWAY: Final fidelity and semantic validation remain open work.</a:t>
-            </a:r>
-            <a:endParaRPr/>
-          </a:p>
-          <a:p>
-            <a:pPr indent="0" lvl="0" marL="0" rtl="0" algn="l">
-              <a:spcBef>
-                <a:spcPts val="0"/>
-              </a:spcBef>
-              <a:spcAft>
-                <a:spcPts val="0"/>
-              </a:spcAft>
-              <a:buNone/>
-            </a:pPr>
+              <a:t>AUDIENCE TAKEAWAY: Instances plus documentation can propose knowledge; experts confirm it.</a:t>
+            </a:r>
+          </a:p>
+          <a:p>
             <a:r>
               <a:rPr lang="en-US" sz="1200">
                 <a:solidFill>
@@ -5424,33 +5364,8 @@
                 <a:cs typeface="Calibri"/>
                 <a:sym typeface="Calibri"/>
               </a:rPr>
-              <a:t>SOURCE AND SCOPE: Paper §5 limitations and §4.7 evaluation; future steps grounded in conclusion.</a:t>
-            </a:r>
-            <a:endParaRPr/>
-          </a:p>
-          <a:p>
-            <a:pPr indent="0" lvl="0" marL="0" rtl="0" algn="l">
-              <a:spcBef>
-                <a:spcPts val="0"/>
-              </a:spcBef>
-              <a:spcAft>
-                <a:spcPts val="0"/>
-              </a:spcAft>
-              <a:buNone/>
-            </a:pPr>
-            <a:r>
-              <a:rPr lang="en-US" sz="1200">
-                <a:solidFill>
-                  <a:schemeClr val="dk1"/>
-                </a:solidFill>
-                <a:latin typeface="Calibri"/>
-                <a:ea typeface="Calibri"/>
-                <a:cs typeface="Calibri"/>
-                <a:sym typeface="Calibri"/>
-              </a:rPr>
-              <a:t>Timing targets include normal visual pauses; verify with a recorded rehearsal.</a:t>
-            </a:r>
-            <a:endParaRPr/>
+              <a:t>SOURCE AND SCOPE: Paper Section 5 (instance-level signals, OOPS!/tool feedback, symbolic reasoning). Rows are synthetic. The OWL excerpt is verified (presentation/excerpts/slide22_future_candidate.omn): a typed individual with facts and provenance, no causal axiom. If asked why not OWL causation: OWL reasoning is deductive and open-world; it cannot derive causation from statistics, and 'Cisplatin SubClassOf causes some BoneMarrowDepression' would wrongly claim it for every case.</a:t>
+            </a:r>
           </a:p>
         </p:txBody>
       </p:sp>
@@ -40415,7 +40330,7 @@
                 <a:cs typeface="Calibri"/>
                 <a:sym typeface="Calibri"/>
               </a:rPr>
-              <a:t>RIGOR keeps the link to the data: best on BURR.</a:t>
+              <a:t>RIGOR keeps the link to the data.</a:t>
             </a:r>
             <a:endParaRPr/>
           </a:p>
@@ -40468,7 +40383,7 @@
                 <a:cs typeface="Calibri"/>
                 <a:sym typeface="Calibri"/>
               </a:rPr>
-              <a:t>BURR (Laskowski et al., 2025) scores ontology learning against a gold standard  ·  ISWC scenario</a:t>
+              <a:t>BURR benchmark (Laskowski et al., 2025)  ·  ISWC scenario  ·  highest F1 among the compared ontology-learning systems</a:t>
             </a:r>
             <a:endParaRPr/>
           </a:p>
@@ -41432,94 +41347,6 @@
       </p:sp>
       <p:sp>
         <p:nvSpPr>
-          <p:cNvPr id="1005" name="Rounded Rectangle 1004"/>
-          <p:cNvSpPr/>
-          <p:nvPr/>
-        </p:nvSpPr>
-        <p:spPr>
-          <a:xfrm>
-            <a:off x="841248" y="5422392"/>
-            <a:ext cx="10497312" cy="457200"/>
-          </a:xfrm>
-          <a:prstGeom prst="roundRect">
-            <a:avLst/>
-          </a:prstGeom>
-          <a:solidFill>
-            <a:srgbClr val="FFFFFF"/>
-          </a:solidFill>
-          <a:ln w="12700">
-            <a:solidFill>
-              <a:srgbClr val="D9DEDB"/>
-            </a:solidFill>
-          </a:ln>
-        </p:spPr>
-        <p:style>
-          <a:lnRef idx="1">
-            <a:schemeClr val="accent1"/>
-          </a:lnRef>
-          <a:fillRef idx="3">
-            <a:schemeClr val="accent1"/>
-          </a:fillRef>
-          <a:effectRef idx="2">
-            <a:schemeClr val="accent1"/>
-          </a:effectRef>
-          <a:fontRef idx="minor">
-            <a:schemeClr val="lt1"/>
-          </a:fontRef>
-        </p:style>
-        <p:txBody>
-          <a:bodyPr rtlCol="0" anchor="ctr"/>
-          <a:lstStyle/>
-          <a:p>
-            <a:pPr algn="ctr"/>
-          </a:p>
-        </p:txBody>
-      </p:sp>
-      <p:sp>
-        <p:nvSpPr>
-          <p:cNvPr id="1006" name="TextBox 1005"/>
-          <p:cNvSpPr txBox="1"/>
-          <p:nvPr/>
-        </p:nvSpPr>
-        <p:spPr>
-          <a:xfrm>
-            <a:off x="1014984" y="5486400"/>
-            <a:ext cx="10131552" cy="310896"/>
-          </a:xfrm>
-          <a:prstGeom prst="rect">
-            <a:avLst/>
-          </a:prstGeom>
-          <a:noFill/>
-        </p:spPr>
-        <p:txBody>
-          <a:bodyPr wrap="square" lIns="0" rIns="0" tIns="0" bIns="0" anchor="ctr">
-            <a:spAutoFit/>
-          </a:bodyPr>
-          <a:lstStyle/>
-          <a:p>
-            <a:r>
-              <a:rPr sz="1280" b="0">
-                <a:solidFill>
-                  <a:srgbClr val="3A434C"/>
-                </a:solidFill>
-                <a:latin typeface="Calibri"/>
-              </a:rPr>
-              <a:t>BURR's own finding: LLM-based methods trail rule-based ones.   </a:t>
-            </a:r>
-            <a:r>
-              <a:rPr sz="1280" b="1">
-                <a:solidFill>
-                  <a:srgbClr val="0B6E4F"/>
-                </a:solidFill>
-                <a:latin typeface="Calibri"/>
-              </a:rPr>
-              <a:t>Here RIGOR leads both.</a:t>
-            </a:r>
-          </a:p>
-        </p:txBody>
-      </p:sp>
-      <p:sp>
-        <p:nvSpPr>
           <p:cNvPr id="1007" name="BURR card"/>
           <p:cNvSpPr/>
           <p:nvPr/>
@@ -41639,7 +41466,7 @@
         </p:nvSpPr>
         <p:spPr>
           <a:xfrm>
-            <a:off x="1069848" y="3127248"/>
+            <a:off x="1069848" y="3090672"/>
             <a:ext cx="1005840" cy="329184"/>
           </a:xfrm>
           <a:prstGeom prst="rect">
@@ -41678,7 +41505,7 @@
         </p:nvSpPr>
         <p:spPr>
           <a:xfrm>
-            <a:off x="2075688" y="3127248"/>
+            <a:off x="2075688" y="3090672"/>
             <a:ext cx="1298448" cy="329184"/>
           </a:xfrm>
           <a:prstGeom prst="roundRect">
@@ -41723,7 +41550,7 @@
         </p:nvSpPr>
         <p:spPr>
           <a:xfrm>
-            <a:off x="3392424" y="3127248"/>
+            <a:off x="3392424" y="3090672"/>
             <a:ext cx="237744" cy="329184"/>
           </a:xfrm>
           <a:prstGeom prst="rect">
@@ -41762,7 +41589,7 @@
         </p:nvSpPr>
         <p:spPr>
           <a:xfrm>
-            <a:off x="3648456" y="3127248"/>
+            <a:off x="3648456" y="3090672"/>
             <a:ext cx="1856231" cy="329184"/>
           </a:xfrm>
           <a:prstGeom prst="roundRect">
@@ -41817,7 +41644,7 @@
         </p:nvSpPr>
         <p:spPr>
           <a:xfrm>
-            <a:off x="1069848" y="3584448"/>
+            <a:off x="1069848" y="3511296"/>
             <a:ext cx="1005840" cy="329184"/>
           </a:xfrm>
           <a:prstGeom prst="rect">
@@ -41856,7 +41683,7 @@
         </p:nvSpPr>
         <p:spPr>
           <a:xfrm>
-            <a:off x="2075688" y="3584448"/>
+            <a:off x="2075688" y="3511296"/>
             <a:ext cx="1298448" cy="329184"/>
           </a:xfrm>
           <a:prstGeom prst="roundRect">
@@ -41901,7 +41728,7 @@
         </p:nvSpPr>
         <p:spPr>
           <a:xfrm>
-            <a:off x="3392424" y="3584448"/>
+            <a:off x="3392424" y="3511296"/>
             <a:ext cx="237744" cy="329184"/>
           </a:xfrm>
           <a:prstGeom prst="rect">
@@ -41940,7 +41767,7 @@
         </p:nvSpPr>
         <p:spPr>
           <a:xfrm>
-            <a:off x="3648456" y="3584448"/>
+            <a:off x="3648456" y="3511296"/>
             <a:ext cx="1856231" cy="329184"/>
           </a:xfrm>
           <a:prstGeom prst="roundRect">
@@ -41995,7 +41822,7 @@
         </p:nvSpPr>
         <p:spPr>
           <a:xfrm>
-            <a:off x="1069848" y="4041648"/>
+            <a:off x="1069848" y="3931920"/>
             <a:ext cx="1005840" cy="329184"/>
           </a:xfrm>
           <a:prstGeom prst="rect">
@@ -42034,7 +41861,7 @@
         </p:nvSpPr>
         <p:spPr>
           <a:xfrm>
-            <a:off x="2075688" y="4041648"/>
+            <a:off x="2075688" y="3931920"/>
             <a:ext cx="1298448" cy="329184"/>
           </a:xfrm>
           <a:prstGeom prst="roundRect">
@@ -42079,7 +41906,7 @@
         </p:nvSpPr>
         <p:spPr>
           <a:xfrm>
-            <a:off x="3392424" y="4041648"/>
+            <a:off x="3392424" y="3931920"/>
             <a:ext cx="237744" cy="329184"/>
           </a:xfrm>
           <a:prstGeom prst="rect">
@@ -42118,7 +41945,7 @@
         </p:nvSpPr>
         <p:spPr>
           <a:xfrm>
-            <a:off x="3648456" y="4041648"/>
+            <a:off x="3648456" y="3931920"/>
             <a:ext cx="1856231" cy="329184"/>
           </a:xfrm>
           <a:prstGeom prst="roundRect">
@@ -42173,8 +42000,8 @@
         </p:nvSpPr>
         <p:spPr>
           <a:xfrm>
-            <a:off x="1069848" y="4443983"/>
-            <a:ext cx="4389120" cy="438912"/>
+            <a:off x="1069848" y="4352544"/>
+            <a:ext cx="4389120" cy="585216"/>
           </a:xfrm>
           <a:prstGeom prst="rect">
             <a:avLst/>
@@ -42199,7 +42026,7 @@
                 <a:latin typeface="Calibri"/>
                 <a:cs typeface="Calibri"/>
               </a:rPr>
-              <a:t xml:space="preserve">BURR compares each system's mapping with a gold-standard mapping and reports F1 per element type.</a:t>
+              <a:t xml:space="preserve">Elements match when they map to the same database elements, whatever their names. F1 per element type.</a:t>
             </a:r>
           </a:p>
         </p:txBody>
@@ -42212,7 +42039,7 @@
         </p:nvSpPr>
         <p:spPr>
           <a:xfrm>
-            <a:off x="1069848" y="4937760"/>
+            <a:off x="1069848" y="4974336"/>
             <a:ext cx="4389120" cy="182880"/>
           </a:xfrm>
           <a:prstGeom prst="rect">
@@ -42238,7 +42065,7 @@
                 <a:latin typeface="Calibri"/>
                 <a:cs typeface="Calibri"/>
               </a:rPr>
-              <a:t xml:space="preserve">Illustrative elements from the ISWC domain</a:t>
+              <a:t xml:space="preserve">Illustrative elements  ·  ISWC gold mapping: D2RQ example by Bizer &amp; Seaborne</a:t>
             </a:r>
           </a:p>
         </p:txBody>
@@ -42251,7 +42078,7 @@
         </p:nvSpPr>
         <p:spPr>
           <a:xfrm>
-            <a:off x="850392" y="5943600"/>
+            <a:off x="850392" y="5413248"/>
             <a:ext cx="10488168" cy="246888"/>
           </a:xfrm>
           <a:prstGeom prst="rect">
@@ -42361,7 +42188,7 @@
                 <a:cs typeface="Consolas"/>
                 <a:sym typeface="Consolas"/>
               </a:rPr>
-              <a:t>LIMITS  /  NEXT STEPS</a:t>
+              <a:t>FUTURE WORK  /  FROM SCHEMAS TO INSTANCES</a:t>
             </a:r>
             <a:endParaRPr/>
           </a:p>
@@ -42414,7 +42241,7 @@
                 <a:cs typeface="Calibri"/>
                 <a:sym typeface="Calibri"/>
               </a:rPr>
-              <a:t>Two challenges remain.</a:t>
+              <a:t>Next: let the data speak.</a:t>
             </a:r>
             <a:endParaRPr/>
           </a:p>
@@ -42467,7 +42294,7 @@
                 <a:cs typeface="Calibri"/>
                 <a:sym typeface="Calibri"/>
               </a:rPr>
-              <a:t>The direct-mapping backbone is strong. Semantic enrichment is not yet error-free.</a:t>
+              <a:t>Today RIGOR reads schemas and documentation. Instance data could propose new knowledge, for experts to review.</a:t>
             </a:r>
             <a:endParaRPr/>
           </a:p>
@@ -42475,75 +42302,121 @@
       </p:sp>
       <p:sp>
         <p:nvSpPr>
-          <p:cNvPr id="1016" name="Google Shape;1016;p22"/>
+          <p:cNvPr id="1031" name="Future card 1"/>
           <p:cNvSpPr/>
           <p:nvPr/>
         </p:nvSpPr>
         <p:spPr>
           <a:xfrm>
-            <a:off x="914400" y="2322576"/>
-            <a:ext cx="5038344" cy="2450592"/>
+            <a:off x="822960" y="2194560"/>
+            <a:ext cx="3017520" cy="2962656"/>
           </a:xfrm>
           <a:prstGeom prst="roundRect">
             <a:avLst>
-              <a:gd fmla="val 9000" name="adj"/>
+              <a:gd name="adj" fmla="val 12000"/>
             </a:avLst>
           </a:prstGeom>
           <a:solidFill>
             <a:srgbClr val="FFFFFF"/>
           </a:solidFill>
-          <a:ln cap="flat" cmpd="sng" w="12700">
+          <a:ln w="9525">
             <a:solidFill>
               <a:srgbClr val="D9DEDB"/>
             </a:solidFill>
-            <a:prstDash val="solid"/>
-            <a:miter lim="8000"/>
-            <a:headEnd len="sm" w="sm" type="none"/>
-            <a:tailEnd len="sm" w="sm" type="none"/>
-          </a:ln>
-        </p:spPr>
-        <p:txBody>
-          <a:bodyPr anchorCtr="0" anchor="ctr" bIns="45700" lIns="91425" spcFirstLastPara="1" rIns="91425" wrap="square" tIns="45700">
+          </a:ln>
+        </p:spPr>
+        <p:txBody>
+          <a:bodyPr wrap="square" lIns="0" tIns="0" rIns="0" bIns="0" anchor="t">
             <a:noAutofit/>
           </a:bodyPr>
           <a:lstStyle/>
           <a:p>
-            <a:pPr indent="0" lvl="0" marL="0" marR="0" rtl="0" algn="ctr">
-              <a:spcBef>
-                <a:spcPts val="0"/>
-              </a:spcBef>
-              <a:spcAft>
-                <a:spcPts val="0"/>
-              </a:spcAft>
-              <a:buNone/>
-            </a:pPr>
-            <a:r>
-              <a:t/>
-            </a:r>
-            <a:endParaRPr sz="1800">
-              <a:solidFill>
-                <a:schemeClr val="dk1"/>
-              </a:solidFill>
-              <a:latin typeface="Calibri"/>
-              <a:ea typeface="Calibri"/>
-              <a:cs typeface="Calibri"/>
-              <a:sym typeface="Calibri"/>
-            </a:endParaRPr>
-          </a:p>
-        </p:txBody>
-      </p:sp>
-      <p:sp>
-        <p:nvSpPr>
-          <p:cNvPr id="1017" name="Google Shape;1017;p22"/>
+            <a:pPr algn="l"/>
+          </a:p>
+        </p:txBody>
+      </p:sp>
+      <p:sp>
+        <p:nvSpPr>
+          <p:cNvPr id="1032" name="Future card 2"/>
           <p:cNvSpPr/>
           <p:nvPr/>
         </p:nvSpPr>
         <p:spPr>
           <a:xfrm>
-            <a:off x="914400" y="2322576"/>
-            <a:ext cx="5038344" cy="64008"/>
-          </a:xfrm>
-          <a:prstGeom prst="rect">
+            <a:off x="4224528" y="2194560"/>
+            <a:ext cx="2788920" cy="2962656"/>
+          </a:xfrm>
+          <a:prstGeom prst="roundRect">
+            <a:avLst>
+              <a:gd name="adj" fmla="val 12000"/>
+            </a:avLst>
+          </a:prstGeom>
+          <a:solidFill>
+            <a:srgbClr val="FFFFFF"/>
+          </a:solidFill>
+          <a:ln w="9525">
+            <a:solidFill>
+              <a:srgbClr val="D9DEDB"/>
+            </a:solidFill>
+          </a:ln>
+        </p:spPr>
+        <p:txBody>
+          <a:bodyPr wrap="square" lIns="0" tIns="0" rIns="0" bIns="0" anchor="t">
+            <a:noAutofit/>
+          </a:bodyPr>
+          <a:lstStyle/>
+          <a:p>
+            <a:pPr algn="l"/>
+          </a:p>
+        </p:txBody>
+      </p:sp>
+      <p:sp>
+        <p:nvSpPr>
+          <p:cNvPr id="1033" name="Future card 3"/>
+          <p:cNvSpPr/>
+          <p:nvPr/>
+        </p:nvSpPr>
+        <p:spPr>
+          <a:xfrm>
+            <a:off x="7397496" y="2194560"/>
+            <a:ext cx="3941063" cy="2962656"/>
+          </a:xfrm>
+          <a:prstGeom prst="roundRect">
+            <a:avLst>
+              <a:gd name="adj" fmla="val 12000"/>
+            </a:avLst>
+          </a:prstGeom>
+          <a:solidFill>
+            <a:srgbClr val="FFFFFF"/>
+          </a:solidFill>
+          <a:ln w="9525">
+            <a:solidFill>
+              <a:srgbClr val="D9DEDB"/>
+            </a:solidFill>
+          </a:ln>
+        </p:spPr>
+        <p:txBody>
+          <a:bodyPr wrap="square" lIns="0" tIns="0" rIns="0" bIns="0" anchor="t">
+            <a:noAutofit/>
+          </a:bodyPr>
+          <a:lstStyle/>
+          <a:p>
+            <a:pPr algn="l"/>
+          </a:p>
+        </p:txBody>
+      </p:sp>
+      <p:sp>
+        <p:nvSpPr>
+          <p:cNvPr id="1034" name="Flow arrow"/>
+          <p:cNvSpPr/>
+          <p:nvPr/>
+        </p:nvSpPr>
+        <p:spPr>
+          <a:xfrm>
+            <a:off x="3877056" y="3456432"/>
+            <a:ext cx="310896" cy="384048"/>
+          </a:xfrm>
+          <a:prstGeom prst="rightArrow">
             <a:avLst/>
           </a:prstGeom>
           <a:solidFill>
@@ -42554,98 +42427,56 @@
           </a:ln>
         </p:spPr>
         <p:txBody>
-          <a:bodyPr anchorCtr="0" anchor="ctr" bIns="45700" lIns="91425" spcFirstLastPara="1" rIns="91425" wrap="square" tIns="45700">
+          <a:bodyPr wrap="square" lIns="0" tIns="0" rIns="0" bIns="0" anchor="t">
             <a:noAutofit/>
           </a:bodyPr>
           <a:lstStyle/>
           <a:p>
-            <a:pPr indent="0" lvl="0" marL="0" marR="0" rtl="0" algn="ctr">
-              <a:spcBef>
-                <a:spcPts val="0"/>
-              </a:spcBef>
-              <a:spcAft>
-                <a:spcPts val="0"/>
-              </a:spcAft>
-              <a:buNone/>
-            </a:pPr>
-            <a:r>
-              <a:t/>
-            </a:r>
-            <a:endParaRPr sz="1800">
-              <a:solidFill>
-                <a:schemeClr val="dk1"/>
-              </a:solidFill>
-              <a:latin typeface="Calibri"/>
-              <a:ea typeface="Calibri"/>
-              <a:cs typeface="Calibri"/>
-              <a:sym typeface="Calibri"/>
-            </a:endParaRPr>
-          </a:p>
-        </p:txBody>
-      </p:sp>
-      <p:sp>
-        <p:nvSpPr>
-          <p:cNvPr id="1018" name="Google Shape;1018;p22"/>
-          <p:cNvSpPr txBox="1"/>
-          <p:nvPr/>
-        </p:nvSpPr>
-        <p:spPr>
-          <a:xfrm>
-            <a:off x="1133856" y="2551176"/>
-            <a:ext cx="4535424" cy="292608"/>
-          </a:xfrm>
-          <a:prstGeom prst="rect">
-            <a:avLst/>
-          </a:prstGeom>
-          <a:noFill/>
+            <a:pPr algn="l"/>
+          </a:p>
+        </p:txBody>
+      </p:sp>
+      <p:sp>
+        <p:nvSpPr>
+          <p:cNvPr id="1035" name="Flow arrow"/>
+          <p:cNvSpPr/>
+          <p:nvPr/>
+        </p:nvSpPr>
+        <p:spPr>
+          <a:xfrm>
+            <a:off x="7050024" y="3456432"/>
+            <a:ext cx="310896" cy="384048"/>
+          </a:xfrm>
+          <a:prstGeom prst="rightArrow">
+            <a:avLst/>
+          </a:prstGeom>
+          <a:solidFill>
+            <a:srgbClr val="0B6E4F"/>
+          </a:solidFill>
           <a:ln>
             <a:noFill/>
           </a:ln>
         </p:spPr>
         <p:txBody>
-          <a:bodyPr anchorCtr="0" anchor="ctr" bIns="0" lIns="0" spcFirstLastPara="1" rIns="0" wrap="square" tIns="0">
-            <a:spAutoFit/>
-          </a:bodyPr>
-          <a:lstStyle/>
-          <a:p>
-            <a:pPr indent="0" lvl="0" marL="0" marR="0" rtl="0" algn="l">
-              <a:lnSpc>
-                <a:spcPct val="105000"/>
-              </a:lnSpc>
-              <a:spcBef>
-                <a:spcPts val="0"/>
-              </a:spcBef>
-              <a:spcAft>
-                <a:spcPts val="0"/>
-              </a:spcAft>
-              <a:buNone/>
-            </a:pPr>
-            <a:r>
-              <a:rPr b="1" lang="en-US" sz="1520">
-                <a:solidFill>
-                  <a:srgbClr val="0B6E4F"/>
-                </a:solidFill>
-                <a:latin typeface="Consolas"/>
-                <a:ea typeface="Consolas"/>
-                <a:cs typeface="Consolas"/>
-                <a:sym typeface="Consolas"/>
-              </a:rPr>
-              <a:t>PRESERVING COVERAGE</a:t>
-            </a:r>
-            <a:endParaRPr/>
-          </a:p>
-        </p:txBody>
-      </p:sp>
-      <p:sp>
-        <p:nvSpPr>
-          <p:cNvPr id="1019" name="Google Shape;1019;p22"/>
+          <a:bodyPr wrap="square" lIns="0" tIns="0" rIns="0" bIns="0" anchor="t">
+            <a:noAutofit/>
+          </a:bodyPr>
+          <a:lstStyle/>
+          <a:p>
+            <a:pPr algn="l"/>
+          </a:p>
+        </p:txBody>
+      </p:sp>
+      <p:sp>
+        <p:nvSpPr>
+          <p:cNvPr id="1036" name="Card 1 label"/>
           <p:cNvSpPr txBox="1"/>
           <p:nvPr/>
         </p:nvSpPr>
         <p:spPr>
           <a:xfrm>
-            <a:off x="1133856" y="2926080"/>
-            <a:ext cx="4526280" cy="566928"/>
+            <a:off x="1024128" y="2359152"/>
+            <a:ext cx="2651760" cy="274320"/>
           </a:xfrm>
           <a:prstGeom prst="rect">
             <a:avLst/>
@@ -42656,49 +42487,35 @@
           </a:ln>
         </p:spPr>
         <p:txBody>
-          <a:bodyPr anchorCtr="0" anchor="ctr" bIns="0" lIns="0" spcFirstLastPara="1" rIns="0" wrap="square" tIns="0">
-            <a:spAutoFit/>
-          </a:bodyPr>
-          <a:lstStyle/>
-          <a:p>
-            <a:pPr indent="0" lvl="0" marL="0" marR="0" rtl="0" algn="l">
-              <a:lnSpc>
-                <a:spcPct val="106000"/>
-              </a:lnSpc>
-              <a:spcBef>
-                <a:spcPts val="0"/>
-              </a:spcBef>
-              <a:spcAft>
-                <a:spcPts val="0"/>
-              </a:spcAft>
-              <a:buNone/>
-            </a:pPr>
-            <a:r>
-              <a:rPr b="1" lang="en-US" sz="2900">
-                <a:solidFill>
-                  <a:srgbClr val="1F2328"/>
-                </a:solidFill>
-                <a:latin typeface="Cambria"/>
-                <a:ea typeface="Calibri"/>
-                <a:cs typeface="Calibri"/>
-                <a:sym typeface="Calibri"/>
-              </a:rPr>
-              <a:t>0.77–1.00</a:t>
-            </a:r>
-            <a:endParaRPr/>
-          </a:p>
-        </p:txBody>
-      </p:sp>
-      <p:sp>
-        <p:nvSpPr>
-          <p:cNvPr id="1020" name="Google Shape;1020;p22"/>
+          <a:bodyPr wrap="square" lIns="0" tIns="0" rIns="0" bIns="0" anchor="t">
+            <a:noAutofit/>
+          </a:bodyPr>
+          <a:lstStyle/>
+          <a:p>
+            <a:pPr algn="l"/>
+            <a:r>
+              <a:rPr lang="en-US" sz="1300" b="1" dirty="0">
+                <a:solidFill>
+                  <a:srgbClr val="2F6B78"/>
+                </a:solidFill>
+                <a:latin typeface="Consolas"/>
+                <a:cs typeface="Consolas"/>
+              </a:rPr>
+              <a:t xml:space="preserve">1  INSTANCES</a:t>
+            </a:r>
+          </a:p>
+        </p:txBody>
+      </p:sp>
+      <p:sp>
+        <p:nvSpPr>
+          <p:cNvPr id="1037" name="Card 1 sub"/>
           <p:cNvSpPr txBox="1"/>
           <p:nvPr/>
         </p:nvSpPr>
         <p:spPr>
           <a:xfrm>
-            <a:off x="1133856" y="3621024"/>
-            <a:ext cx="4562856" cy="658368"/>
+            <a:off x="1024128" y="2651760"/>
+            <a:ext cx="2651760" cy="256032"/>
           </a:xfrm>
           <a:prstGeom prst="rect">
             <a:avLst/>
@@ -42709,53 +42526,85 @@
           </a:ln>
         </p:spPr>
         <p:txBody>
-          <a:bodyPr anchorCtr="0" anchor="t" bIns="0" lIns="0" spcFirstLastPara="1" rIns="0" wrap="square" tIns="0">
-            <a:spAutoFit/>
-          </a:bodyPr>
-          <a:lstStyle/>
-          <a:p>
-            <a:pPr indent="0" lvl="0" marL="0" marR="0" rtl="0" algn="l">
-              <a:lnSpc>
-                <a:spcPct val="106000"/>
-              </a:lnSpc>
-              <a:spcBef>
-                <a:spcPts val="0"/>
-              </a:spcBef>
-              <a:spcAft>
-                <a:spcPts val="0"/>
-              </a:spcAft>
-              <a:buNone/>
-            </a:pPr>
-            <a:r>
-              <a:rPr b="0" lang="en-US" sz="1510">
+          <a:bodyPr wrap="square" lIns="0" tIns="0" rIns="0" bIns="0" anchor="t">
+            <a:noAutofit/>
+          </a:bodyPr>
+          <a:lstStyle/>
+          <a:p>
+            <a:pPr algn="l"/>
+            <a:r>
+              <a:rPr lang="en-US" sz="1300" b="0" dirty="0">
                 <a:solidFill>
                   <a:srgbClr val="5B6770"/>
                 </a:solidFill>
                 <a:latin typeface="Calibri"/>
-                <a:ea typeface="Calibri"/>
                 <a:cs typeface="Calibri"/>
-                <a:sym typeface="Calibri"/>
-              </a:rPr>
-              <a:t>Measured column coverage after enrichment; the cleaned direct-mapping seed is complete by construction.</a:t>
-            </a:r>
-            <a:endParaRPr/>
-          </a:p>
-        </p:txBody>
-      </p:sp>
-      <p:sp>
-        <p:nvSpPr>
-          <p:cNvPr id="1021" name="Google Shape;1021;p22"/>
-          <p:cNvSpPr/>
-          <p:nvPr/>
-        </p:nvSpPr>
-        <p:spPr>
-          <a:xfrm>
-            <a:off x="914400" y="5029200"/>
-            <a:ext cx="5038344" cy="585216"/>
+              </a:rPr>
+              <a:t xml:space="preserve">What patient rows show</a:t>
+            </a:r>
+          </a:p>
+        </p:txBody>
+      </p:sp>
+      <p:sp>
+        <p:nvSpPr>
+          <p:cNvPr id="1038" name="Instance row 0"/>
+          <p:cNvSpPr txBox="1"/>
+          <p:nvPr/>
+        </p:nvSpPr>
+        <p:spPr>
+          <a:xfrm>
+            <a:off x="960120" y="3017520"/>
+            <a:ext cx="2743200" cy="246888"/>
           </a:xfrm>
           <a:prstGeom prst="roundRect">
             <a:avLst>
-              <a:gd fmla="val 9000" name="adj"/>
+              <a:gd name="adj" fmla="val 12000"/>
+            </a:avLst>
+          </a:prstGeom>
+          <a:noFill/>
+          <a:ln>
+            <a:noFill/>
+          </a:ln>
+        </p:spPr>
+        <p:txBody>
+          <a:bodyPr wrap="square" lIns="91440" tIns="0" rIns="91440" bIns="0" anchor="ctr">
+            <a:noAutofit/>
+          </a:bodyPr>
+          <a:lstStyle/>
+          <a:p>
+            <a:pPr algn="l">
+              <a:tabLst>
+                <a:tab pos="777240" algn="l"/>
+                <a:tab pos="1737360" algn="l"/>
+              </a:tabLst>
+            </a:pPr>
+            <a:r>
+              <a:rPr lang="en-US" sz="950" b="1" dirty="0">
+                <a:solidFill>
+                  <a:srgbClr val="5B6770"/>
+                </a:solidFill>
+                <a:latin typeface="Consolas"/>
+                <a:cs typeface="Consolas"/>
+              </a:rPr>
+              <a:t xml:space="preserve">PATIENT	CISPLATIN	BM_DEP AFTER</a:t>
+            </a:r>
+          </a:p>
+        </p:txBody>
+      </p:sp>
+      <p:sp>
+        <p:nvSpPr>
+          <p:cNvPr id="1039" name="Instance row 1"/>
+          <p:cNvSpPr/>
+          <p:nvPr/>
+        </p:nvSpPr>
+        <p:spPr>
+          <a:xfrm>
+            <a:off x="960120" y="3291839"/>
+            <a:ext cx="2743200" cy="246888"/>
+          </a:xfrm>
+          <a:prstGeom prst="roundRect">
+            <a:avLst>
+              <a:gd name="adj" fmla="val 12000"/>
             </a:avLst>
           </a:prstGeom>
           <a:solidFill>
@@ -42766,371 +42615,44 @@
           </a:ln>
         </p:spPr>
         <p:txBody>
-          <a:bodyPr anchorCtr="0" anchor="ctr" bIns="45700" lIns="91425" spcFirstLastPara="1" rIns="91425" wrap="square" tIns="45700">
+          <a:bodyPr wrap="square" lIns="91440" tIns="0" rIns="91440" bIns="0" anchor="ctr">
             <a:noAutofit/>
           </a:bodyPr>
           <a:lstStyle/>
           <a:p>
-            <a:pPr indent="0" lvl="0" marL="0" marR="0" rtl="0" algn="ctr">
-              <a:spcBef>
-                <a:spcPts val="0"/>
-              </a:spcBef>
-              <a:spcAft>
-                <a:spcPts val="0"/>
-              </a:spcAft>
-              <a:buNone/>
-            </a:pPr>
-            <a:r>
-              <a:t/>
-            </a:r>
-            <a:endParaRPr sz="1800">
-              <a:solidFill>
-                <a:schemeClr val="dk1"/>
-              </a:solidFill>
-              <a:latin typeface="Calibri"/>
-              <a:ea typeface="Calibri"/>
-              <a:cs typeface="Calibri"/>
-              <a:sym typeface="Calibri"/>
-            </a:endParaRPr>
-          </a:p>
-        </p:txBody>
-      </p:sp>
-      <p:sp>
-        <p:nvSpPr>
-          <p:cNvPr id="1022" name="Google Shape;1022;p22"/>
-          <p:cNvSpPr txBox="1"/>
-          <p:nvPr/>
-        </p:nvSpPr>
-        <p:spPr>
-          <a:xfrm>
-            <a:off x="1078992" y="5074920"/>
-            <a:ext cx="4700016" cy="438912"/>
-          </a:xfrm>
-          <a:prstGeom prst="rect">
-            <a:avLst/>
-          </a:prstGeom>
-          <a:noFill/>
-          <a:ln>
-            <a:noFill/>
-          </a:ln>
-        </p:spPr>
-        <p:txBody>
-          <a:bodyPr anchorCtr="0" anchor="ctr" bIns="0" lIns="0" spcFirstLastPara="1" rIns="0" wrap="square" tIns="0">
-            <a:spAutoFit/>
-          </a:bodyPr>
-          <a:lstStyle/>
-          <a:p>
-            <a:pPr indent="0" lvl="0" marL="0" marR="0" rtl="0" algn="l">
-              <a:lnSpc>
-                <a:spcPct val="105000"/>
-              </a:lnSpc>
-              <a:spcBef>
-                <a:spcPts val="0"/>
-              </a:spcBef>
-              <a:spcAft>
-                <a:spcPts val="0"/>
-              </a:spcAft>
-              <a:buNone/>
-            </a:pPr>
-            <a:r>
-              <a:rPr b="0" lang="en-US" sz="1550">
+            <a:pPr algn="l">
+              <a:tabLst>
+                <a:tab pos="777240" algn="l"/>
+                <a:tab pos="1737360" algn="l"/>
+              </a:tabLst>
+            </a:pPr>
+            <a:r>
+              <a:rPr lang="en-US" sz="1150" b="0" dirty="0">
                 <a:solidFill>
                   <a:srgbClr val="1F2328"/>
                 </a:solidFill>
-                <a:latin typeface="Calibri"/>
-                <a:ea typeface="Calibri"/>
-                <a:cs typeface="Calibri"/>
-                <a:sym typeface="Calibri"/>
-              </a:rPr>
-              <a:t>NEXT  ·  Strengthen coverage checks for each fragment.</a:t>
-            </a:r>
-            <a:endParaRPr/>
-          </a:p>
-        </p:txBody>
-      </p:sp>
-      <p:sp>
-        <p:nvSpPr>
-          <p:cNvPr id="1023" name="Google Shape;1023;p22"/>
+                <a:latin typeface="Consolas"/>
+                <a:cs typeface="Consolas"/>
+              </a:rPr>
+              <a:t xml:space="preserve">P01	yes	1</a:t>
+            </a:r>
+          </a:p>
+        </p:txBody>
+      </p:sp>
+      <p:sp>
+        <p:nvSpPr>
+          <p:cNvPr id="1040" name="Instance row 2"/>
           <p:cNvSpPr/>
           <p:nvPr/>
         </p:nvSpPr>
         <p:spPr>
           <a:xfrm>
-            <a:off x="6208776" y="2322576"/>
-            <a:ext cx="5038344" cy="2450592"/>
+            <a:off x="960120" y="3566160"/>
+            <a:ext cx="2743200" cy="246888"/>
           </a:xfrm>
           <a:prstGeom prst="roundRect">
             <a:avLst>
-              <a:gd fmla="val 9000" name="adj"/>
-            </a:avLst>
-          </a:prstGeom>
-          <a:solidFill>
-            <a:srgbClr val="FFFFFF"/>
-          </a:solidFill>
-          <a:ln cap="flat" cmpd="sng" w="12700">
-            <a:solidFill>
-              <a:srgbClr val="D9DEDB"/>
-            </a:solidFill>
-            <a:prstDash val="solid"/>
-            <a:miter lim="8000"/>
-            <a:headEnd len="sm" w="sm" type="none"/>
-            <a:tailEnd len="sm" w="sm" type="none"/>
-          </a:ln>
-        </p:spPr>
-        <p:txBody>
-          <a:bodyPr anchorCtr="0" anchor="ctr" bIns="45700" lIns="91425" spcFirstLastPara="1" rIns="91425" wrap="square" tIns="45700">
-            <a:noAutofit/>
-          </a:bodyPr>
-          <a:lstStyle/>
-          <a:p>
-            <a:pPr indent="0" lvl="0" marL="0" marR="0" rtl="0" algn="ctr">
-              <a:spcBef>
-                <a:spcPts val="0"/>
-              </a:spcBef>
-              <a:spcAft>
-                <a:spcPts val="0"/>
-              </a:spcAft>
-              <a:buNone/>
-            </a:pPr>
-            <a:r>
-              <a:t/>
-            </a:r>
-            <a:endParaRPr sz="1800">
-              <a:solidFill>
-                <a:schemeClr val="dk1"/>
-              </a:solidFill>
-              <a:latin typeface="Calibri"/>
-              <a:ea typeface="Calibri"/>
-              <a:cs typeface="Calibri"/>
-              <a:sym typeface="Calibri"/>
-            </a:endParaRPr>
-          </a:p>
-        </p:txBody>
-      </p:sp>
-      <p:sp>
-        <p:nvSpPr>
-          <p:cNvPr id="1024" name="Google Shape;1024;p22"/>
-          <p:cNvSpPr/>
-          <p:nvPr/>
-        </p:nvSpPr>
-        <p:spPr>
-          <a:xfrm>
-            <a:off x="6208776" y="2322576"/>
-            <a:ext cx="5038344" cy="64008"/>
-          </a:xfrm>
-          <a:prstGeom prst="rect">
-            <a:avLst/>
-          </a:prstGeom>
-          <a:solidFill>
-            <a:srgbClr val="0B6E4F"/>
-          </a:solidFill>
-          <a:ln>
-            <a:noFill/>
-          </a:ln>
-        </p:spPr>
-        <p:txBody>
-          <a:bodyPr anchorCtr="0" anchor="ctr" bIns="45700" lIns="91425" spcFirstLastPara="1" rIns="91425" wrap="square" tIns="45700">
-            <a:noAutofit/>
-          </a:bodyPr>
-          <a:lstStyle/>
-          <a:p>
-            <a:pPr indent="0" lvl="0" marL="0" marR="0" rtl="0" algn="ctr">
-              <a:spcBef>
-                <a:spcPts val="0"/>
-              </a:spcBef>
-              <a:spcAft>
-                <a:spcPts val="0"/>
-              </a:spcAft>
-              <a:buNone/>
-            </a:pPr>
-            <a:r>
-              <a:t/>
-            </a:r>
-            <a:endParaRPr sz="1800">
-              <a:solidFill>
-                <a:schemeClr val="dk1"/>
-              </a:solidFill>
-              <a:latin typeface="Calibri"/>
-              <a:ea typeface="Calibri"/>
-              <a:cs typeface="Calibri"/>
-              <a:sym typeface="Calibri"/>
-            </a:endParaRPr>
-          </a:p>
-        </p:txBody>
-      </p:sp>
-      <p:sp>
-        <p:nvSpPr>
-          <p:cNvPr id="1025" name="Google Shape;1025;p22"/>
-          <p:cNvSpPr txBox="1"/>
-          <p:nvPr/>
-        </p:nvSpPr>
-        <p:spPr>
-          <a:xfrm>
-            <a:off x="6428232" y="2551176"/>
-            <a:ext cx="4535424" cy="292608"/>
-          </a:xfrm>
-          <a:prstGeom prst="rect">
-            <a:avLst/>
-          </a:prstGeom>
-          <a:noFill/>
-          <a:ln>
-            <a:noFill/>
-          </a:ln>
-        </p:spPr>
-        <p:txBody>
-          <a:bodyPr anchorCtr="0" anchor="ctr" bIns="0" lIns="0" spcFirstLastPara="1" rIns="0" wrap="square" tIns="0">
-            <a:spAutoFit/>
-          </a:bodyPr>
-          <a:lstStyle/>
-          <a:p>
-            <a:pPr indent="0" lvl="0" marL="0" marR="0" rtl="0" algn="l">
-              <a:lnSpc>
-                <a:spcPct val="105000"/>
-              </a:lnSpc>
-              <a:spcBef>
-                <a:spcPts val="0"/>
-              </a:spcBef>
-              <a:spcAft>
-                <a:spcPts val="0"/>
-              </a:spcAft>
-              <a:buNone/>
-            </a:pPr>
-            <a:r>
-              <a:rPr b="1" lang="en-US" sz="1520">
-                <a:solidFill>
-                  <a:srgbClr val="0B6E4F"/>
-                </a:solidFill>
-                <a:latin typeface="Consolas"/>
-                <a:ea typeface="Consolas"/>
-                <a:cs typeface="Consolas"/>
-                <a:sym typeface="Consolas"/>
-              </a:rPr>
-              <a:t>CATCHING SEMANTIC ERRORS</a:t>
-            </a:r>
-            <a:endParaRPr/>
-          </a:p>
-        </p:txBody>
-      </p:sp>
-      <p:sp>
-        <p:nvSpPr>
-          <p:cNvPr id="1026" name="Google Shape;1026;p22"/>
-          <p:cNvSpPr txBox="1"/>
-          <p:nvPr/>
-        </p:nvSpPr>
-        <p:spPr>
-          <a:xfrm>
-            <a:off x="6428232" y="2926080"/>
-            <a:ext cx="4526280" cy="566928"/>
-          </a:xfrm>
-          <a:prstGeom prst="rect">
-            <a:avLst/>
-          </a:prstGeom>
-          <a:noFill/>
-          <a:ln>
-            <a:noFill/>
-          </a:ln>
-        </p:spPr>
-        <p:txBody>
-          <a:bodyPr anchorCtr="0" anchor="ctr" bIns="0" lIns="0" spcFirstLastPara="1" rIns="0" wrap="square" tIns="0">
-            <a:spAutoFit/>
-          </a:bodyPr>
-          <a:lstStyle/>
-          <a:p>
-            <a:pPr indent="0" lvl="0" marL="0" marR="0" rtl="0" algn="l">
-              <a:lnSpc>
-                <a:spcPct val="106000"/>
-              </a:lnSpc>
-              <a:spcBef>
-                <a:spcPts val="0"/>
-              </a:spcBef>
-              <a:spcAft>
-                <a:spcPts val="0"/>
-              </a:spcAft>
-              <a:buNone/>
-            </a:pPr>
-            <a:r>
-              <a:rPr b="1" lang="en-US" sz="2900">
-                <a:solidFill>
-                  <a:srgbClr val="1F2328"/>
-                </a:solidFill>
-                <a:latin typeface="Cambria"/>
-                <a:ea typeface="Calibri"/>
-                <a:cs typeface="Calibri"/>
-                <a:sym typeface="Calibri"/>
-              </a:rPr>
-              <a:t>3 of 9</a:t>
-            </a:r>
-            <a:endParaRPr/>
-          </a:p>
-        </p:txBody>
-      </p:sp>
-      <p:sp>
-        <p:nvSpPr>
-          <p:cNvPr id="1027" name="Google Shape;1027;p22"/>
-          <p:cNvSpPr txBox="1"/>
-          <p:nvPr/>
-        </p:nvSpPr>
-        <p:spPr>
-          <a:xfrm>
-            <a:off x="6428232" y="3621024"/>
-            <a:ext cx="4562856" cy="658368"/>
-          </a:xfrm>
-          <a:prstGeom prst="rect">
-            <a:avLst/>
-          </a:prstGeom>
-          <a:noFill/>
-          <a:ln>
-            <a:noFill/>
-          </a:ln>
-        </p:spPr>
-        <p:txBody>
-          <a:bodyPr anchorCtr="0" anchor="t" bIns="0" lIns="0" spcFirstLastPara="1" rIns="0" wrap="square" tIns="0">
-            <a:spAutoFit/>
-          </a:bodyPr>
-          <a:lstStyle/>
-          <a:p>
-            <a:pPr indent="0" lvl="0" marL="0" marR="0" rtl="0" algn="l">
-              <a:lnSpc>
-                <a:spcPct val="106000"/>
-              </a:lnSpc>
-              <a:spcBef>
-                <a:spcPts val="0"/>
-              </a:spcBef>
-              <a:spcAft>
-                <a:spcPts val="0"/>
-              </a:spcAft>
-              <a:buNone/>
-            </a:pPr>
-            <a:r>
-              <a:rPr b="0" lang="en-US" sz="1510">
-                <a:solidFill>
-                  <a:srgbClr val="5B6770"/>
-                </a:solidFill>
-                <a:latin typeface="Calibri"/>
-                <a:ea typeface="Calibri"/>
-                <a:cs typeface="Calibri"/>
-                <a:sym typeface="Calibri"/>
-              </a:rPr>
-              <a:t>RIGOR runs still contain critical P19 pitfalls; justified disjointness is rarely generated.</a:t>
-            </a:r>
-            <a:endParaRPr/>
-          </a:p>
-        </p:txBody>
-      </p:sp>
-      <p:sp>
-        <p:nvSpPr>
-          <p:cNvPr id="1028" name="Google Shape;1028;p22"/>
-          <p:cNvSpPr/>
-          <p:nvPr/>
-        </p:nvSpPr>
-        <p:spPr>
-          <a:xfrm>
-            <a:off x="6208776" y="5029200"/>
-            <a:ext cx="5038344" cy="585216"/>
-          </a:xfrm>
-          <a:prstGeom prst="roundRect">
-            <a:avLst>
-              <a:gd fmla="val 9000" name="adj"/>
+              <a:gd name="adj" fmla="val 12000"/>
             </a:avLst>
           </a:prstGeom>
           <a:solidFill>
@@ -43141,48 +42663,45 @@
           </a:ln>
         </p:spPr>
         <p:txBody>
-          <a:bodyPr anchorCtr="0" anchor="ctr" bIns="45700" lIns="91425" spcFirstLastPara="1" rIns="91425" wrap="square" tIns="45700">
+          <a:bodyPr wrap="square" lIns="91440" tIns="0" rIns="91440" bIns="0" anchor="ctr">
             <a:noAutofit/>
           </a:bodyPr>
           <a:lstStyle/>
           <a:p>
-            <a:pPr indent="0" lvl="0" marL="0" marR="0" rtl="0" algn="ctr">
-              <a:spcBef>
-                <a:spcPts val="0"/>
-              </a:spcBef>
-              <a:spcAft>
-                <a:spcPts val="0"/>
-              </a:spcAft>
-              <a:buNone/>
-            </a:pPr>
-            <a:r>
-              <a:t/>
-            </a:r>
-            <a:endParaRPr sz="1800">
-              <a:solidFill>
-                <a:schemeClr val="dk1"/>
-              </a:solidFill>
-              <a:latin typeface="Calibri"/>
-              <a:ea typeface="Calibri"/>
-              <a:cs typeface="Calibri"/>
-              <a:sym typeface="Calibri"/>
-            </a:endParaRPr>
-          </a:p>
-        </p:txBody>
-      </p:sp>
-      <p:sp>
-        <p:nvSpPr>
-          <p:cNvPr id="1029" name="Google Shape;1029;p22"/>
+            <a:pPr algn="l">
+              <a:tabLst>
+                <a:tab pos="777240" algn="l"/>
+                <a:tab pos="1737360" algn="l"/>
+              </a:tabLst>
+            </a:pPr>
+            <a:r>
+              <a:rPr lang="en-US" sz="1150" b="0" dirty="0">
+                <a:solidFill>
+                  <a:srgbClr val="1F2328"/>
+                </a:solidFill>
+                <a:latin typeface="Consolas"/>
+                <a:cs typeface="Consolas"/>
+              </a:rPr>
+              <a:t xml:space="preserve">P02	yes	1</a:t>
+            </a:r>
+          </a:p>
+        </p:txBody>
+      </p:sp>
+      <p:sp>
+        <p:nvSpPr>
+          <p:cNvPr id="1041" name="Instance row 3"/>
           <p:cNvSpPr txBox="1"/>
           <p:nvPr/>
         </p:nvSpPr>
         <p:spPr>
           <a:xfrm>
-            <a:off x="6373368" y="5074920"/>
-            <a:ext cx="4700016" cy="438912"/>
-          </a:xfrm>
-          <a:prstGeom prst="rect">
-            <a:avLst/>
+            <a:off x="960120" y="3840479"/>
+            <a:ext cx="2743200" cy="246888"/>
+          </a:xfrm>
+          <a:prstGeom prst="roundRect">
+            <a:avLst>
+              <a:gd name="adj" fmla="val 12000"/>
+            </a:avLst>
           </a:prstGeom>
           <a:noFill/>
           <a:ln>
@@ -43190,89 +42709,1049 @@
           </a:ln>
         </p:spPr>
         <p:txBody>
-          <a:bodyPr anchorCtr="0" anchor="ctr" bIns="0" lIns="0" spcFirstLastPara="1" rIns="0" wrap="square" tIns="0">
-            <a:spAutoFit/>
-          </a:bodyPr>
-          <a:lstStyle/>
-          <a:p>
-            <a:pPr indent="0" lvl="0" marL="0" marR="0" rtl="0" algn="l">
-              <a:lnSpc>
-                <a:spcPct val="105000"/>
-              </a:lnSpc>
-              <a:spcBef>
-                <a:spcPts val="0"/>
-              </a:spcBef>
-              <a:spcAft>
-                <a:spcPts val="0"/>
-              </a:spcAft>
-              <a:buNone/>
-            </a:pPr>
-            <a:r>
-              <a:rPr b="0" lang="en-US" sz="1550">
+          <a:bodyPr wrap="square" lIns="91440" tIns="0" rIns="91440" bIns="0" anchor="ctr">
+            <a:noAutofit/>
+          </a:bodyPr>
+          <a:lstStyle/>
+          <a:p>
+            <a:pPr algn="l">
+              <a:tabLst>
+                <a:tab pos="777240" algn="l"/>
+                <a:tab pos="1737360" algn="l"/>
+              </a:tabLst>
+            </a:pPr>
+            <a:r>
+              <a:rPr lang="en-US" sz="1150" b="0" dirty="0">
                 <a:solidFill>
                   <a:srgbClr val="1F2328"/>
                 </a:solidFill>
-                <a:latin typeface="Calibri"/>
-                <a:ea typeface="Calibri"/>
-                <a:cs typeface="Calibri"/>
-                <a:sym typeface="Calibri"/>
-              </a:rPr>
-              <a:t>NEXT  ·  Add tool feedback and symbolic reasoning.</a:t>
-            </a:r>
-            <a:endParaRPr/>
-          </a:p>
-        </p:txBody>
-      </p:sp>
-      <p:sp>
-        <p:nvSpPr>
-          <p:cNvPr id="1030" name="Google Shape;1030;p22"/>
-          <p:cNvSpPr txBox="1"/>
-          <p:nvPr/>
-        </p:nvSpPr>
-        <p:spPr>
-          <a:xfrm>
-            <a:off x="932688" y="5852160"/>
-            <a:ext cx="10058400" cy="292608"/>
-          </a:xfrm>
-          <a:prstGeom prst="rect">
-            <a:avLst/>
-          </a:prstGeom>
-          <a:noFill/>
+                <a:latin typeface="Consolas"/>
+                <a:cs typeface="Consolas"/>
+              </a:rPr>
+              <a:t xml:space="preserve">P03	no	0</a:t>
+            </a:r>
+          </a:p>
+        </p:txBody>
+      </p:sp>
+      <p:sp>
+        <p:nvSpPr>
+          <p:cNvPr id="1042" name="Instance row 4"/>
+          <p:cNvSpPr/>
+          <p:nvPr/>
+        </p:nvSpPr>
+        <p:spPr>
+          <a:xfrm>
+            <a:off x="960120" y="4114800"/>
+            <a:ext cx="2743200" cy="246888"/>
+          </a:xfrm>
+          <a:prstGeom prst="roundRect">
+            <a:avLst>
+              <a:gd name="adj" fmla="val 12000"/>
+            </a:avLst>
+          </a:prstGeom>
+          <a:solidFill>
+            <a:srgbClr val="E6F2EC"/>
+          </a:solidFill>
           <a:ln>
             <a:noFill/>
           </a:ln>
         </p:spPr>
         <p:txBody>
-          <a:bodyPr anchorCtr="0" anchor="ctr" bIns="0" lIns="0" spcFirstLastPara="1" rIns="0" wrap="square" tIns="0">
-            <a:spAutoFit/>
-          </a:bodyPr>
-          <a:lstStyle/>
-          <a:p>
-            <a:pPr indent="0" lvl="0" marL="0" marR="0" rtl="0" algn="l">
+          <a:bodyPr wrap="square" lIns="91440" tIns="0" rIns="91440" bIns="0" anchor="ctr">
+            <a:noAutofit/>
+          </a:bodyPr>
+          <a:lstStyle/>
+          <a:p>
+            <a:pPr algn="l">
+              <a:tabLst>
+                <a:tab pos="777240" algn="l"/>
+                <a:tab pos="1737360" algn="l"/>
+              </a:tabLst>
+            </a:pPr>
+            <a:r>
+              <a:rPr lang="en-US" sz="1150" b="0" dirty="0">
+                <a:solidFill>
+                  <a:srgbClr val="1F2328"/>
+                </a:solidFill>
+                <a:latin typeface="Consolas"/>
+                <a:cs typeface="Consolas"/>
+              </a:rPr>
+              <a:t xml:space="preserve">P04	yes	1</a:t>
+            </a:r>
+          </a:p>
+        </p:txBody>
+      </p:sp>
+      <p:sp>
+        <p:nvSpPr>
+          <p:cNvPr id="1043" name="Instance row 5"/>
+          <p:cNvSpPr txBox="1"/>
+          <p:nvPr/>
+        </p:nvSpPr>
+        <p:spPr>
+          <a:xfrm>
+            <a:off x="960120" y="4389120"/>
+            <a:ext cx="2743200" cy="246888"/>
+          </a:xfrm>
+          <a:prstGeom prst="roundRect">
+            <a:avLst>
+              <a:gd name="adj" fmla="val 12000"/>
+            </a:avLst>
+          </a:prstGeom>
+          <a:noFill/>
+          <a:ln>
+            <a:noFill/>
+          </a:ln>
+        </p:spPr>
+        <p:txBody>
+          <a:bodyPr wrap="square" lIns="91440" tIns="0" rIns="91440" bIns="0" anchor="ctr">
+            <a:noAutofit/>
+          </a:bodyPr>
+          <a:lstStyle/>
+          <a:p>
+            <a:pPr algn="l">
+              <a:tabLst>
+                <a:tab pos="777240" algn="l"/>
+                <a:tab pos="1737360" algn="l"/>
+              </a:tabLst>
+            </a:pPr>
+            <a:r>
+              <a:rPr lang="en-US" sz="1150" b="0" dirty="0">
+                <a:solidFill>
+                  <a:srgbClr val="1F2328"/>
+                </a:solidFill>
+                <a:latin typeface="Consolas"/>
+                <a:cs typeface="Consolas"/>
+              </a:rPr>
+              <a:t xml:space="preserve">P05	no	0</a:t>
+            </a:r>
+          </a:p>
+        </p:txBody>
+      </p:sp>
+      <p:sp>
+        <p:nvSpPr>
+          <p:cNvPr id="1044" name="Card 1 note"/>
+          <p:cNvSpPr txBox="1"/>
+          <p:nvPr/>
+        </p:nvSpPr>
+        <p:spPr>
+          <a:xfrm>
+            <a:off x="1024128" y="4736592"/>
+            <a:ext cx="2651760" cy="384048"/>
+          </a:xfrm>
+          <a:prstGeom prst="rect">
+            <a:avLst/>
+          </a:prstGeom>
+          <a:noFill/>
+          <a:ln>
+            <a:noFill/>
+          </a:ln>
+        </p:spPr>
+        <p:txBody>
+          <a:bodyPr wrap="square" lIns="0" tIns="0" rIns="0" bIns="0" anchor="t">
+            <a:noAutofit/>
+          </a:bodyPr>
+          <a:lstStyle/>
+          <a:p>
+            <a:pPr algn="l"/>
+            <a:r>
+              <a:rPr lang="en-US" sz="1100" b="0" dirty="0">
+                <a:solidFill>
+                  <a:srgbClr val="5B6770"/>
+                </a:solidFill>
+                <a:latin typeface="Calibri"/>
+                <a:cs typeface="Calibri"/>
+              </a:rPr>
+              <a:t xml:space="preserve">Synthetic illustration. Rows also reveal codes: BM_DEP is only 0 or 1.</a:t>
+            </a:r>
+          </a:p>
+        </p:txBody>
+      </p:sp>
+      <p:sp>
+        <p:nvSpPr>
+          <p:cNvPr id="1045" name="Card 2 label"/>
+          <p:cNvSpPr txBox="1"/>
+          <p:nvPr/>
+        </p:nvSpPr>
+        <p:spPr>
+          <a:xfrm>
+            <a:off x="4425696" y="2359152"/>
+            <a:ext cx="2423160" cy="274320"/>
+          </a:xfrm>
+          <a:prstGeom prst="rect">
+            <a:avLst/>
+          </a:prstGeom>
+          <a:noFill/>
+          <a:ln>
+            <a:noFill/>
+          </a:ln>
+        </p:spPr>
+        <p:txBody>
+          <a:bodyPr wrap="square" lIns="0" tIns="0" rIns="0" bIns="0" anchor="t">
+            <a:noAutofit/>
+          </a:bodyPr>
+          <a:lstStyle/>
+          <a:p>
+            <a:pPr algn="l"/>
+            <a:r>
+              <a:rPr lang="en-US" sz="1300" b="1" dirty="0">
+                <a:solidFill>
+                  <a:srgbClr val="2F6B78"/>
+                </a:solidFill>
+                <a:latin typeface="Consolas"/>
+                <a:cs typeface="Consolas"/>
+              </a:rPr>
+              <a:t xml:space="preserve">2  + DOCUMENTATION</a:t>
+            </a:r>
+          </a:p>
+        </p:txBody>
+      </p:sp>
+      <p:sp>
+        <p:nvSpPr>
+          <p:cNvPr id="1046" name="Card 2 sub"/>
+          <p:cNvSpPr txBox="1"/>
+          <p:nvPr/>
+        </p:nvSpPr>
+        <p:spPr>
+          <a:xfrm>
+            <a:off x="4425696" y="2651760"/>
+            <a:ext cx="2423160" cy="256032"/>
+          </a:xfrm>
+          <a:prstGeom prst="rect">
+            <a:avLst/>
+          </a:prstGeom>
+          <a:noFill/>
+          <a:ln>
+            <a:noFill/>
+          </a:ln>
+        </p:spPr>
+        <p:txBody>
+          <a:bodyPr wrap="square" lIns="0" tIns="0" rIns="0" bIns="0" anchor="t">
+            <a:noAutofit/>
+          </a:bodyPr>
+          <a:lstStyle/>
+          <a:p>
+            <a:pPr algn="l"/>
+            <a:r>
+              <a:rPr lang="en-US" sz="1300" b="0" dirty="0">
+                <a:solidFill>
+                  <a:srgbClr val="5B6770"/>
+                </a:solidFill>
+                <a:latin typeface="Calibri"/>
+                <a:cs typeface="Calibri"/>
+              </a:rPr>
+              <a:t xml:space="preserve">What the drug label says</a:t>
+            </a:r>
+          </a:p>
+        </p:txBody>
+      </p:sp>
+      <p:sp>
+        <p:nvSpPr>
+          <p:cNvPr id="1047" name="Drug label quote"/>
+          <p:cNvSpPr/>
+          <p:nvPr/>
+        </p:nvSpPr>
+        <p:spPr>
+          <a:xfrm>
+            <a:off x="4389120" y="3017520"/>
+            <a:ext cx="2459736" cy="1115568"/>
+          </a:xfrm>
+          <a:prstGeom prst="roundRect">
+            <a:avLst>
+              <a:gd name="adj" fmla="val 12000"/>
+            </a:avLst>
+          </a:prstGeom>
+          <a:solidFill>
+            <a:srgbClr val="F3F5F4"/>
+          </a:solidFill>
+          <a:ln>
+            <a:noFill/>
+          </a:ln>
+        </p:spPr>
+        <p:txBody>
+          <a:bodyPr wrap="square" lIns="128016" tIns="0" rIns="128016" bIns="0" anchor="ctr">
+            <a:noAutofit/>
+          </a:bodyPr>
+          <a:lstStyle/>
+          <a:p>
+            <a:pPr algn="l"/>
+            <a:r>
+              <a:rPr lang="en-US" sz="1400" b="0" dirty="0" i="1">
+                <a:solidFill>
+                  <a:srgbClr val="1F2328"/>
+                </a:solidFill>
+                <a:latin typeface="Calibri"/>
+                <a:cs typeface="Calibri"/>
+              </a:rPr>
+              <a:t xml:space="preserve">Myelosuppression (bone-marrow suppression) is a documented adverse reaction of cisplatin.</a:t>
+            </a:r>
+          </a:p>
+        </p:txBody>
+      </p:sp>
+      <p:sp>
+        <p:nvSpPr>
+          <p:cNvPr id="1048" name="Quote source"/>
+          <p:cNvSpPr txBox="1"/>
+          <p:nvPr/>
+        </p:nvSpPr>
+        <p:spPr>
+          <a:xfrm>
+            <a:off x="4425696" y="4169664"/>
+            <a:ext cx="2423160" cy="201168"/>
+          </a:xfrm>
+          <a:prstGeom prst="rect">
+            <a:avLst/>
+          </a:prstGeom>
+          <a:noFill/>
+          <a:ln>
+            <a:noFill/>
+          </a:ln>
+        </p:spPr>
+        <p:txBody>
+          <a:bodyPr wrap="square" lIns="0" tIns="0" rIns="0" bIns="0" anchor="t">
+            <a:noAutofit/>
+          </a:bodyPr>
+          <a:lstStyle/>
+          <a:p>
+            <a:pPr algn="l"/>
+            <a:r>
+              <a:rPr lang="en-US" sz="1000" b="0" dirty="0">
+                <a:solidFill>
+                  <a:srgbClr val="5B6770"/>
+                </a:solidFill>
+                <a:latin typeface="Calibri"/>
+                <a:cs typeface="Calibri"/>
+              </a:rPr>
+              <a:t xml:space="preserve">Cisplatin drug label, paraphrased</a:t>
+            </a:r>
+          </a:p>
+        </p:txBody>
+      </p:sp>
+      <p:sp>
+        <p:nvSpPr>
+          <p:cNvPr id="1049" name="Card 2 note"/>
+          <p:cNvSpPr txBox="1"/>
+          <p:nvPr/>
+        </p:nvSpPr>
+        <p:spPr>
+          <a:xfrm>
+            <a:off x="4425696" y="4480560"/>
+            <a:ext cx="2423160" cy="548640"/>
+          </a:xfrm>
+          <a:prstGeom prst="rect">
+            <a:avLst/>
+          </a:prstGeom>
+          <a:noFill/>
+          <a:ln>
+            <a:noFill/>
+          </a:ln>
+        </p:spPr>
+        <p:txBody>
+          <a:bodyPr wrap="square" lIns="0" tIns="0" rIns="0" bIns="0" anchor="t">
+            <a:noAutofit/>
+          </a:bodyPr>
+          <a:lstStyle/>
+          <a:p>
+            <a:pPr algn="l"/>
+            <a:r>
+              <a:rPr lang="en-US" sz="1200" b="0" dirty="0">
+                <a:solidFill>
+                  <a:srgbClr val="3A434C"/>
+                </a:solidFill>
+                <a:latin typeface="Calibri"/>
+                <a:cs typeface="Calibri"/>
+              </a:rPr>
+              <a:t xml:space="preserve">Timing is evidence too: BM_DEP is recorded after the first cycle.</a:t>
+            </a:r>
+          </a:p>
+        </p:txBody>
+      </p:sp>
+      <p:sp>
+        <p:nvSpPr>
+          <p:cNvPr id="1050" name="Card 3 label"/>
+          <p:cNvSpPr txBox="1"/>
+          <p:nvPr/>
+        </p:nvSpPr>
+        <p:spPr>
+          <a:xfrm>
+            <a:off x="7598664" y="2359152"/>
+            <a:ext cx="3575303" cy="274320"/>
+          </a:xfrm>
+          <a:prstGeom prst="rect">
+            <a:avLst/>
+          </a:prstGeom>
+          <a:noFill/>
+          <a:ln>
+            <a:noFill/>
+          </a:ln>
+        </p:spPr>
+        <p:txBody>
+          <a:bodyPr wrap="square" lIns="0" tIns="0" rIns="0" bIns="0" anchor="t">
+            <a:noAutofit/>
+          </a:bodyPr>
+          <a:lstStyle/>
+          <a:p>
+            <a:pPr algn="l"/>
+            <a:r>
+              <a:rPr lang="en-US" sz="1300" b="1" dirty="0">
+                <a:solidFill>
+                  <a:srgbClr val="0B6E4F"/>
+                </a:solidFill>
+                <a:latin typeface="Consolas"/>
+                <a:cs typeface="Consolas"/>
+              </a:rPr>
+              <a:t xml:space="preserve">3  CANDIDATE KNOWLEDGE</a:t>
+            </a:r>
+          </a:p>
+        </p:txBody>
+      </p:sp>
+      <p:sp>
+        <p:nvSpPr>
+          <p:cNvPr id="1051" name="Card 3 sub"/>
+          <p:cNvSpPr txBox="1"/>
+          <p:nvPr/>
+        </p:nvSpPr>
+        <p:spPr>
+          <a:xfrm>
+            <a:off x="7598664" y="2651760"/>
+            <a:ext cx="3575303" cy="256032"/>
+          </a:xfrm>
+          <a:prstGeom prst="rect">
+            <a:avLst/>
+          </a:prstGeom>
+          <a:noFill/>
+          <a:ln>
+            <a:noFill/>
+          </a:ln>
+        </p:spPr>
+        <p:txBody>
+          <a:bodyPr wrap="square" lIns="0" tIns="0" rIns="0" bIns="0" anchor="t">
+            <a:noAutofit/>
+          </a:bodyPr>
+          <a:lstStyle/>
+          <a:p>
+            <a:pPr algn="l"/>
+            <a:r>
+              <a:rPr lang="en-US" sz="1300" b="0" dirty="0">
+                <a:solidFill>
+                  <a:srgbClr val="5B6770"/>
+                </a:solidFill>
+                <a:latin typeface="Calibri"/>
+                <a:cs typeface="Calibri"/>
+              </a:rPr>
+              <a:t xml:space="preserve">A reviewable hypothesis, not a fact</a:t>
+            </a:r>
+          </a:p>
+        </p:txBody>
+      </p:sp>
+      <p:sp>
+        <p:nvSpPr>
+          <p:cNvPr id="1052" name="Code 1052" descr="OWL Manchester Syntax excerpt"/>
+          <p:cNvSpPr txBox="1"/>
+          <p:nvPr/>
+        </p:nvSpPr>
+        <p:spPr>
+          <a:xfrm>
+            <a:off x="7534656" y="2962656"/>
+            <a:ext cx="3666744" cy="1575054"/>
+          </a:xfrm>
+          <a:prstGeom prst="roundRect">
+            <a:avLst>
+              <a:gd name="adj" fmla="val 5000"/>
+            </a:avLst>
+          </a:prstGeom>
+          <a:solidFill>
+            <a:srgbClr val="F6F8FA"/>
+          </a:solidFill>
+          <a:ln w="9525">
+            <a:solidFill>
+              <a:srgbClr val="D0D7DE"/>
+            </a:solidFill>
+          </a:ln>
+        </p:spPr>
+        <p:txBody>
+          <a:bodyPr wrap="none" lIns="91440" tIns="73152" rIns="91440" bIns="54864" anchor="t">
+            <a:noAutofit/>
+          </a:bodyPr>
+          <a:lstStyle/>
+          <a:p>
+            <a:pPr>
               <a:lnSpc>
-                <a:spcPct val="105000"/>
+                <a:spcPts val="1250"/>
               </a:lnSpc>
               <a:spcBef>
                 <a:spcPts val="0"/>
               </a:spcBef>
-              <a:spcAft>
-                <a:spcPts val="0"/>
-              </a:spcAft>
-              <a:buNone/>
-            </a:pPr>
-            <a:r>
-              <a:rPr b="0" lang="en-US" sz="1520">
+            </a:pPr>
+            <a:r>
+              <a:rPr lang="en-US" sz="1100" b="1" i="0" dirty="0">
+                <a:solidFill>
+                  <a:srgbClr val="0B6E4F"/>
+                </a:solidFill>
+                <a:latin typeface="Consolas"/>
+                <a:cs typeface="Consolas"/>
+              </a:rPr>
+              <a:t xml:space="preserve">Individual:</a:t>
+            </a:r>
+            <a:r>
+              <a:rPr lang="en-US" sz="1100" b="0" i="0" dirty="0">
+                <a:solidFill>
+                  <a:srgbClr val="1F2328"/>
+                </a:solidFill>
+                <a:latin typeface="Consolas"/>
+                <a:cs typeface="Consolas"/>
+              </a:rPr>
+              <a:t xml:space="preserve"> </a:t>
+            </a:r>
+            <a:r>
+              <a:rPr lang="en-US" sz="1100" b="0" i="0" dirty="0">
+                <a:solidFill>
+                  <a:srgbClr val="1F2328"/>
+                </a:solidFill>
+                <a:latin typeface="Consolas"/>
+                <a:cs typeface="Consolas"/>
+              </a:rPr>
+              <a:t xml:space="preserve">cisplatin_bmdep</a:t>
+            </a:r>
+            <a:endParaRPr lang="en-US" sz="1100"/>
+          </a:p>
+          <a:p>
+            <a:pPr>
+              <a:lnSpc>
+                <a:spcPts val="1250"/>
+              </a:lnSpc>
+              <a:spcBef>
+                <a:spcPts val="0"/>
+              </a:spcBef>
+            </a:pPr>
+            <a:r>
+              <a:rPr lang="en-US" sz="1100" b="0" i="0" dirty="0">
+                <a:solidFill>
+                  <a:srgbClr val="1F2328"/>
+                </a:solidFill>
+                <a:latin typeface="Consolas"/>
+                <a:cs typeface="Consolas"/>
+              </a:rPr>
+              <a:t xml:space="preserve">  </a:t>
+            </a:r>
+            <a:r>
+              <a:rPr lang="en-US" sz="1100" b="1" i="0" dirty="0">
+                <a:solidFill>
+                  <a:srgbClr val="0B6E4F"/>
+                </a:solidFill>
+                <a:latin typeface="Consolas"/>
+                <a:cs typeface="Consolas"/>
+              </a:rPr>
+              <a:t xml:space="preserve">Types:</a:t>
+            </a:r>
+            <a:r>
+              <a:rPr lang="en-US" sz="1100" b="0" i="0" dirty="0">
+                <a:solidFill>
+                  <a:srgbClr val="1F2328"/>
+                </a:solidFill>
+                <a:latin typeface="Consolas"/>
+                <a:cs typeface="Consolas"/>
+              </a:rPr>
+              <a:t xml:space="preserve"> </a:t>
+            </a:r>
+            <a:r>
+              <a:rPr lang="en-US" sz="1100" b="0" i="0" dirty="0">
+                <a:solidFill>
+                  <a:srgbClr val="1F2328"/>
+                </a:solidFill>
+                <a:latin typeface="Consolas"/>
+                <a:cs typeface="Consolas"/>
+              </a:rPr>
+              <a:t xml:space="preserve">CandidateAssociation</a:t>
+            </a:r>
+            <a:endParaRPr lang="en-US" sz="1100"/>
+          </a:p>
+          <a:p>
+            <a:pPr>
+              <a:lnSpc>
+                <a:spcPts val="1250"/>
+              </a:lnSpc>
+              <a:spcBef>
+                <a:spcPts val="0"/>
+              </a:spcBef>
+            </a:pPr>
+            <a:r>
+              <a:rPr lang="en-US" sz="1100" b="0" i="0" dirty="0">
+                <a:solidFill>
+                  <a:srgbClr val="1F2328"/>
+                </a:solidFill>
+                <a:latin typeface="Consolas"/>
+                <a:cs typeface="Consolas"/>
+              </a:rPr>
+              <a:t xml:space="preserve">  </a:t>
+            </a:r>
+            <a:r>
+              <a:rPr lang="en-US" sz="1100" b="1" i="0" dirty="0">
+                <a:solidFill>
+                  <a:srgbClr val="0B6E4F"/>
+                </a:solidFill>
+                <a:latin typeface="Consolas"/>
+                <a:cs typeface="Consolas"/>
+              </a:rPr>
+              <a:t xml:space="preserve">Facts:</a:t>
+            </a:r>
+            <a:endParaRPr lang="en-US" sz="1100"/>
+          </a:p>
+          <a:p>
+            <a:pPr>
+              <a:lnSpc>
+                <a:spcPts val="1250"/>
+              </a:lnSpc>
+              <a:spcBef>
+                <a:spcPts val="0"/>
+              </a:spcBef>
+            </a:pPr>
+            <a:r>
+              <a:rPr lang="en-US" sz="1100" b="0" i="0" dirty="0">
+                <a:solidFill>
+                  <a:srgbClr val="1F2328"/>
+                </a:solidFill>
+                <a:latin typeface="Consolas"/>
+                <a:cs typeface="Consolas"/>
+              </a:rPr>
+              <a:t xml:space="preserve">    </a:t>
+            </a:r>
+            <a:r>
+              <a:rPr lang="en-US" sz="1100" b="0" i="0" dirty="0">
+                <a:solidFill>
+                  <a:srgbClr val="1F2328"/>
+                </a:solidFill>
+                <a:latin typeface="Consolas"/>
+                <a:cs typeface="Consolas"/>
+              </a:rPr>
+              <a:t xml:space="preserve">hasDrug</a:t>
+            </a:r>
+            <a:r>
+              <a:rPr lang="en-US" sz="1100" b="0" i="0" dirty="0">
+                <a:solidFill>
+                  <a:srgbClr val="1F2328"/>
+                </a:solidFill>
+                <a:latin typeface="Consolas"/>
+                <a:cs typeface="Consolas"/>
+              </a:rPr>
+              <a:t xml:space="preserve"> </a:t>
+            </a:r>
+            <a:r>
+              <a:rPr lang="en-US" sz="1100" b="0" i="0" dirty="0">
+                <a:solidFill>
+                  <a:srgbClr val="1F2328"/>
+                </a:solidFill>
+                <a:latin typeface="Consolas"/>
+                <a:cs typeface="Consolas"/>
+              </a:rPr>
+              <a:t xml:space="preserve">Cisplatin</a:t>
+            </a:r>
+            <a:r>
+              <a:rPr lang="en-US" sz="1100" b="0" i="0" dirty="0">
+                <a:solidFill>
+                  <a:srgbClr val="1F2328"/>
+                </a:solidFill>
+                <a:latin typeface="Consolas"/>
+                <a:cs typeface="Consolas"/>
+              </a:rPr>
+              <a:t xml:space="preserve">,</a:t>
+            </a:r>
+            <a:endParaRPr lang="en-US" sz="1100"/>
+          </a:p>
+          <a:p>
+            <a:pPr>
+              <a:lnSpc>
+                <a:spcPts val="1250"/>
+              </a:lnSpc>
+              <a:spcBef>
+                <a:spcPts val="0"/>
+              </a:spcBef>
+            </a:pPr>
+            <a:r>
+              <a:rPr lang="en-US" sz="1100" b="0" i="0" dirty="0">
+                <a:solidFill>
+                  <a:srgbClr val="1F2328"/>
+                </a:solidFill>
+                <a:latin typeface="Consolas"/>
+                <a:cs typeface="Consolas"/>
+              </a:rPr>
+              <a:t xml:space="preserve">    </a:t>
+            </a:r>
+            <a:r>
+              <a:rPr lang="en-US" sz="1100" b="0" i="0" dirty="0">
+                <a:solidFill>
+                  <a:srgbClr val="1F2328"/>
+                </a:solidFill>
+                <a:latin typeface="Consolas"/>
+                <a:cs typeface="Consolas"/>
+              </a:rPr>
+              <a:t xml:space="preserve">hasCondition</a:t>
+            </a:r>
+            <a:r>
+              <a:rPr lang="en-US" sz="1100" b="0" i="0" dirty="0">
+                <a:solidFill>
+                  <a:srgbClr val="1F2328"/>
+                </a:solidFill>
+                <a:latin typeface="Consolas"/>
+                <a:cs typeface="Consolas"/>
+              </a:rPr>
+              <a:t xml:space="preserve"> </a:t>
+            </a:r>
+            <a:r>
+              <a:rPr lang="en-US" sz="1100" b="0" i="0" dirty="0">
+                <a:solidFill>
+                  <a:srgbClr val="1F2328"/>
+                </a:solidFill>
+                <a:latin typeface="Consolas"/>
+                <a:cs typeface="Consolas"/>
+              </a:rPr>
+              <a:t xml:space="preserve">BoneMarrowDepression</a:t>
+            </a:r>
+            <a:r>
+              <a:rPr lang="en-US" sz="1100" b="0" i="0" dirty="0">
+                <a:solidFill>
+                  <a:srgbClr val="1F2328"/>
+                </a:solidFill>
+                <a:latin typeface="Consolas"/>
+                <a:cs typeface="Consolas"/>
+              </a:rPr>
+              <a:t xml:space="preserve">,</a:t>
+            </a:r>
+            <a:endParaRPr lang="en-US" sz="1100"/>
+          </a:p>
+          <a:p>
+            <a:pPr>
+              <a:lnSpc>
+                <a:spcPts val="1250"/>
+              </a:lnSpc>
+              <a:spcBef>
+                <a:spcPts val="0"/>
+              </a:spcBef>
+            </a:pPr>
+            <a:r>
+              <a:rPr lang="en-US" sz="1100" b="0" i="0" dirty="0">
+                <a:solidFill>
+                  <a:srgbClr val="1F2328"/>
+                </a:solidFill>
+                <a:latin typeface="Consolas"/>
+                <a:cs typeface="Consolas"/>
+              </a:rPr>
+              <a:t xml:space="preserve">    </a:t>
+            </a:r>
+            <a:r>
+              <a:rPr lang="en-US" sz="1100" b="0" i="0" dirty="0">
+                <a:solidFill>
+                  <a:srgbClr val="1F2328"/>
+                </a:solidFill>
+                <a:latin typeface="Consolas"/>
+                <a:cs typeface="Consolas"/>
+              </a:rPr>
+              <a:t xml:space="preserve">status</a:t>
+            </a:r>
+            <a:r>
+              <a:rPr lang="en-US" sz="1100" b="0" i="0" dirty="0">
+                <a:solidFill>
+                  <a:srgbClr val="1F2328"/>
+                </a:solidFill>
+                <a:latin typeface="Consolas"/>
+                <a:cs typeface="Consolas"/>
+              </a:rPr>
+              <a:t xml:space="preserve"> </a:t>
+            </a:r>
+            <a:r>
+              <a:rPr lang="en-US" sz="1100" b="0" i="0" dirty="0">
+                <a:solidFill>
+                  <a:srgbClr val="A3401E"/>
+                </a:solidFill>
+                <a:latin typeface="Consolas"/>
+                <a:cs typeface="Consolas"/>
+              </a:rPr>
+              <a:t xml:space="preserve">"needs expert review"</a:t>
+            </a:r>
+            <a:endParaRPr lang="en-US" sz="1100"/>
+          </a:p>
+          <a:p>
+            <a:pPr>
+              <a:lnSpc>
+                <a:spcPts val="1250"/>
+              </a:lnSpc>
+              <a:spcBef>
+                <a:spcPts val="0"/>
+              </a:spcBef>
+            </a:pPr>
+            <a:r>
+              <a:rPr lang="en-US" sz="1100" b="0" i="0" dirty="0">
+                <a:solidFill>
+                  <a:srgbClr val="1F2328"/>
+                </a:solidFill>
+                <a:latin typeface="Consolas"/>
+                <a:cs typeface="Consolas"/>
+              </a:rPr>
+              <a:t xml:space="preserve">  </a:t>
+            </a:r>
+            <a:r>
+              <a:rPr lang="en-US" sz="1100" b="1" i="0" dirty="0">
+                <a:solidFill>
+                  <a:srgbClr val="0B6E4F"/>
+                </a:solidFill>
+                <a:latin typeface="Consolas"/>
+                <a:cs typeface="Consolas"/>
+              </a:rPr>
+              <a:t xml:space="preserve">Annotations:</a:t>
+            </a:r>
+            <a:endParaRPr lang="en-US" sz="1100"/>
+          </a:p>
+          <a:p>
+            <a:pPr>
+              <a:lnSpc>
+                <a:spcPts val="1250"/>
+              </a:lnSpc>
+              <a:spcBef>
+                <a:spcPts val="0"/>
+              </a:spcBef>
+            </a:pPr>
+            <a:r>
+              <a:rPr lang="en-US" sz="1100" b="0" i="0" dirty="0">
+                <a:solidFill>
+                  <a:srgbClr val="1F2328"/>
+                </a:solidFill>
+                <a:latin typeface="Consolas"/>
+                <a:cs typeface="Consolas"/>
+              </a:rPr>
+              <a:t xml:space="preserve">    </a:t>
+            </a:r>
+            <a:r>
+              <a:rPr lang="en-US" sz="1100" b="0" i="0" dirty="0">
                 <a:solidFill>
                   <a:srgbClr val="5B6770"/>
                 </a:solidFill>
+                <a:latin typeface="Consolas"/>
+                <a:cs typeface="Consolas"/>
+              </a:rPr>
+              <a:t xml:space="preserve">prov:wasDerivedFrom</a:t>
+            </a:r>
+            <a:r>
+              <a:rPr lang="en-US" sz="1100" b="0" i="0" dirty="0">
+                <a:solidFill>
+                  <a:srgbClr val="1F2328"/>
+                </a:solidFill>
+                <a:latin typeface="Consolas"/>
+                <a:cs typeface="Consolas"/>
+              </a:rPr>
+              <a:t xml:space="preserve"> </a:t>
+            </a:r>
+            <a:r>
+              <a:rPr lang="en-US" sz="1100" b="0" i="0" dirty="0">
+                <a:solidFill>
+                  <a:srgbClr val="2F6B78"/>
+                </a:solidFill>
+                <a:latin typeface="Consolas"/>
+                <a:cs typeface="Consolas"/>
+              </a:rPr>
+              <a:t xml:space="preserve">src:BM_DEP</a:t>
+            </a:r>
+            <a:r>
+              <a:rPr lang="en-US" sz="1100" b="0" i="0" dirty="0">
+                <a:solidFill>
+                  <a:srgbClr val="1F2328"/>
+                </a:solidFill>
+                <a:latin typeface="Consolas"/>
+                <a:cs typeface="Consolas"/>
+              </a:rPr>
+              <a:t xml:space="preserve">,</a:t>
+            </a:r>
+            <a:endParaRPr lang="en-US" sz="1100"/>
+          </a:p>
+          <a:p>
+            <a:pPr>
+              <a:lnSpc>
+                <a:spcPts val="1250"/>
+              </a:lnSpc>
+              <a:spcBef>
+                <a:spcPts val="0"/>
+              </a:spcBef>
+            </a:pPr>
+            <a:r>
+              <a:rPr lang="en-US" sz="1100" b="0" i="0" dirty="0">
+                <a:solidFill>
+                  <a:srgbClr val="1F2328"/>
+                </a:solidFill>
+                <a:latin typeface="Consolas"/>
+                <a:cs typeface="Consolas"/>
+              </a:rPr>
+              <a:t xml:space="preserve">    </a:t>
+            </a:r>
+            <a:r>
+              <a:rPr lang="en-US" sz="1100" b="0" i="0" dirty="0">
+                <a:solidFill>
+                  <a:srgbClr val="5B6770"/>
+                </a:solidFill>
+                <a:latin typeface="Consolas"/>
+                <a:cs typeface="Consolas"/>
+              </a:rPr>
+              <a:t xml:space="preserve">prov:wasDerivedFrom</a:t>
+            </a:r>
+            <a:r>
+              <a:rPr lang="en-US" sz="1100" b="0" i="0" dirty="0">
+                <a:solidFill>
+                  <a:srgbClr val="1F2328"/>
+                </a:solidFill>
+                <a:latin typeface="Consolas"/>
+                <a:cs typeface="Consolas"/>
+              </a:rPr>
+              <a:t xml:space="preserve"> </a:t>
+            </a:r>
+            <a:r>
+              <a:rPr lang="en-US" sz="1100" b="0" i="0" dirty="0">
+                <a:solidFill>
+                  <a:srgbClr val="2F6B78"/>
+                </a:solidFill>
+                <a:latin typeface="Consolas"/>
+                <a:cs typeface="Consolas"/>
+              </a:rPr>
+              <a:t xml:space="preserve">doc:cisplatin_label</a:t>
+            </a:r>
+            <a:endParaRPr lang="en-US" sz="1100"/>
+          </a:p>
+        </p:txBody>
+      </p:sp>
+      <p:sp>
+        <p:nvSpPr>
+          <p:cNvPr id="1053" name="Card 3 note"/>
+          <p:cNvSpPr txBox="1"/>
+          <p:nvPr/>
+        </p:nvSpPr>
+        <p:spPr>
+          <a:xfrm>
+            <a:off x="7598664" y="4626864"/>
+            <a:ext cx="3575303" cy="475488"/>
+          </a:xfrm>
+          <a:prstGeom prst="rect">
+            <a:avLst/>
+          </a:prstGeom>
+          <a:noFill/>
+          <a:ln>
+            <a:noFill/>
+          </a:ln>
+        </p:spPr>
+        <p:txBody>
+          <a:bodyPr wrap="square" lIns="0" tIns="0" rIns="0" bIns="0" anchor="t">
+            <a:noAutofit/>
+          </a:bodyPr>
+          <a:lstStyle/>
+          <a:p>
+            <a:pPr algn="l"/>
+            <a:r>
+              <a:rPr lang="en-US" sz="1100" b="1" dirty="0">
+                <a:solidFill>
+                  <a:srgbClr val="B23A1E"/>
+                </a:solidFill>
                 <a:latin typeface="Calibri"/>
-                <a:ea typeface="Calibri"/>
                 <a:cs typeface="Calibri"/>
-                <a:sym typeface="Calibri"/>
-              </a:rPr>
-              <a:t>Expert study: 4 medical tables. Downstream applications remain untested.</a:t>
-            </a:r>
-            <a:endParaRPr/>
+              </a:rPr>
+              <a:t xml:space="preserve">No causes axiom. </a:t>
+            </a:r>
+            <a:r>
+              <a:rPr lang="en-US" sz="1100" b="0" dirty="0">
+                <a:solidFill>
+                  <a:srgbClr val="3A434C"/>
+                </a:solidFill>
+                <a:latin typeface="Calibri"/>
+                <a:cs typeface="Calibri"/>
+              </a:rPr>
+              <a:t xml:space="preserve">Co-administered gemcitabine, radiotherapy or cirrhosis can also suppress the marrow.</a:t>
+            </a:r>
+          </a:p>
+        </p:txBody>
+      </p:sp>
+      <p:sp>
+        <p:nvSpPr>
+          <p:cNvPr id="1054" name="Also next strip"/>
+          <p:cNvSpPr/>
+          <p:nvPr/>
+        </p:nvSpPr>
+        <p:spPr>
+          <a:xfrm>
+            <a:off x="822960" y="5340096"/>
+            <a:ext cx="10515600" cy="420624"/>
+          </a:xfrm>
+          <a:prstGeom prst="roundRect">
+            <a:avLst>
+              <a:gd name="adj" fmla="val 12000"/>
+            </a:avLst>
+          </a:prstGeom>
+          <a:solidFill>
+            <a:srgbClr val="E6F2EC"/>
+          </a:solidFill>
+          <a:ln>
+            <a:noFill/>
+          </a:ln>
+        </p:spPr>
+        <p:txBody>
+          <a:bodyPr wrap="square" lIns="182880" tIns="0" rIns="182880" bIns="0" anchor="ctr">
+            <a:noAutofit/>
+          </a:bodyPr>
+          <a:lstStyle/>
+          <a:p>
+            <a:pPr algn="l"/>
+            <a:r>
+              <a:rPr lang="en-US" sz="1250" b="1" dirty="0">
+                <a:solidFill>
+                  <a:srgbClr val="0B6E4F"/>
+                </a:solidFill>
+                <a:latin typeface="Calibri"/>
+                <a:cs typeface="Calibri"/>
+              </a:rPr>
+              <a:t xml:space="preserve">ALSO NEXT   </a:t>
+            </a:r>
+            <a:r>
+              <a:rPr lang="en-US" sz="1250" b="0" dirty="0">
+                <a:solidFill>
+                  <a:srgbClr val="1F2328"/>
+                </a:solidFill>
+                <a:latin typeface="Calibri"/>
+                <a:cs typeface="Calibri"/>
+              </a:rPr>
+              <a:t xml:space="preserve">Validator and reasoner feedback inside the loop, to catch residual P19  ·  aggregate statistics only, so patient data stays in the hospital</a:t>
+            </a:r>
+          </a:p>
+        </p:txBody>
+      </p:sp>
+      <p:sp>
+        <p:nvSpPr>
+          <p:cNvPr id="1055" name="Future caption"/>
+          <p:cNvSpPr txBox="1"/>
+          <p:nvPr/>
+        </p:nvSpPr>
+        <p:spPr>
+          <a:xfrm>
+            <a:off x="850392" y="5870448"/>
+            <a:ext cx="10488168" cy="237744"/>
+          </a:xfrm>
+          <a:prstGeom prst="rect">
+            <a:avLst/>
+          </a:prstGeom>
+          <a:noFill/>
+          <a:ln>
+            <a:noFill/>
+          </a:ln>
+        </p:spPr>
+        <p:txBody>
+          <a:bodyPr wrap="square" lIns="0" tIns="0" rIns="0" bIns="0" anchor="t">
+            <a:noAutofit/>
+          </a:bodyPr>
+          <a:lstStyle/>
+          <a:p>
+            <a:pPr algn="l"/>
+            <a:r>
+              <a:rPr lang="en-US" sz="1050" b="0" dirty="0">
+                <a:solidFill>
+                  <a:srgbClr val="5B6770"/>
+                </a:solidFill>
+                <a:latin typeface="Calibri"/>
+                <a:cs typeface="Calibri"/>
+              </a:rPr>
+              <a:t xml:space="preserve">Instance rows are synthetic. Future directions follow paper Section 5 (instance-level signals, tool feedback, symbolic reasoning).</a:t>
+            </a:r>
           </a:p>
         </p:txBody>
       </p:sp>
@@ -50606,7 +51085,7 @@
                 <a:cs typeface="Calibri"/>
                 <a:sym typeface="Calibri"/>
               </a:rPr>
-              <a:t>Ranked first in 70% of expert rankings  ·  best F1 on the BURR benchmark</a:t>
+              <a:t>Ranked first in 70% of expert rankings  ·  highest BURR F1 among compared ontology-learning systems</a:t>
             </a:r>
             <a:endParaRPr/>
           </a:p>

</xml_diff>